<commit_message>
Formato Assurance ITO: agregar instrucciones para asistentes IA
Instrucciones en notas del orador de la plantilla y en una lámina
oculta (no se proyecta ni se imprime).

Co-Authored-By: Claude Opus 5.5 <noreply@anthropic.com>
Claude-Session: https://claude.ai/code/session_017MaLNPnWzNhW9Tdfmjv67V
</commit_message>
<xml_diff>
--- a/FORMATO_ASSURANCE_ITO_v1.0.pptx
+++ b/FORMATO_ASSURANCE_ITO_v1.0.pptx
@@ -8,9 +8,10 @@
     <p:sldId id="256" r:id="rId2"/>
     <p:sldId id="257" r:id="rId3"/>
     <p:sldId id="258" r:id="rId4"/>
+    <p:sldId id="259" r:id="rId5"/>
   </p:sldIdLst>
   <p:notesMasterIdLst>
-    <p:notesMasterId r:id="rId5"/>
+    <p:notesMasterId r:id="rId6"/>
   </p:notesMasterIdLst>
   <p:sldSz cx="12191695" cy="8732520"/>
   <p:notesSz cx="8732520" cy="12191695"/>
@@ -504,7 +505,65 @@
           <a:p>
             <a:r>
               <a:rPr lang="en-US" dirty="0"/>
-              <a:t/>
+              <a:t>INSTRUCCIONES PARA ASISTENTES IA – FORMATO ASSURANCE ITO v1.0
+OBJETIVO
+Con el Excel de eventos de seguridad que entrega el usuario (CAAP, HAP, CBP, HBP), completar la lámina 1 "PLANTILLA" de este archivo con los focos prioritarios de verificación en terreno para el turno y período indicados. La lámina 3 "EJEMPLO" muestra el resultado esperado: úsala como referencia de largo, tono y formato.
+1. ENTRADAS Y DATOS
+- Identifica en el Excel las columnas de: ID del evento, tipo (CAAP/HAP/CBP/HBP), fecha, turno, empresa contratista (EECC), área/sector y descripción. Si existen, también acciones y estado.
+- Usa solo eventos del turno (1-3 o 2-4) y del período que indique el usuario. Si el turno o el período no están claros, pregunta antes de completar.
+- Usa exclusivamente datos del Excel. Nunca inventes IDs, empresas, fechas, áreas ni eventos. Copia los IDs exactamente como aparecen.
+- Si falta un dato necesario, escribe [DATO FALTANTE] en esa casilla e infórmalo al usuario.
+- No incluyas nombres de personas; usa el cargo o rol (trabajador, rigger, operador, supervisor).
+2. SELECCIÓN DE FOCOS (4 a 6)
+- Agrupa los eventos por riesgo (p. ej.: izaje, trabajo en altura/andamios, vehículos y equipos, energía eléctrica, excavaciones/zanjas, orden y aseo). Un foco = un riesgo.
+- Prioriza en este orden: CAAP &gt; HAP &gt; CBP &gt; HBP. A igual tipo: más eventos del mismo riesgo y, luego, más recientes.
+- Un tema de HBP con 3 o más eventos en el período puede ser foco propio (recurrente).
+- Ordena los focos de mayor a menor prioridad y numéralos 1, 2, 3…
+- Si hay menos de 6 focos, elimina las filas sobrantes de la tabla.
+3. NIVEL / PRIORIDAD (primera columna)
+- Estructura: número / "N1 · CRÍTICO" o "N2 · ALTO" / tipo del evento más grave del foco (CAAP, HAP, CBP o HBP).
+- N1 · CRÍTICO (celda roja C62828): el foco incluye un CAAP o HAP, o involucra un riesgo crítico (izaje, trabajo en altura, energía eléctrica/energías peligrosas, vehículos o equipos móviles).
+- N2 · ALTO (celda naranja E67E22): el resto.
+4. FOCO DE ASSURANCE
+- Formato: "Tema del foco." en negrita + instrucción que empieza con un verbo ("Verificar…"): qué se revisa, dónde y bajo qué estándar. Máximo unos 350 caracteres.
+- Luego, en línea aparte, "Criterio de restricción:" (en negrita) + la condición en que se prohíbe o se detiene la tarea. Máximo unos 150 caracteres.
+- Redacta a partir de las brechas reales de los eventos. No cites números de estándares o procedimientos que no estén en el Excel.
+5. EVENTO / EVIDENCIA ORIGEN
+- Formato fijo por evento: "[T1-3] TIPO ID – EECC:" (en negrita) + qué ocurrió, en una frase de hasta 120 caracteres.
+- Máximo 3 eventos por foco; elige los de mayor potencial. Si un evento aparece en ambos turnos, usa [T1-3/T2-4].
+- Para temas recurrentes se permite: "[T1-3] N eventos HBP: descripción del patrón."
+6. HERRAMIENTA PREVENTIVA SGE
+- Herramientas unidas con "+". Usa las que figuren en el Excel o las ya usadas en este formato: GCC, CdP [tema] (p. ej. CdP Maniobras de Izaje, CdP Trabajos en Altura, CdP Operación de Vehículos Livianos), ASP, PTS, Gestión del Cambio, Desafío en Terreno, Inspección de Plataformas de Andamios, EdC Vehículo Liviano, Inspección de Equipos, Acompañamiento ASP.
+7. EVIDENCIA / REGISTRO ESPERADO
+- Registros concretos y verificables separados por "/", terminando siempre en "registro fotográfico".
+8. VERIFICACIÓN EN TERRENO
+- No la modifiques: deja "☐ C ☐ NC ☐ NA / Obs.:" en blanco. La completa el Inspector ITO en terreno.
+9. RECURRENTE
+- "N eventos HBP — tema (n) · tema (n). Refuerzo transversal en todos los recorridos y al cierre de cada tarea."
+- N = total de HBP del turno y período, incluidos los usados en los focos. Verifica la suma: los subtotales no pueden superar N.
+10. SÍNTESIS Y RECORRIDOS
+- Bloque AM y Bloque Mediodía: áreas reales tomadas del Excel + 3 o 4 controles, cada uno con el N° de foco entre paréntesis, p. ej. "Plan de izaje específico por maniobra (1)". Asigna al AM los focos de inicio de jornada (izaje, pre-uso de vehículos y equipos) y al Mediodía los de intervención (plataformas, instalaciones eléctricas, orden y aseo).
+- Bloque PM: mantén "Gestión SAP · CdP pendientes · Entrega de turno" y sus líneas fijas. En "Actualizar PTS con brechas de CdP:" indica las brechas que el Excel respalde; si no hay, elimina esa línea.
+- Brechas principales / Controles críticos no negociables / Detener la tarea si…: máximo 5 viñetas de 1 línea (unos 50 caracteres) en cada recuadro, coherentes con los focos. Brechas = lo que falló. Controles = lo que no se negocia. Detener si = condición concreta de detención.
+11. ENCABEZADO, CIERRE Y FIRMAS
+- Título: "ASSURANCE TURNO 1-3" o "ASSURANCE TURNO 2-4". Fecha/Período: "DD al DD MES". Turno: marca ☒ en el que corresponde.
+- Inspector ITO, Proyecto/EECC y Área/Sector: complétalos solo si el usuario los entrega; si no, deja la línea en blanco.
+- La franja CIERRE y las firmas se dejan en blanco.
+12. FORMATO (obligatorio)
+- No cambies estructura, columnas, colores, fuentes, íconos ni tamaño de la lámina.
+- Reemplaza todo texto gris entre [corchetes] por contenido real en color de texto normal (negro, sin cursiva). No debe quedar ningún corchete, salvo [DATO FALTANTE] y las marcas de turno [T1-3]/[T2-4].
+- Letra mínima 6 pt. Si el texto no cabe, resume; no reduzcas más la letra ni agrandes filas.
+- Antes de entregar: elimina la lámina 2 (instructivo), la lámina 3 (ejemplo) y esta lámina oculta, y borra las notas del orador de la lámina 1.
+- Nombre del archivo: ASSURANCE_TURNO_[1-3 o 2-4]_[DD-DD]_[MES].pptx (ej.: ASSURANCE_TURNO_1-3_07-20_SEP.pptx).
+13. ENTREGA
+- Si puedes editar archivos .pptx: entrega el archivo completado.
+- Si no puedes: entrega el contenido en texto, ordenado por sección y por fila de la plantilla (Encabezado; Foco 1 a 6 con sus 5 columnas; Recurrente; Bloques AM/Mediodía/PM; Brechas; Controles; Detener si), listo para copiar y pegar en cada casilla.
+14. CONTROL DE CALIDAD (en tu respuesta al usuario, no dentro del archivo)
+Al final de tu respuesta incluye un resumen breve con:
+- total de eventos leídos y cuántos de cada tipo;
+- eventos usados en cada foco y los de alto potencial que quedaron fuera, con el motivo;
+- datos faltantes o inconsistentes y supuestos realizados.
+Antes de entregar, confirma que: cada ID existe en el Excel; cada foco tiene al menos un evento de origen; los conteos del Recurrente cuadran; y no quedan textos guía.</a:t>
             </a:r>
             <a:endParaRPr lang="en-US" dirty="0"/>
           </a:p>
@@ -704,6 +763,94 @@
             <a:fld id="{F7021451-1387-4CA6-816F-3879F97B5CBC}" type="slidenum">
               <a:rPr lang="en-US"/>
               <a:t>3</a:t>
+            </a:fld>
+            <a:endParaRPr lang="en-US"/>
+          </a:p>
+        </p:txBody>
+      </p:sp>
+    </p:spTree>
+    <p:extLst>
+      <p:ext uri="{BB962C8B-B14F-4D97-AF65-F5344CB8AC3E}">
+        <p14:creationId xmlns:p14="http://schemas.microsoft.com/office/powerpoint/2010/main" val="1024086991"/>
+      </p:ext>
+    </p:extLst>
+  </p:cSld>
+  <p:clrMapOvr>
+    <a:masterClrMapping/>
+  </p:clrMapOvr>
+</p:notes>
+</file>
+
+<file path=ppt/notesSlides/notesSlide4.xml><?xml version="1.0" encoding="utf-8"?>
+<p:notes xmlns:a="http://schemas.openxmlformats.org/drawingml/2006/main" xmlns:r="http://schemas.openxmlformats.org/officeDocument/2006/relationships" xmlns:p="http://schemas.openxmlformats.org/presentationml/2006/main">
+  <p:cSld>
+    <p:spTree>
+      <p:nvGrpSpPr>
+        <p:cNvPr id="1" name=""/>
+        <p:cNvGrpSpPr/>
+        <p:nvPr/>
+      </p:nvGrpSpPr>
+      <p:grpSpPr>
+        <a:xfrm>
+          <a:off x="0" y="0"/>
+          <a:ext cx="0" cy="0"/>
+          <a:chOff x="0" y="0"/>
+          <a:chExt cx="0" cy="0"/>
+        </a:xfrm>
+      </p:grpSpPr>
+      <p:sp>
+        <p:nvSpPr>
+          <p:cNvPr id="2" name="Slide Image Placeholder 1"/>
+          <p:cNvSpPr>
+            <a:spLocks noGrp="1" noRot="1" noChangeAspect="1"/>
+          </p:cNvSpPr>
+          <p:nvPr>
+            <p:ph type="sldImg"/>
+          </p:nvPr>
+        </p:nvSpPr>
+        <p:spPr/>
+      </p:sp>
+      <p:sp>
+        <p:nvSpPr>
+          <p:cNvPr id="3" name="Notes Placeholder 2"/>
+          <p:cNvSpPr>
+            <a:spLocks noGrp="1"/>
+          </p:cNvSpPr>
+          <p:nvPr>
+            <p:ph type="body" idx="1"/>
+          </p:nvPr>
+        </p:nvSpPr>
+        <p:spPr/>
+        <p:txBody>
+          <a:bodyPr/>
+          <a:lstStyle/>
+          <a:p>
+            <a:r>
+              <a:rPr lang="en-US" dirty="0"/>
+              <a:t/>
+            </a:r>
+            <a:endParaRPr lang="en-US" dirty="0"/>
+          </a:p>
+        </p:txBody>
+      </p:sp>
+      <p:sp>
+        <p:nvSpPr>
+          <p:cNvPr id="4" name="Slide Number Placeholder 3"/>
+          <p:cNvSpPr>
+            <a:spLocks noGrp="1"/>
+          </p:cNvSpPr>
+          <p:nvPr>
+            <p:ph type="sldNum" sz="quarter" idx="10"/>
+          </p:nvPr>
+        </p:nvSpPr>
+        <p:spPr/>
+        <p:txBody>
+          <a:bodyPr/>
+          <a:lstStyle/>
+          <a:p>
+            <a:fld id="{F7021451-1387-4CA6-816F-3879F97B5CBC}" type="slidenum">
+              <a:rPr lang="en-US"/>
+              <a:t>4</a:t>
             </a:fld>
             <a:endParaRPr lang="en-US"/>
           </a:p>
@@ -16459,6 +16606,1302 @@
 </p:sld>
 </file>
 
+<file path=ppt/slides/slide4.xml><?xml version="1.0" encoding="utf-8"?>
+<p:sld xmlns:a="http://schemas.openxmlformats.org/drawingml/2006/main" xmlns:r="http://schemas.openxmlformats.org/officeDocument/2006/relationships" xmlns:p="http://schemas.openxmlformats.org/presentationml/2006/main" show="0">
+  <p:cSld name="Slide 4">
+    <p:bg>
+      <p:bgPr>
+        <a:solidFill>
+          <a:srgbClr val="FFFFFF"/>
+        </a:solidFill>
+      </p:bgPr>
+    </p:bg>
+    <p:spTree>
+      <p:nvGrpSpPr>
+        <p:cNvPr id="1" name=""/>
+        <p:cNvGrpSpPr/>
+        <p:nvPr/>
+      </p:nvGrpSpPr>
+      <p:grpSpPr>
+        <a:xfrm>
+          <a:off x="0" y="0"/>
+          <a:ext cx="0" cy="0"/>
+          <a:chOff x="0" y="0"/>
+          <a:chExt cx="0" cy="0"/>
+        </a:xfrm>
+      </p:grpSpPr>
+      <p:sp>
+        <p:nvSpPr>
+          <p:cNvPr id="2" name="Text 0"/>
+          <p:cNvSpPr txBox="1"/>
+          <p:nvPr/>
+        </p:nvSpPr>
+        <p:spPr>
+          <a:xfrm>
+            <a:off x="365760" y="228600"/>
+            <a:ext cx="11457432" cy="365760"/>
+          </a:xfrm>
+          <a:prstGeom prst="rect">
+            <a:avLst/>
+          </a:prstGeom>
+          <a:noFill/>
+          <a:ln/>
+        </p:spPr>
+        <p:txBody>
+          <a:bodyPr wrap="square" lIns="0" tIns="0" rIns="0" bIns="0" rtlCol="0" anchor="ctr"/>
+          <a:lstStyle/>
+          <a:p>
+            <a:pPr indent="0" marL="0">
+              <a:buNone/>
+            </a:pPr>
+            <a:r>
+              <a:rPr lang="en-US" sz="1400" b="1" dirty="0">
+                <a:solidFill>
+                  <a:srgbClr val="1F3D6B"/>
+                </a:solidFill>
+                <a:latin typeface="Arial" pitchFamily="34" charset="0"/>
+                <a:ea typeface="Arial" pitchFamily="34" charset="-122"/>
+                <a:cs typeface="Arial" pitchFamily="34" charset="-120"/>
+              </a:rPr>
+              <a:t>INSTRUCCIONES PARA ASISTENTES IA – FORMATO ASSURANCE ITO v1.0  (lámina oculta: no se muestra al presentar ni se imprime)</a:t>
+            </a:r>
+            <a:endParaRPr lang="en-US" sz="1400" dirty="0"/>
+          </a:p>
+        </p:txBody>
+      </p:sp>
+      <p:sp>
+        <p:nvSpPr>
+          <p:cNvPr id="3" name="Text 1"/>
+          <p:cNvSpPr txBox="1"/>
+          <p:nvPr/>
+        </p:nvSpPr>
+        <p:spPr>
+          <a:xfrm>
+            <a:off x="365760" y="731520"/>
+            <a:ext cx="5632704" cy="7589520"/>
+          </a:xfrm>
+          <a:prstGeom prst="rect">
+            <a:avLst/>
+          </a:prstGeom>
+          <a:noFill/>
+          <a:ln/>
+        </p:spPr>
+        <p:txBody>
+          <a:bodyPr wrap="square" lIns="0" tIns="0" rIns="0" bIns="0" rtlCol="0" anchor="t"/>
+          <a:lstStyle/>
+          <a:p>
+            <a:pPr indent="0" marL="0">
+              <a:buNone/>
+            </a:pPr>
+            <a:r>
+              <a:rPr lang="en-US" sz="700" b="1" dirty="0">
+                <a:solidFill>
+                  <a:srgbClr val="1F3D6B"/>
+                </a:solidFill>
+                <a:latin typeface="Arial" pitchFamily="34" charset="0"/>
+                <a:ea typeface="Arial" pitchFamily="34" charset="-122"/>
+                <a:cs typeface="Arial" pitchFamily="34" charset="-120"/>
+              </a:rPr>
+              <a:t>OBJETIVO</a:t>
+            </a:r>
+            <a:endParaRPr lang="en-US" sz="700" dirty="0"/>
+          </a:p>
+          <a:p>
+            <a:pPr indent="0" marL="0">
+              <a:buNone/>
+            </a:pPr>
+            <a:r>
+              <a:rPr lang="en-US" sz="700" dirty="0">
+                <a:solidFill>
+                  <a:srgbClr val="222222"/>
+                </a:solidFill>
+                <a:latin typeface="Arial" pitchFamily="34" charset="0"/>
+                <a:ea typeface="Arial" pitchFamily="34" charset="-122"/>
+                <a:cs typeface="Arial" pitchFamily="34" charset="-120"/>
+              </a:rPr>
+              <a:t>Con el Excel de eventos de seguridad que entrega el usuario (CAAP, HAP, CBP, HBP), completar la lámina 1 "PLANTILLA" de este archivo con los focos prioritarios de verificación en terreno para el turno y período indicados. La lámina 3 "EJEMPLO" muestra el resultado esperado: úsala como referencia de largo, tono y formato.</a:t>
+            </a:r>
+            <a:endParaRPr lang="en-US" sz="700" dirty="0"/>
+          </a:p>
+          <a:p>
+            <a:pPr indent="0" marL="0">
+              <a:spcBef>
+                <a:spcPts val="500"/>
+              </a:spcBef>
+              <a:buNone/>
+            </a:pPr>
+            <a:r>
+              <a:rPr lang="en-US" sz="700" b="1" dirty="0">
+                <a:solidFill>
+                  <a:srgbClr val="1F3D6B"/>
+                </a:solidFill>
+                <a:latin typeface="Arial" pitchFamily="34" charset="0"/>
+                <a:ea typeface="Arial" pitchFamily="34" charset="-122"/>
+                <a:cs typeface="Arial" pitchFamily="34" charset="-120"/>
+              </a:rPr>
+              <a:t>1. ENTRADAS Y DATOS</a:t>
+            </a:r>
+            <a:endParaRPr lang="en-US" sz="700" dirty="0"/>
+          </a:p>
+          <a:p>
+            <a:pPr indent="0" marL="0">
+              <a:buNone/>
+            </a:pPr>
+            <a:r>
+              <a:rPr lang="en-US" sz="700" dirty="0">
+                <a:solidFill>
+                  <a:srgbClr val="222222"/>
+                </a:solidFill>
+                <a:latin typeface="Arial" pitchFamily="34" charset="0"/>
+                <a:ea typeface="Arial" pitchFamily="34" charset="-122"/>
+                <a:cs typeface="Arial" pitchFamily="34" charset="-120"/>
+              </a:rPr>
+              <a:t>- Identifica en el Excel las columnas de: ID del evento, tipo (CAAP/HAP/CBP/HBP), fecha, turno, empresa contratista (EECC), área/sector y descripción. Si existen, también acciones y estado.</a:t>
+            </a:r>
+            <a:endParaRPr lang="en-US" sz="700" dirty="0"/>
+          </a:p>
+          <a:p>
+            <a:pPr indent="0" marL="0">
+              <a:buNone/>
+            </a:pPr>
+            <a:r>
+              <a:rPr lang="en-US" sz="700" dirty="0">
+                <a:solidFill>
+                  <a:srgbClr val="222222"/>
+                </a:solidFill>
+                <a:latin typeface="Arial" pitchFamily="34" charset="0"/>
+                <a:ea typeface="Arial" pitchFamily="34" charset="-122"/>
+                <a:cs typeface="Arial" pitchFamily="34" charset="-120"/>
+              </a:rPr>
+              <a:t>- Usa solo eventos del turno (1-3 o 2-4) y del período que indique el usuario. Si el turno o el período no están claros, pregunta antes de completar.</a:t>
+            </a:r>
+            <a:endParaRPr lang="en-US" sz="700" dirty="0"/>
+          </a:p>
+          <a:p>
+            <a:pPr indent="0" marL="0">
+              <a:buNone/>
+            </a:pPr>
+            <a:r>
+              <a:rPr lang="en-US" sz="700" dirty="0">
+                <a:solidFill>
+                  <a:srgbClr val="222222"/>
+                </a:solidFill>
+                <a:latin typeface="Arial" pitchFamily="34" charset="0"/>
+                <a:ea typeface="Arial" pitchFamily="34" charset="-122"/>
+                <a:cs typeface="Arial" pitchFamily="34" charset="-120"/>
+              </a:rPr>
+              <a:t>- Usa exclusivamente datos del Excel. Nunca inventes IDs, empresas, fechas, áreas ni eventos. Copia los IDs exactamente como aparecen.</a:t>
+            </a:r>
+            <a:endParaRPr lang="en-US" sz="700" dirty="0"/>
+          </a:p>
+          <a:p>
+            <a:pPr indent="0" marL="0">
+              <a:buNone/>
+            </a:pPr>
+            <a:r>
+              <a:rPr lang="en-US" sz="700" dirty="0">
+                <a:solidFill>
+                  <a:srgbClr val="222222"/>
+                </a:solidFill>
+                <a:latin typeface="Arial" pitchFamily="34" charset="0"/>
+                <a:ea typeface="Arial" pitchFamily="34" charset="-122"/>
+                <a:cs typeface="Arial" pitchFamily="34" charset="-120"/>
+              </a:rPr>
+              <a:t>- Si falta un dato necesario, escribe [DATO FALTANTE] en esa casilla e infórmalo al usuario.</a:t>
+            </a:r>
+            <a:endParaRPr lang="en-US" sz="700" dirty="0"/>
+          </a:p>
+          <a:p>
+            <a:pPr indent="0" marL="0">
+              <a:buNone/>
+            </a:pPr>
+            <a:r>
+              <a:rPr lang="en-US" sz="700" dirty="0">
+                <a:solidFill>
+                  <a:srgbClr val="222222"/>
+                </a:solidFill>
+                <a:latin typeface="Arial" pitchFamily="34" charset="0"/>
+                <a:ea typeface="Arial" pitchFamily="34" charset="-122"/>
+                <a:cs typeface="Arial" pitchFamily="34" charset="-120"/>
+              </a:rPr>
+              <a:t>- No incluyas nombres de personas; usa el cargo o rol (trabajador, rigger, operador, supervisor).</a:t>
+            </a:r>
+            <a:endParaRPr lang="en-US" sz="700" dirty="0"/>
+          </a:p>
+          <a:p>
+            <a:pPr indent="0" marL="0">
+              <a:spcBef>
+                <a:spcPts val="500"/>
+              </a:spcBef>
+              <a:buNone/>
+            </a:pPr>
+            <a:r>
+              <a:rPr lang="en-US" sz="700" b="1" dirty="0">
+                <a:solidFill>
+                  <a:srgbClr val="1F3D6B"/>
+                </a:solidFill>
+                <a:latin typeface="Arial" pitchFamily="34" charset="0"/>
+                <a:ea typeface="Arial" pitchFamily="34" charset="-122"/>
+                <a:cs typeface="Arial" pitchFamily="34" charset="-120"/>
+              </a:rPr>
+              <a:t>2. SELECCIÓN DE FOCOS (4 a 6)</a:t>
+            </a:r>
+            <a:endParaRPr lang="en-US" sz="700" dirty="0"/>
+          </a:p>
+          <a:p>
+            <a:pPr indent="0" marL="0">
+              <a:buNone/>
+            </a:pPr>
+            <a:r>
+              <a:rPr lang="en-US" sz="700" dirty="0">
+                <a:solidFill>
+                  <a:srgbClr val="222222"/>
+                </a:solidFill>
+                <a:latin typeface="Arial" pitchFamily="34" charset="0"/>
+                <a:ea typeface="Arial" pitchFamily="34" charset="-122"/>
+                <a:cs typeface="Arial" pitchFamily="34" charset="-120"/>
+              </a:rPr>
+              <a:t>- Agrupa los eventos por riesgo (p. ej.: izaje, trabajo en altura/andamios, vehículos y equipos, energía eléctrica, excavaciones/zanjas, orden y aseo). Un foco = un riesgo.</a:t>
+            </a:r>
+            <a:endParaRPr lang="en-US" sz="700" dirty="0"/>
+          </a:p>
+          <a:p>
+            <a:pPr indent="0" marL="0">
+              <a:buNone/>
+            </a:pPr>
+            <a:r>
+              <a:rPr lang="en-US" sz="700" dirty="0">
+                <a:solidFill>
+                  <a:srgbClr val="222222"/>
+                </a:solidFill>
+                <a:latin typeface="Arial" pitchFamily="34" charset="0"/>
+                <a:ea typeface="Arial" pitchFamily="34" charset="-122"/>
+                <a:cs typeface="Arial" pitchFamily="34" charset="-120"/>
+              </a:rPr>
+              <a:t>- Prioriza en este orden: CAAP &gt; HAP &gt; CBP &gt; HBP. A igual tipo: más eventos del mismo riesgo y, luego, más recientes.</a:t>
+            </a:r>
+            <a:endParaRPr lang="en-US" sz="700" dirty="0"/>
+          </a:p>
+          <a:p>
+            <a:pPr indent="0" marL="0">
+              <a:buNone/>
+            </a:pPr>
+            <a:r>
+              <a:rPr lang="en-US" sz="700" dirty="0">
+                <a:solidFill>
+                  <a:srgbClr val="222222"/>
+                </a:solidFill>
+                <a:latin typeface="Arial" pitchFamily="34" charset="0"/>
+                <a:ea typeface="Arial" pitchFamily="34" charset="-122"/>
+                <a:cs typeface="Arial" pitchFamily="34" charset="-120"/>
+              </a:rPr>
+              <a:t>- Un tema de HBP con 3 o más eventos en el período puede ser foco propio (recurrente).</a:t>
+            </a:r>
+            <a:endParaRPr lang="en-US" sz="700" dirty="0"/>
+          </a:p>
+          <a:p>
+            <a:pPr indent="0" marL="0">
+              <a:buNone/>
+            </a:pPr>
+            <a:r>
+              <a:rPr lang="en-US" sz="700" dirty="0">
+                <a:solidFill>
+                  <a:srgbClr val="222222"/>
+                </a:solidFill>
+                <a:latin typeface="Arial" pitchFamily="34" charset="0"/>
+                <a:ea typeface="Arial" pitchFamily="34" charset="-122"/>
+                <a:cs typeface="Arial" pitchFamily="34" charset="-120"/>
+              </a:rPr>
+              <a:t>- Ordena los focos de mayor a menor prioridad y numéralos 1, 2, 3…</a:t>
+            </a:r>
+            <a:endParaRPr lang="en-US" sz="700" dirty="0"/>
+          </a:p>
+          <a:p>
+            <a:pPr indent="0" marL="0">
+              <a:buNone/>
+            </a:pPr>
+            <a:r>
+              <a:rPr lang="en-US" sz="700" dirty="0">
+                <a:solidFill>
+                  <a:srgbClr val="222222"/>
+                </a:solidFill>
+                <a:latin typeface="Arial" pitchFamily="34" charset="0"/>
+                <a:ea typeface="Arial" pitchFamily="34" charset="-122"/>
+                <a:cs typeface="Arial" pitchFamily="34" charset="-120"/>
+              </a:rPr>
+              <a:t>- Si hay menos de 6 focos, elimina las filas sobrantes de la tabla.</a:t>
+            </a:r>
+            <a:endParaRPr lang="en-US" sz="700" dirty="0"/>
+          </a:p>
+          <a:p>
+            <a:pPr indent="0" marL="0">
+              <a:spcBef>
+                <a:spcPts val="500"/>
+              </a:spcBef>
+              <a:buNone/>
+            </a:pPr>
+            <a:r>
+              <a:rPr lang="en-US" sz="700" b="1" dirty="0">
+                <a:solidFill>
+                  <a:srgbClr val="1F3D6B"/>
+                </a:solidFill>
+                <a:latin typeface="Arial" pitchFamily="34" charset="0"/>
+                <a:ea typeface="Arial" pitchFamily="34" charset="-122"/>
+                <a:cs typeface="Arial" pitchFamily="34" charset="-120"/>
+              </a:rPr>
+              <a:t>3. NIVEL / PRIORIDAD (primera columna)</a:t>
+            </a:r>
+            <a:endParaRPr lang="en-US" sz="700" dirty="0"/>
+          </a:p>
+          <a:p>
+            <a:pPr indent="0" marL="0">
+              <a:buNone/>
+            </a:pPr>
+            <a:r>
+              <a:rPr lang="en-US" sz="700" dirty="0">
+                <a:solidFill>
+                  <a:srgbClr val="222222"/>
+                </a:solidFill>
+                <a:latin typeface="Arial" pitchFamily="34" charset="0"/>
+                <a:ea typeface="Arial" pitchFamily="34" charset="-122"/>
+                <a:cs typeface="Arial" pitchFamily="34" charset="-120"/>
+              </a:rPr>
+              <a:t>- Estructura: número / "N1 · CRÍTICO" o "N2 · ALTO" / tipo del evento más grave del foco (CAAP, HAP, CBP o HBP).</a:t>
+            </a:r>
+            <a:endParaRPr lang="en-US" sz="700" dirty="0"/>
+          </a:p>
+          <a:p>
+            <a:pPr indent="0" marL="0">
+              <a:buNone/>
+            </a:pPr>
+            <a:r>
+              <a:rPr lang="en-US" sz="700" dirty="0">
+                <a:solidFill>
+                  <a:srgbClr val="222222"/>
+                </a:solidFill>
+                <a:latin typeface="Arial" pitchFamily="34" charset="0"/>
+                <a:ea typeface="Arial" pitchFamily="34" charset="-122"/>
+                <a:cs typeface="Arial" pitchFamily="34" charset="-120"/>
+              </a:rPr>
+              <a:t>- N1 · CRÍTICO (celda roja C62828): el foco incluye un CAAP o HAP, o involucra un riesgo crítico (izaje, trabajo en altura, energía eléctrica/energías peligrosas, vehículos o equipos móviles).</a:t>
+            </a:r>
+            <a:endParaRPr lang="en-US" sz="700" dirty="0"/>
+          </a:p>
+          <a:p>
+            <a:pPr indent="0" marL="0">
+              <a:buNone/>
+            </a:pPr>
+            <a:r>
+              <a:rPr lang="en-US" sz="700" dirty="0">
+                <a:solidFill>
+                  <a:srgbClr val="222222"/>
+                </a:solidFill>
+                <a:latin typeface="Arial" pitchFamily="34" charset="0"/>
+                <a:ea typeface="Arial" pitchFamily="34" charset="-122"/>
+                <a:cs typeface="Arial" pitchFamily="34" charset="-120"/>
+              </a:rPr>
+              <a:t>- N2 · ALTO (celda naranja E67E22): el resto.</a:t>
+            </a:r>
+            <a:endParaRPr lang="en-US" sz="700" dirty="0"/>
+          </a:p>
+          <a:p>
+            <a:pPr indent="0" marL="0">
+              <a:spcBef>
+                <a:spcPts val="500"/>
+              </a:spcBef>
+              <a:buNone/>
+            </a:pPr>
+            <a:r>
+              <a:rPr lang="en-US" sz="700" b="1" dirty="0">
+                <a:solidFill>
+                  <a:srgbClr val="1F3D6B"/>
+                </a:solidFill>
+                <a:latin typeface="Arial" pitchFamily="34" charset="0"/>
+                <a:ea typeface="Arial" pitchFamily="34" charset="-122"/>
+                <a:cs typeface="Arial" pitchFamily="34" charset="-120"/>
+              </a:rPr>
+              <a:t>4. FOCO DE ASSURANCE</a:t>
+            </a:r>
+            <a:endParaRPr lang="en-US" sz="700" dirty="0"/>
+          </a:p>
+          <a:p>
+            <a:pPr indent="0" marL="0">
+              <a:buNone/>
+            </a:pPr>
+            <a:r>
+              <a:rPr lang="en-US" sz="700" dirty="0">
+                <a:solidFill>
+                  <a:srgbClr val="222222"/>
+                </a:solidFill>
+                <a:latin typeface="Arial" pitchFamily="34" charset="0"/>
+                <a:ea typeface="Arial" pitchFamily="34" charset="-122"/>
+                <a:cs typeface="Arial" pitchFamily="34" charset="-120"/>
+              </a:rPr>
+              <a:t>- Formato: "Tema del foco." en negrita + instrucción que empieza con un verbo ("Verificar…"): qué se revisa, dónde y bajo qué estándar. Máximo unos 350 caracteres.</a:t>
+            </a:r>
+            <a:endParaRPr lang="en-US" sz="700" dirty="0"/>
+          </a:p>
+          <a:p>
+            <a:pPr indent="0" marL="0">
+              <a:buNone/>
+            </a:pPr>
+            <a:r>
+              <a:rPr lang="en-US" sz="700" dirty="0">
+                <a:solidFill>
+                  <a:srgbClr val="222222"/>
+                </a:solidFill>
+                <a:latin typeface="Arial" pitchFamily="34" charset="0"/>
+                <a:ea typeface="Arial" pitchFamily="34" charset="-122"/>
+                <a:cs typeface="Arial" pitchFamily="34" charset="-120"/>
+              </a:rPr>
+              <a:t>- Luego, en línea aparte, "Criterio de restricción:" (en negrita) + la condición en que se prohíbe o se detiene la tarea. Máximo unos 150 caracteres.</a:t>
+            </a:r>
+            <a:endParaRPr lang="en-US" sz="700" dirty="0"/>
+          </a:p>
+          <a:p>
+            <a:pPr indent="0" marL="0">
+              <a:buNone/>
+            </a:pPr>
+            <a:r>
+              <a:rPr lang="en-US" sz="700" dirty="0">
+                <a:solidFill>
+                  <a:srgbClr val="222222"/>
+                </a:solidFill>
+                <a:latin typeface="Arial" pitchFamily="34" charset="0"/>
+                <a:ea typeface="Arial" pitchFamily="34" charset="-122"/>
+                <a:cs typeface="Arial" pitchFamily="34" charset="-120"/>
+              </a:rPr>
+              <a:t>- Redacta a partir de las brechas reales de los eventos. No cites números de estándares o procedimientos que no estén en el Excel.</a:t>
+            </a:r>
+            <a:endParaRPr lang="en-US" sz="700" dirty="0"/>
+          </a:p>
+          <a:p>
+            <a:pPr indent="0" marL="0">
+              <a:spcBef>
+                <a:spcPts val="500"/>
+              </a:spcBef>
+              <a:buNone/>
+            </a:pPr>
+            <a:r>
+              <a:rPr lang="en-US" sz="700" b="1" dirty="0">
+                <a:solidFill>
+                  <a:srgbClr val="1F3D6B"/>
+                </a:solidFill>
+                <a:latin typeface="Arial" pitchFamily="34" charset="0"/>
+                <a:ea typeface="Arial" pitchFamily="34" charset="-122"/>
+                <a:cs typeface="Arial" pitchFamily="34" charset="-120"/>
+              </a:rPr>
+              <a:t>5. EVENTO / EVIDENCIA ORIGEN</a:t>
+            </a:r>
+            <a:endParaRPr lang="en-US" sz="700" dirty="0"/>
+          </a:p>
+          <a:p>
+            <a:pPr indent="0" marL="0">
+              <a:buNone/>
+            </a:pPr>
+            <a:r>
+              <a:rPr lang="en-US" sz="700" dirty="0">
+                <a:solidFill>
+                  <a:srgbClr val="222222"/>
+                </a:solidFill>
+                <a:latin typeface="Arial" pitchFamily="34" charset="0"/>
+                <a:ea typeface="Arial" pitchFamily="34" charset="-122"/>
+                <a:cs typeface="Arial" pitchFamily="34" charset="-120"/>
+              </a:rPr>
+              <a:t>- Formato fijo por evento: "[T1-3] TIPO ID – EECC:" (en negrita) + qué ocurrió, en una frase de hasta 120 caracteres.</a:t>
+            </a:r>
+            <a:endParaRPr lang="en-US" sz="700" dirty="0"/>
+          </a:p>
+          <a:p>
+            <a:pPr indent="0" marL="0">
+              <a:buNone/>
+            </a:pPr>
+            <a:r>
+              <a:rPr lang="en-US" sz="700" dirty="0">
+                <a:solidFill>
+                  <a:srgbClr val="222222"/>
+                </a:solidFill>
+                <a:latin typeface="Arial" pitchFamily="34" charset="0"/>
+                <a:ea typeface="Arial" pitchFamily="34" charset="-122"/>
+                <a:cs typeface="Arial" pitchFamily="34" charset="-120"/>
+              </a:rPr>
+              <a:t>- Máximo 3 eventos por foco; elige los de mayor potencial. Si un evento aparece en ambos turnos, usa [T1-3/T2-4].</a:t>
+            </a:r>
+            <a:endParaRPr lang="en-US" sz="700" dirty="0"/>
+          </a:p>
+          <a:p>
+            <a:pPr indent="0" marL="0">
+              <a:buNone/>
+            </a:pPr>
+            <a:r>
+              <a:rPr lang="en-US" sz="700" dirty="0">
+                <a:solidFill>
+                  <a:srgbClr val="222222"/>
+                </a:solidFill>
+                <a:latin typeface="Arial" pitchFamily="34" charset="0"/>
+                <a:ea typeface="Arial" pitchFamily="34" charset="-122"/>
+                <a:cs typeface="Arial" pitchFamily="34" charset="-120"/>
+              </a:rPr>
+              <a:t>- Para temas recurrentes se permite: "[T1-3] N eventos HBP: descripción del patrón."</a:t>
+            </a:r>
+            <a:endParaRPr lang="en-US" sz="700" dirty="0"/>
+          </a:p>
+          <a:p>
+            <a:pPr indent="0" marL="0">
+              <a:spcBef>
+                <a:spcPts val="500"/>
+              </a:spcBef>
+              <a:buNone/>
+            </a:pPr>
+            <a:r>
+              <a:rPr lang="en-US" sz="700" b="1" dirty="0">
+                <a:solidFill>
+                  <a:srgbClr val="1F3D6B"/>
+                </a:solidFill>
+                <a:latin typeface="Arial" pitchFamily="34" charset="0"/>
+                <a:ea typeface="Arial" pitchFamily="34" charset="-122"/>
+                <a:cs typeface="Arial" pitchFamily="34" charset="-120"/>
+              </a:rPr>
+              <a:t>6. HERRAMIENTA PREVENTIVA SGE</a:t>
+            </a:r>
+            <a:endParaRPr lang="en-US" sz="700" dirty="0"/>
+          </a:p>
+          <a:p>
+            <a:pPr indent="0" marL="0">
+              <a:buNone/>
+            </a:pPr>
+            <a:r>
+              <a:rPr lang="en-US" sz="700" dirty="0">
+                <a:solidFill>
+                  <a:srgbClr val="222222"/>
+                </a:solidFill>
+                <a:latin typeface="Arial" pitchFamily="34" charset="0"/>
+                <a:ea typeface="Arial" pitchFamily="34" charset="-122"/>
+                <a:cs typeface="Arial" pitchFamily="34" charset="-120"/>
+              </a:rPr>
+              <a:t>- Herramientas unidas con "+". Usa las que figuren en el Excel o las ya usadas en este formato: GCC, CdP [tema] (p. ej. CdP Maniobras de Izaje, CdP Trabajos en Altura, CdP Operación de Vehículos Livianos), ASP, PTS, Gestión del Cambio, Desafío en Terreno, Inspección de Plataformas de Andamios, EdC Vehículo Liviano, Inspección de Equipos, Acompañamiento ASP.</a:t>
+            </a:r>
+            <a:endParaRPr lang="en-US" sz="700" dirty="0"/>
+          </a:p>
+          <a:p>
+            <a:pPr indent="0" marL="0">
+              <a:spcBef>
+                <a:spcPts val="500"/>
+              </a:spcBef>
+              <a:buNone/>
+            </a:pPr>
+            <a:r>
+              <a:rPr lang="en-US" sz="700" b="1" dirty="0">
+                <a:solidFill>
+                  <a:srgbClr val="1F3D6B"/>
+                </a:solidFill>
+                <a:latin typeface="Arial" pitchFamily="34" charset="0"/>
+                <a:ea typeface="Arial" pitchFamily="34" charset="-122"/>
+                <a:cs typeface="Arial" pitchFamily="34" charset="-120"/>
+              </a:rPr>
+              <a:t>7. EVIDENCIA / REGISTRO ESPERADO</a:t>
+            </a:r>
+            <a:endParaRPr lang="en-US" sz="700" dirty="0"/>
+          </a:p>
+          <a:p>
+            <a:pPr indent="0" marL="0">
+              <a:buNone/>
+            </a:pPr>
+            <a:r>
+              <a:rPr lang="en-US" sz="700" dirty="0">
+                <a:solidFill>
+                  <a:srgbClr val="222222"/>
+                </a:solidFill>
+                <a:latin typeface="Arial" pitchFamily="34" charset="0"/>
+                <a:ea typeface="Arial" pitchFamily="34" charset="-122"/>
+                <a:cs typeface="Arial" pitchFamily="34" charset="-120"/>
+              </a:rPr>
+              <a:t>- Registros concretos y verificables separados por "/", terminando siempre en "registro fotográfico".</a:t>
+            </a:r>
+            <a:endParaRPr lang="en-US" sz="700" dirty="0"/>
+          </a:p>
+        </p:txBody>
+      </p:sp>
+      <p:sp>
+        <p:nvSpPr>
+          <p:cNvPr id="4" name="Text 2"/>
+          <p:cNvSpPr txBox="1"/>
+          <p:nvPr/>
+        </p:nvSpPr>
+        <p:spPr>
+          <a:xfrm>
+            <a:off x="6190488" y="731520"/>
+            <a:ext cx="5632704" cy="7589520"/>
+          </a:xfrm>
+          <a:prstGeom prst="rect">
+            <a:avLst/>
+          </a:prstGeom>
+          <a:noFill/>
+          <a:ln/>
+        </p:spPr>
+        <p:txBody>
+          <a:bodyPr wrap="square" lIns="0" tIns="0" rIns="0" bIns="0" rtlCol="0" anchor="t"/>
+          <a:lstStyle/>
+          <a:p>
+            <a:pPr indent="0" marL="0">
+              <a:buNone/>
+            </a:pPr>
+            <a:r>
+              <a:rPr lang="en-US" sz="700" b="1" dirty="0">
+                <a:solidFill>
+                  <a:srgbClr val="1F3D6B"/>
+                </a:solidFill>
+                <a:latin typeface="Arial" pitchFamily="34" charset="0"/>
+                <a:ea typeface="Arial" pitchFamily="34" charset="-122"/>
+                <a:cs typeface="Arial" pitchFamily="34" charset="-120"/>
+              </a:rPr>
+              <a:t>8. VERIFICACIÓN EN TERRENO</a:t>
+            </a:r>
+            <a:endParaRPr lang="en-US" sz="700" dirty="0"/>
+          </a:p>
+          <a:p>
+            <a:pPr indent="0" marL="0">
+              <a:buNone/>
+            </a:pPr>
+            <a:r>
+              <a:rPr lang="en-US" sz="700" dirty="0">
+                <a:solidFill>
+                  <a:srgbClr val="222222"/>
+                </a:solidFill>
+                <a:latin typeface="Arial" pitchFamily="34" charset="0"/>
+                <a:ea typeface="Arial" pitchFamily="34" charset="-122"/>
+                <a:cs typeface="Arial" pitchFamily="34" charset="-120"/>
+              </a:rPr>
+              <a:t>- No la modifiques: deja "☐ C ☐ NC ☐ NA / Obs.:" en blanco. La completa el Inspector ITO en terreno.</a:t>
+            </a:r>
+            <a:endParaRPr lang="en-US" sz="700" dirty="0"/>
+          </a:p>
+          <a:p>
+            <a:pPr indent="0" marL="0">
+              <a:spcBef>
+                <a:spcPts val="500"/>
+              </a:spcBef>
+              <a:buNone/>
+            </a:pPr>
+            <a:r>
+              <a:rPr lang="en-US" sz="700" b="1" dirty="0">
+                <a:solidFill>
+                  <a:srgbClr val="1F3D6B"/>
+                </a:solidFill>
+                <a:latin typeface="Arial" pitchFamily="34" charset="0"/>
+                <a:ea typeface="Arial" pitchFamily="34" charset="-122"/>
+                <a:cs typeface="Arial" pitchFamily="34" charset="-120"/>
+              </a:rPr>
+              <a:t>9. RECURRENTE</a:t>
+            </a:r>
+            <a:endParaRPr lang="en-US" sz="700" dirty="0"/>
+          </a:p>
+          <a:p>
+            <a:pPr indent="0" marL="0">
+              <a:buNone/>
+            </a:pPr>
+            <a:r>
+              <a:rPr lang="en-US" sz="700" dirty="0">
+                <a:solidFill>
+                  <a:srgbClr val="222222"/>
+                </a:solidFill>
+                <a:latin typeface="Arial" pitchFamily="34" charset="0"/>
+                <a:ea typeface="Arial" pitchFamily="34" charset="-122"/>
+                <a:cs typeface="Arial" pitchFamily="34" charset="-120"/>
+              </a:rPr>
+              <a:t>- "N eventos HBP — tema (n) · tema (n). Refuerzo transversal en todos los recorridos y al cierre de cada tarea."</a:t>
+            </a:r>
+            <a:endParaRPr lang="en-US" sz="700" dirty="0"/>
+          </a:p>
+          <a:p>
+            <a:pPr indent="0" marL="0">
+              <a:buNone/>
+            </a:pPr>
+            <a:r>
+              <a:rPr lang="en-US" sz="700" dirty="0">
+                <a:solidFill>
+                  <a:srgbClr val="222222"/>
+                </a:solidFill>
+                <a:latin typeface="Arial" pitchFamily="34" charset="0"/>
+                <a:ea typeface="Arial" pitchFamily="34" charset="-122"/>
+                <a:cs typeface="Arial" pitchFamily="34" charset="-120"/>
+              </a:rPr>
+              <a:t>- N = total de HBP del turno y período, incluidos los usados en los focos. Verifica la suma: los subtotales no pueden superar N.</a:t>
+            </a:r>
+            <a:endParaRPr lang="en-US" sz="700" dirty="0"/>
+          </a:p>
+          <a:p>
+            <a:pPr indent="0" marL="0">
+              <a:spcBef>
+                <a:spcPts val="500"/>
+              </a:spcBef>
+              <a:buNone/>
+            </a:pPr>
+            <a:r>
+              <a:rPr lang="en-US" sz="700" b="1" dirty="0">
+                <a:solidFill>
+                  <a:srgbClr val="1F3D6B"/>
+                </a:solidFill>
+                <a:latin typeface="Arial" pitchFamily="34" charset="0"/>
+                <a:ea typeface="Arial" pitchFamily="34" charset="-122"/>
+                <a:cs typeface="Arial" pitchFamily="34" charset="-120"/>
+              </a:rPr>
+              <a:t>10. SÍNTESIS Y RECORRIDOS</a:t>
+            </a:r>
+            <a:endParaRPr lang="en-US" sz="700" dirty="0"/>
+          </a:p>
+          <a:p>
+            <a:pPr indent="0" marL="0">
+              <a:buNone/>
+            </a:pPr>
+            <a:r>
+              <a:rPr lang="en-US" sz="700" dirty="0">
+                <a:solidFill>
+                  <a:srgbClr val="222222"/>
+                </a:solidFill>
+                <a:latin typeface="Arial" pitchFamily="34" charset="0"/>
+                <a:ea typeface="Arial" pitchFamily="34" charset="-122"/>
+                <a:cs typeface="Arial" pitchFamily="34" charset="-120"/>
+              </a:rPr>
+              <a:t>- Bloque AM y Bloque Mediodía: áreas reales tomadas del Excel + 3 o 4 controles, cada uno con el N° de foco entre paréntesis, p. ej. "Plan de izaje específico por maniobra (1)". Asigna al AM los focos de inicio de jornada (izaje, pre-uso de vehículos y equipos) y al Mediodía los de intervención (plataformas, instalaciones eléctricas, orden y aseo).</a:t>
+            </a:r>
+            <a:endParaRPr lang="en-US" sz="700" dirty="0"/>
+          </a:p>
+          <a:p>
+            <a:pPr indent="0" marL="0">
+              <a:buNone/>
+            </a:pPr>
+            <a:r>
+              <a:rPr lang="en-US" sz="700" dirty="0">
+                <a:solidFill>
+                  <a:srgbClr val="222222"/>
+                </a:solidFill>
+                <a:latin typeface="Arial" pitchFamily="34" charset="0"/>
+                <a:ea typeface="Arial" pitchFamily="34" charset="-122"/>
+                <a:cs typeface="Arial" pitchFamily="34" charset="-120"/>
+              </a:rPr>
+              <a:t>- Bloque PM: mantén "Gestión SAP · CdP pendientes · Entrega de turno" y sus líneas fijas. En "Actualizar PTS con brechas de CdP:" indica las brechas que el Excel respalde; si no hay, elimina esa línea.</a:t>
+            </a:r>
+            <a:endParaRPr lang="en-US" sz="700" dirty="0"/>
+          </a:p>
+          <a:p>
+            <a:pPr indent="0" marL="0">
+              <a:buNone/>
+            </a:pPr>
+            <a:r>
+              <a:rPr lang="en-US" sz="700" dirty="0">
+                <a:solidFill>
+                  <a:srgbClr val="222222"/>
+                </a:solidFill>
+                <a:latin typeface="Arial" pitchFamily="34" charset="0"/>
+                <a:ea typeface="Arial" pitchFamily="34" charset="-122"/>
+                <a:cs typeface="Arial" pitchFamily="34" charset="-120"/>
+              </a:rPr>
+              <a:t>- Brechas principales / Controles críticos no negociables / Detener la tarea si…: máximo 5 viñetas de 1 línea (unos 50 caracteres) en cada recuadro, coherentes con los focos. Brechas = lo que falló. Controles = lo que no se negocia. Detener si = condición concreta de detención.</a:t>
+            </a:r>
+            <a:endParaRPr lang="en-US" sz="700" dirty="0"/>
+          </a:p>
+          <a:p>
+            <a:pPr indent="0" marL="0">
+              <a:spcBef>
+                <a:spcPts val="500"/>
+              </a:spcBef>
+              <a:buNone/>
+            </a:pPr>
+            <a:r>
+              <a:rPr lang="en-US" sz="700" b="1" dirty="0">
+                <a:solidFill>
+                  <a:srgbClr val="1F3D6B"/>
+                </a:solidFill>
+                <a:latin typeface="Arial" pitchFamily="34" charset="0"/>
+                <a:ea typeface="Arial" pitchFamily="34" charset="-122"/>
+                <a:cs typeface="Arial" pitchFamily="34" charset="-120"/>
+              </a:rPr>
+              <a:t>11. ENCABEZADO, CIERRE Y FIRMAS</a:t>
+            </a:r>
+            <a:endParaRPr lang="en-US" sz="700" dirty="0"/>
+          </a:p>
+          <a:p>
+            <a:pPr indent="0" marL="0">
+              <a:buNone/>
+            </a:pPr>
+            <a:r>
+              <a:rPr lang="en-US" sz="700" dirty="0">
+                <a:solidFill>
+                  <a:srgbClr val="222222"/>
+                </a:solidFill>
+                <a:latin typeface="Arial" pitchFamily="34" charset="0"/>
+                <a:ea typeface="Arial" pitchFamily="34" charset="-122"/>
+                <a:cs typeface="Arial" pitchFamily="34" charset="-120"/>
+              </a:rPr>
+              <a:t>- Título: "ASSURANCE TURNO 1-3" o "ASSURANCE TURNO 2-4". Fecha/Período: "DD al DD MES". Turno: marca ☒ en el que corresponde.</a:t>
+            </a:r>
+            <a:endParaRPr lang="en-US" sz="700" dirty="0"/>
+          </a:p>
+          <a:p>
+            <a:pPr indent="0" marL="0">
+              <a:buNone/>
+            </a:pPr>
+            <a:r>
+              <a:rPr lang="en-US" sz="700" dirty="0">
+                <a:solidFill>
+                  <a:srgbClr val="222222"/>
+                </a:solidFill>
+                <a:latin typeface="Arial" pitchFamily="34" charset="0"/>
+                <a:ea typeface="Arial" pitchFamily="34" charset="-122"/>
+                <a:cs typeface="Arial" pitchFamily="34" charset="-120"/>
+              </a:rPr>
+              <a:t>- Inspector ITO, Proyecto/EECC y Área/Sector: complétalos solo si el usuario los entrega; si no, deja la línea en blanco.</a:t>
+            </a:r>
+            <a:endParaRPr lang="en-US" sz="700" dirty="0"/>
+          </a:p>
+          <a:p>
+            <a:pPr indent="0" marL="0">
+              <a:buNone/>
+            </a:pPr>
+            <a:r>
+              <a:rPr lang="en-US" sz="700" dirty="0">
+                <a:solidFill>
+                  <a:srgbClr val="222222"/>
+                </a:solidFill>
+                <a:latin typeface="Arial" pitchFamily="34" charset="0"/>
+                <a:ea typeface="Arial" pitchFamily="34" charset="-122"/>
+                <a:cs typeface="Arial" pitchFamily="34" charset="-120"/>
+              </a:rPr>
+              <a:t>- La franja CIERRE y las firmas se dejan en blanco.</a:t>
+            </a:r>
+            <a:endParaRPr lang="en-US" sz="700" dirty="0"/>
+          </a:p>
+          <a:p>
+            <a:pPr indent="0" marL="0">
+              <a:spcBef>
+                <a:spcPts val="500"/>
+              </a:spcBef>
+              <a:buNone/>
+            </a:pPr>
+            <a:r>
+              <a:rPr lang="en-US" sz="700" b="1" dirty="0">
+                <a:solidFill>
+                  <a:srgbClr val="1F3D6B"/>
+                </a:solidFill>
+                <a:latin typeface="Arial" pitchFamily="34" charset="0"/>
+                <a:ea typeface="Arial" pitchFamily="34" charset="-122"/>
+                <a:cs typeface="Arial" pitchFamily="34" charset="-120"/>
+              </a:rPr>
+              <a:t>12. FORMATO (obligatorio)</a:t>
+            </a:r>
+            <a:endParaRPr lang="en-US" sz="700" dirty="0"/>
+          </a:p>
+          <a:p>
+            <a:pPr indent="0" marL="0">
+              <a:buNone/>
+            </a:pPr>
+            <a:r>
+              <a:rPr lang="en-US" sz="700" dirty="0">
+                <a:solidFill>
+                  <a:srgbClr val="222222"/>
+                </a:solidFill>
+                <a:latin typeface="Arial" pitchFamily="34" charset="0"/>
+                <a:ea typeface="Arial" pitchFamily="34" charset="-122"/>
+                <a:cs typeface="Arial" pitchFamily="34" charset="-120"/>
+              </a:rPr>
+              <a:t>- No cambies estructura, columnas, colores, fuentes, íconos ni tamaño de la lámina.</a:t>
+            </a:r>
+            <a:endParaRPr lang="en-US" sz="700" dirty="0"/>
+          </a:p>
+          <a:p>
+            <a:pPr indent="0" marL="0">
+              <a:buNone/>
+            </a:pPr>
+            <a:r>
+              <a:rPr lang="en-US" sz="700" dirty="0">
+                <a:solidFill>
+                  <a:srgbClr val="222222"/>
+                </a:solidFill>
+                <a:latin typeface="Arial" pitchFamily="34" charset="0"/>
+                <a:ea typeface="Arial" pitchFamily="34" charset="-122"/>
+                <a:cs typeface="Arial" pitchFamily="34" charset="-120"/>
+              </a:rPr>
+              <a:t>- Reemplaza todo texto gris entre [corchetes] por contenido real en color de texto normal (negro, sin cursiva). No debe quedar ningún corchete, salvo [DATO FALTANTE] y las marcas de turno [T1-3]/[T2-4].</a:t>
+            </a:r>
+            <a:endParaRPr lang="en-US" sz="700" dirty="0"/>
+          </a:p>
+          <a:p>
+            <a:pPr indent="0" marL="0">
+              <a:buNone/>
+            </a:pPr>
+            <a:r>
+              <a:rPr lang="en-US" sz="700" dirty="0">
+                <a:solidFill>
+                  <a:srgbClr val="222222"/>
+                </a:solidFill>
+                <a:latin typeface="Arial" pitchFamily="34" charset="0"/>
+                <a:ea typeface="Arial" pitchFamily="34" charset="-122"/>
+                <a:cs typeface="Arial" pitchFamily="34" charset="-120"/>
+              </a:rPr>
+              <a:t>- Letra mínima 6 pt. Si el texto no cabe, resume; no reduzcas más la letra ni agrandes filas.</a:t>
+            </a:r>
+            <a:endParaRPr lang="en-US" sz="700" dirty="0"/>
+          </a:p>
+          <a:p>
+            <a:pPr indent="0" marL="0">
+              <a:buNone/>
+            </a:pPr>
+            <a:r>
+              <a:rPr lang="en-US" sz="700" dirty="0">
+                <a:solidFill>
+                  <a:srgbClr val="222222"/>
+                </a:solidFill>
+                <a:latin typeface="Arial" pitchFamily="34" charset="0"/>
+                <a:ea typeface="Arial" pitchFamily="34" charset="-122"/>
+                <a:cs typeface="Arial" pitchFamily="34" charset="-120"/>
+              </a:rPr>
+              <a:t>- Antes de entregar: elimina la lámina 2 (instructivo), la lámina 3 (ejemplo) y esta lámina oculta, y borra las notas del orador de la lámina 1.</a:t>
+            </a:r>
+            <a:endParaRPr lang="en-US" sz="700" dirty="0"/>
+          </a:p>
+          <a:p>
+            <a:pPr indent="0" marL="0">
+              <a:buNone/>
+            </a:pPr>
+            <a:r>
+              <a:rPr lang="en-US" sz="700" dirty="0">
+                <a:solidFill>
+                  <a:srgbClr val="222222"/>
+                </a:solidFill>
+                <a:latin typeface="Arial" pitchFamily="34" charset="0"/>
+                <a:ea typeface="Arial" pitchFamily="34" charset="-122"/>
+                <a:cs typeface="Arial" pitchFamily="34" charset="-120"/>
+              </a:rPr>
+              <a:t>- Nombre del archivo: ASSURANCE_TURNO_[1-3 o 2-4]_[DD-DD]_[MES].pptx (ej.: ASSURANCE_TURNO_1-3_07-20_SEP.pptx).</a:t>
+            </a:r>
+            <a:endParaRPr lang="en-US" sz="700" dirty="0"/>
+          </a:p>
+          <a:p>
+            <a:pPr indent="0" marL="0">
+              <a:spcBef>
+                <a:spcPts val="500"/>
+              </a:spcBef>
+              <a:buNone/>
+            </a:pPr>
+            <a:r>
+              <a:rPr lang="en-US" sz="700" b="1" dirty="0">
+                <a:solidFill>
+                  <a:srgbClr val="1F3D6B"/>
+                </a:solidFill>
+                <a:latin typeface="Arial" pitchFamily="34" charset="0"/>
+                <a:ea typeface="Arial" pitchFamily="34" charset="-122"/>
+                <a:cs typeface="Arial" pitchFamily="34" charset="-120"/>
+              </a:rPr>
+              <a:t>13. ENTREGA</a:t>
+            </a:r>
+            <a:endParaRPr lang="en-US" sz="700" dirty="0"/>
+          </a:p>
+          <a:p>
+            <a:pPr indent="0" marL="0">
+              <a:buNone/>
+            </a:pPr>
+            <a:r>
+              <a:rPr lang="en-US" sz="700" dirty="0">
+                <a:solidFill>
+                  <a:srgbClr val="222222"/>
+                </a:solidFill>
+                <a:latin typeface="Arial" pitchFamily="34" charset="0"/>
+                <a:ea typeface="Arial" pitchFamily="34" charset="-122"/>
+                <a:cs typeface="Arial" pitchFamily="34" charset="-120"/>
+              </a:rPr>
+              <a:t>- Si puedes editar archivos .pptx: entrega el archivo completado.</a:t>
+            </a:r>
+            <a:endParaRPr lang="en-US" sz="700" dirty="0"/>
+          </a:p>
+          <a:p>
+            <a:pPr indent="0" marL="0">
+              <a:buNone/>
+            </a:pPr>
+            <a:r>
+              <a:rPr lang="en-US" sz="700" dirty="0">
+                <a:solidFill>
+                  <a:srgbClr val="222222"/>
+                </a:solidFill>
+                <a:latin typeface="Arial" pitchFamily="34" charset="0"/>
+                <a:ea typeface="Arial" pitchFamily="34" charset="-122"/>
+                <a:cs typeface="Arial" pitchFamily="34" charset="-120"/>
+              </a:rPr>
+              <a:t>- Si no puedes: entrega el contenido en texto, ordenado por sección y por fila de la plantilla (Encabezado; Foco 1 a 6 con sus 5 columnas; Recurrente; Bloques AM/Mediodía/PM; Brechas; Controles; Detener si), listo para copiar y pegar en cada casilla.</a:t>
+            </a:r>
+            <a:endParaRPr lang="en-US" sz="700" dirty="0"/>
+          </a:p>
+          <a:p>
+            <a:pPr indent="0" marL="0">
+              <a:spcBef>
+                <a:spcPts val="500"/>
+              </a:spcBef>
+              <a:buNone/>
+            </a:pPr>
+            <a:r>
+              <a:rPr lang="en-US" sz="700" b="1" dirty="0">
+                <a:solidFill>
+                  <a:srgbClr val="1F3D6B"/>
+                </a:solidFill>
+                <a:latin typeface="Arial" pitchFamily="34" charset="0"/>
+                <a:ea typeface="Arial" pitchFamily="34" charset="-122"/>
+                <a:cs typeface="Arial" pitchFamily="34" charset="-120"/>
+              </a:rPr>
+              <a:t>14. CONTROL DE CALIDAD (en tu respuesta al usuario, no dentro del archivo)</a:t>
+            </a:r>
+            <a:endParaRPr lang="en-US" sz="700" dirty="0"/>
+          </a:p>
+          <a:p>
+            <a:pPr indent="0" marL="0">
+              <a:buNone/>
+            </a:pPr>
+            <a:r>
+              <a:rPr lang="en-US" sz="700" dirty="0">
+                <a:solidFill>
+                  <a:srgbClr val="222222"/>
+                </a:solidFill>
+                <a:latin typeface="Arial" pitchFamily="34" charset="0"/>
+                <a:ea typeface="Arial" pitchFamily="34" charset="-122"/>
+                <a:cs typeface="Arial" pitchFamily="34" charset="-120"/>
+              </a:rPr>
+              <a:t>Al final de tu respuesta incluye un resumen breve con:</a:t>
+            </a:r>
+            <a:endParaRPr lang="en-US" sz="700" dirty="0"/>
+          </a:p>
+          <a:p>
+            <a:pPr indent="0" marL="0">
+              <a:buNone/>
+            </a:pPr>
+            <a:r>
+              <a:rPr lang="en-US" sz="700" dirty="0">
+                <a:solidFill>
+                  <a:srgbClr val="222222"/>
+                </a:solidFill>
+                <a:latin typeface="Arial" pitchFamily="34" charset="0"/>
+                <a:ea typeface="Arial" pitchFamily="34" charset="-122"/>
+                <a:cs typeface="Arial" pitchFamily="34" charset="-120"/>
+              </a:rPr>
+              <a:t>- total de eventos leídos y cuántos de cada tipo;</a:t>
+            </a:r>
+            <a:endParaRPr lang="en-US" sz="700" dirty="0"/>
+          </a:p>
+          <a:p>
+            <a:pPr indent="0" marL="0">
+              <a:buNone/>
+            </a:pPr>
+            <a:r>
+              <a:rPr lang="en-US" sz="700" dirty="0">
+                <a:solidFill>
+                  <a:srgbClr val="222222"/>
+                </a:solidFill>
+                <a:latin typeface="Arial" pitchFamily="34" charset="0"/>
+                <a:ea typeface="Arial" pitchFamily="34" charset="-122"/>
+                <a:cs typeface="Arial" pitchFamily="34" charset="-120"/>
+              </a:rPr>
+              <a:t>- eventos usados en cada foco y los de alto potencial que quedaron fuera, con el motivo;</a:t>
+            </a:r>
+            <a:endParaRPr lang="en-US" sz="700" dirty="0"/>
+          </a:p>
+          <a:p>
+            <a:pPr indent="0" marL="0">
+              <a:buNone/>
+            </a:pPr>
+            <a:r>
+              <a:rPr lang="en-US" sz="700" dirty="0">
+                <a:solidFill>
+                  <a:srgbClr val="222222"/>
+                </a:solidFill>
+                <a:latin typeface="Arial" pitchFamily="34" charset="0"/>
+                <a:ea typeface="Arial" pitchFamily="34" charset="-122"/>
+                <a:cs typeface="Arial" pitchFamily="34" charset="-120"/>
+              </a:rPr>
+              <a:t>- datos faltantes o inconsistentes y supuestos realizados.</a:t>
+            </a:r>
+            <a:endParaRPr lang="en-US" sz="700" dirty="0"/>
+          </a:p>
+          <a:p>
+            <a:pPr indent="0" marL="0">
+              <a:buNone/>
+            </a:pPr>
+            <a:r>
+              <a:rPr lang="en-US" sz="700" dirty="0">
+                <a:solidFill>
+                  <a:srgbClr val="222222"/>
+                </a:solidFill>
+                <a:latin typeface="Arial" pitchFamily="34" charset="0"/>
+                <a:ea typeface="Arial" pitchFamily="34" charset="-122"/>
+                <a:cs typeface="Arial" pitchFamily="34" charset="-120"/>
+              </a:rPr>
+              <a:t>Antes de entregar, confirma que: cada ID existe en el Excel; cada foco tiene al menos un evento de origen; los conteos del Recurrente cuadran; y no quedan textos guía.</a:t>
+            </a:r>
+            <a:endParaRPr lang="en-US" sz="700" dirty="0"/>
+          </a:p>
+        </p:txBody>
+      </p:sp>
+      <p:sp>
+        <p:nvSpPr>
+          <p:cNvPr id="5" name="Shape 3"/>
+          <p:cNvSpPr/>
+          <p:nvPr/>
+        </p:nvSpPr>
+        <p:spPr>
+          <a:xfrm>
+            <a:off x="0" y="8385048"/>
+            <a:ext cx="12191695" cy="347472"/>
+          </a:xfrm>
+          <a:prstGeom prst="rect">
+            <a:avLst/>
+          </a:prstGeom>
+          <a:solidFill>
+            <a:srgbClr val="1F3D6B"/>
+          </a:solidFill>
+          <a:ln w="12700">
+            <a:solidFill>
+              <a:srgbClr val="1F3D6B"/>
+            </a:solidFill>
+            <a:prstDash val="solid"/>
+          </a:ln>
+        </p:spPr>
+      </p:sp>
+      <p:sp>
+        <p:nvSpPr>
+          <p:cNvPr id="6" name="Text 4"/>
+          <p:cNvSpPr txBox="1"/>
+          <p:nvPr/>
+        </p:nvSpPr>
+        <p:spPr>
+          <a:xfrm>
+            <a:off x="365760" y="8385048"/>
+            <a:ext cx="4206240" cy="347472"/>
+          </a:xfrm>
+          <a:prstGeom prst="rect">
+            <a:avLst/>
+          </a:prstGeom>
+          <a:noFill/>
+          <a:ln/>
+        </p:spPr>
+        <p:txBody>
+          <a:bodyPr wrap="square" lIns="0" tIns="0" rIns="0" bIns="0" rtlCol="0" anchor="ctr"/>
+          <a:lstStyle/>
+          <a:p>
+            <a:pPr indent="0" marL="0">
+              <a:buNone/>
+            </a:pPr>
+            <a:r>
+              <a:rPr lang="en-US" sz="950" b="1" dirty="0">
+                <a:solidFill>
+                  <a:srgbClr val="FFFFFF"/>
+                </a:solidFill>
+                <a:latin typeface="Arial" pitchFamily="34" charset="0"/>
+                <a:ea typeface="Arial" pitchFamily="34" charset="-122"/>
+                <a:cs typeface="Arial" pitchFamily="34" charset="-120"/>
+              </a:rPr>
+              <a:t>NUESTRO COMPROMISO: CERO DAÑO A LAS PERSONAS</a:t>
+            </a:r>
+            <a:endParaRPr lang="en-US" sz="950" dirty="0"/>
+          </a:p>
+        </p:txBody>
+      </p:sp>
+      <p:sp>
+        <p:nvSpPr>
+          <p:cNvPr id="7" name="Text 5"/>
+          <p:cNvSpPr txBox="1"/>
+          <p:nvPr/>
+        </p:nvSpPr>
+        <p:spPr>
+          <a:xfrm>
+            <a:off x="4206240" y="8385048"/>
+            <a:ext cx="3840480" cy="347472"/>
+          </a:xfrm>
+          <a:prstGeom prst="rect">
+            <a:avLst/>
+          </a:prstGeom>
+          <a:noFill/>
+          <a:ln/>
+        </p:spPr>
+        <p:txBody>
+          <a:bodyPr wrap="square" lIns="0" tIns="0" rIns="0" bIns="0" rtlCol="0" anchor="ctr"/>
+          <a:lstStyle/>
+          <a:p>
+            <a:pPr algn="ctr" indent="0" marL="0">
+              <a:buNone/>
+            </a:pPr>
+            <a:r>
+              <a:rPr lang="en-US" sz="800" b="1" dirty="0">
+                <a:solidFill>
+                  <a:srgbClr val="E53935"/>
+                </a:solidFill>
+                <a:latin typeface="Arial" pitchFamily="34" charset="0"/>
+                <a:ea typeface="Arial" pitchFamily="34" charset="-122"/>
+                <a:cs typeface="Arial" pitchFamily="34" charset="-120"/>
+              </a:rPr>
+              <a:t>▲▲  </a:t>
+            </a:r>
+            <a:pPr algn="ctr" indent="0" marL="0">
+              <a:buNone/>
+            </a:pPr>
+            <a:r>
+              <a:rPr lang="en-US" sz="800" b="1" dirty="0">
+                <a:solidFill>
+                  <a:srgbClr val="FFFFFF"/>
+                </a:solidFill>
+                <a:latin typeface="Arial" pitchFamily="34" charset="0"/>
+                <a:ea typeface="Arial" pitchFamily="34" charset="-122"/>
+                <a:cs typeface="Arial" pitchFamily="34" charset="-120"/>
+              </a:rPr>
+              <a:t>FORMATO ASSURANCE ITO · v1.0 · INSTRUCCIONES IA</a:t>
+            </a:r>
+            <a:endParaRPr lang="en-US" sz="800" dirty="0"/>
+          </a:p>
+        </p:txBody>
+      </p:sp>
+      <p:sp>
+        <p:nvSpPr>
+          <p:cNvPr id="8" name="Text 6"/>
+          <p:cNvSpPr txBox="1"/>
+          <p:nvPr/>
+        </p:nvSpPr>
+        <p:spPr>
+          <a:xfrm>
+            <a:off x="7680960" y="8385048"/>
+            <a:ext cx="4142232" cy="347472"/>
+          </a:xfrm>
+          <a:prstGeom prst="rect">
+            <a:avLst/>
+          </a:prstGeom>
+          <a:noFill/>
+          <a:ln/>
+        </p:spPr>
+        <p:txBody>
+          <a:bodyPr wrap="square" lIns="0" tIns="0" rIns="0" bIns="0" rtlCol="0" anchor="ctr"/>
+          <a:lstStyle/>
+          <a:p>
+            <a:pPr algn="r" indent="0" marL="0">
+              <a:buNone/>
+            </a:pPr>
+            <a:r>
+              <a:rPr lang="en-US" sz="950" b="1" dirty="0">
+                <a:solidFill>
+                  <a:srgbClr val="FFFFFF"/>
+                </a:solidFill>
+                <a:latin typeface="Arial" pitchFamily="34" charset="0"/>
+                <a:ea typeface="Arial" pitchFamily="34" charset="-122"/>
+                <a:cs typeface="Arial" pitchFamily="34" charset="-120"/>
+              </a:rPr>
+              <a:t>SEGURIDAD, SALUD, PERSONAS Y MEDIO AMBIENTE</a:t>
+            </a:r>
+            <a:endParaRPr lang="en-US" sz="950" dirty="0"/>
+          </a:p>
+        </p:txBody>
+      </p:sp>
+    </p:spTree>
+  </p:cSld>
+  <p:clrMapOvr>
+    <a:masterClrMapping/>
+  </p:clrMapOvr>
+</p:sld>
+</file>
+
 <file path=ppt/theme/theme1.xml><?xml version="1.0" encoding="utf-8"?>
 <a:theme xmlns:a="http://schemas.openxmlformats.org/drawingml/2006/main" name="Office Theme">
   <a:themeElements>

</xml_diff>

<commit_message>
Formato Assurance ITO: instrucciones IA en cuadro de texto oculto
Se eliminan las notas del orador y la lámina oculta; las instrucciones
quedan en un cuadro de texto marcado como oculto, fuera del área de la
lámina 1.

Co-Authored-By: Claude Opus 5.5 <noreply@anthropic.com>
Claude-Session: https://claude.ai/code/session_017MaLNPnWzNhW9Tdfmjv67V
</commit_message>
<xml_diff>
--- a/FORMATO_ASSURANCE_ITO_v1.0.pptx
+++ b/FORMATO_ASSURANCE_ITO_v1.0.pptx
@@ -8,10 +8,9 @@
     <p:sldId id="256" r:id="rId2"/>
     <p:sldId id="257" r:id="rId3"/>
     <p:sldId id="258" r:id="rId4"/>
-    <p:sldId id="259" r:id="rId5"/>
   </p:sldIdLst>
   <p:notesMasterIdLst>
-    <p:notesMasterId r:id="rId6"/>
+    <p:notesMasterId r:id="rId5"/>
   </p:notesMasterIdLst>
   <p:sldSz cx="12191695" cy="8732520"/>
   <p:notesSz cx="8732520" cy="12191695"/>
@@ -505,65 +504,7 @@
           <a:p>
             <a:r>
               <a:rPr lang="en-US" dirty="0"/>
-              <a:t>INSTRUCCIONES PARA ASISTENTES IA – FORMATO ASSURANCE ITO v1.0
-OBJETIVO
-Con el Excel de eventos de seguridad que entrega el usuario (CAAP, HAP, CBP, HBP), completar la lámina 1 "PLANTILLA" de este archivo con los focos prioritarios de verificación en terreno para el turno y período indicados. La lámina 3 "EJEMPLO" muestra el resultado esperado: úsala como referencia de largo, tono y formato.
-1. ENTRADAS Y DATOS
-- Identifica en el Excel las columnas de: ID del evento, tipo (CAAP/HAP/CBP/HBP), fecha, turno, empresa contratista (EECC), área/sector y descripción. Si existen, también acciones y estado.
-- Usa solo eventos del turno (1-3 o 2-4) y del período que indique el usuario. Si el turno o el período no están claros, pregunta antes de completar.
-- Usa exclusivamente datos del Excel. Nunca inventes IDs, empresas, fechas, áreas ni eventos. Copia los IDs exactamente como aparecen.
-- Si falta un dato necesario, escribe [DATO FALTANTE] en esa casilla e infórmalo al usuario.
-- No incluyas nombres de personas; usa el cargo o rol (trabajador, rigger, operador, supervisor).
-2. SELECCIÓN DE FOCOS (4 a 6)
-- Agrupa los eventos por riesgo (p. ej.: izaje, trabajo en altura/andamios, vehículos y equipos, energía eléctrica, excavaciones/zanjas, orden y aseo). Un foco = un riesgo.
-- Prioriza en este orden: CAAP &gt; HAP &gt; CBP &gt; HBP. A igual tipo: más eventos del mismo riesgo y, luego, más recientes.
-- Un tema de HBP con 3 o más eventos en el período puede ser foco propio (recurrente).
-- Ordena los focos de mayor a menor prioridad y numéralos 1, 2, 3…
-- Si hay menos de 6 focos, elimina las filas sobrantes de la tabla.
-3. NIVEL / PRIORIDAD (primera columna)
-- Estructura: número / "N1 · CRÍTICO" o "N2 · ALTO" / tipo del evento más grave del foco (CAAP, HAP, CBP o HBP).
-- N1 · CRÍTICO (celda roja C62828): el foco incluye un CAAP o HAP, o involucra un riesgo crítico (izaje, trabajo en altura, energía eléctrica/energías peligrosas, vehículos o equipos móviles).
-- N2 · ALTO (celda naranja E67E22): el resto.
-4. FOCO DE ASSURANCE
-- Formato: "Tema del foco." en negrita + instrucción que empieza con un verbo ("Verificar…"): qué se revisa, dónde y bajo qué estándar. Máximo unos 350 caracteres.
-- Luego, en línea aparte, "Criterio de restricción:" (en negrita) + la condición en que se prohíbe o se detiene la tarea. Máximo unos 150 caracteres.
-- Redacta a partir de las brechas reales de los eventos. No cites números de estándares o procedimientos que no estén en el Excel.
-5. EVENTO / EVIDENCIA ORIGEN
-- Formato fijo por evento: "[T1-3] TIPO ID – EECC:" (en negrita) + qué ocurrió, en una frase de hasta 120 caracteres.
-- Máximo 3 eventos por foco; elige los de mayor potencial. Si un evento aparece en ambos turnos, usa [T1-3/T2-4].
-- Para temas recurrentes se permite: "[T1-3] N eventos HBP: descripción del patrón."
-6. HERRAMIENTA PREVENTIVA SGE
-- Herramientas unidas con "+". Usa las que figuren en el Excel o las ya usadas en este formato: GCC, CdP [tema] (p. ej. CdP Maniobras de Izaje, CdP Trabajos en Altura, CdP Operación de Vehículos Livianos), ASP, PTS, Gestión del Cambio, Desafío en Terreno, Inspección de Plataformas de Andamios, EdC Vehículo Liviano, Inspección de Equipos, Acompañamiento ASP.
-7. EVIDENCIA / REGISTRO ESPERADO
-- Registros concretos y verificables separados por "/", terminando siempre en "registro fotográfico".
-8. VERIFICACIÓN EN TERRENO
-- No la modifiques: deja "☐ C ☐ NC ☐ NA / Obs.:" en blanco. La completa el Inspector ITO en terreno.
-9. RECURRENTE
-- "N eventos HBP — tema (n) · tema (n). Refuerzo transversal en todos los recorridos y al cierre de cada tarea."
-- N = total de HBP del turno y período, incluidos los usados en los focos. Verifica la suma: los subtotales no pueden superar N.
-10. SÍNTESIS Y RECORRIDOS
-- Bloque AM y Bloque Mediodía: áreas reales tomadas del Excel + 3 o 4 controles, cada uno con el N° de foco entre paréntesis, p. ej. "Plan de izaje específico por maniobra (1)". Asigna al AM los focos de inicio de jornada (izaje, pre-uso de vehículos y equipos) y al Mediodía los de intervención (plataformas, instalaciones eléctricas, orden y aseo).
-- Bloque PM: mantén "Gestión SAP · CdP pendientes · Entrega de turno" y sus líneas fijas. En "Actualizar PTS con brechas de CdP:" indica las brechas que el Excel respalde; si no hay, elimina esa línea.
-- Brechas principales / Controles críticos no negociables / Detener la tarea si…: máximo 5 viñetas de 1 línea (unos 50 caracteres) en cada recuadro, coherentes con los focos. Brechas = lo que falló. Controles = lo que no se negocia. Detener si = condición concreta de detención.
-11. ENCABEZADO, CIERRE Y FIRMAS
-- Título: "ASSURANCE TURNO 1-3" o "ASSURANCE TURNO 2-4". Fecha/Período: "DD al DD MES". Turno: marca ☒ en el que corresponde.
-- Inspector ITO, Proyecto/EECC y Área/Sector: complétalos solo si el usuario los entrega; si no, deja la línea en blanco.
-- La franja CIERRE y las firmas se dejan en blanco.
-12. FORMATO (obligatorio)
-- No cambies estructura, columnas, colores, fuentes, íconos ni tamaño de la lámina.
-- Reemplaza todo texto gris entre [corchetes] por contenido real en color de texto normal (negro, sin cursiva). No debe quedar ningún corchete, salvo [DATO FALTANTE] y las marcas de turno [T1-3]/[T2-4].
-- Letra mínima 6 pt. Si el texto no cabe, resume; no reduzcas más la letra ni agrandes filas.
-- Antes de entregar: elimina la lámina 2 (instructivo), la lámina 3 (ejemplo) y esta lámina oculta, y borra las notas del orador de la lámina 1.
-- Nombre del archivo: ASSURANCE_TURNO_[1-3 o 2-4]_[DD-DD]_[MES].pptx (ej.: ASSURANCE_TURNO_1-3_07-20_SEP.pptx).
-13. ENTREGA
-- Si puedes editar archivos .pptx: entrega el archivo completado.
-- Si no puedes: entrega el contenido en texto, ordenado por sección y por fila de la plantilla (Encabezado; Foco 1 a 6 con sus 5 columnas; Recurrente; Bloques AM/Mediodía/PM; Brechas; Controles; Detener si), listo para copiar y pegar en cada casilla.
-14. CONTROL DE CALIDAD (en tu respuesta al usuario, no dentro del archivo)
-Al final de tu respuesta incluye un resumen breve con:
-- total de eventos leídos y cuántos de cada tipo;
-- eventos usados en cada foco y los de alto potencial que quedaron fuera, con el motivo;
-- datos faltantes o inconsistentes y supuestos realizados.
-Antes de entregar, confirma que: cada ID existe en el Excel; cada foco tiene al menos un evento de origen; los conteos del Recurrente cuadran; y no quedan textos guía.</a:t>
+              <a:t/>
             </a:r>
             <a:endParaRPr lang="en-US" dirty="0"/>
           </a:p>
@@ -763,94 +704,6 @@
             <a:fld id="{F7021451-1387-4CA6-816F-3879F97B5CBC}" type="slidenum">
               <a:rPr lang="en-US"/>
               <a:t>3</a:t>
-            </a:fld>
-            <a:endParaRPr lang="en-US"/>
-          </a:p>
-        </p:txBody>
-      </p:sp>
-    </p:spTree>
-    <p:extLst>
-      <p:ext uri="{BB962C8B-B14F-4D97-AF65-F5344CB8AC3E}">
-        <p14:creationId xmlns:p14="http://schemas.microsoft.com/office/powerpoint/2010/main" val="1024086991"/>
-      </p:ext>
-    </p:extLst>
-  </p:cSld>
-  <p:clrMapOvr>
-    <a:masterClrMapping/>
-  </p:clrMapOvr>
-</p:notes>
-</file>
-
-<file path=ppt/notesSlides/notesSlide4.xml><?xml version="1.0" encoding="utf-8"?>
-<p:notes xmlns:a="http://schemas.openxmlformats.org/drawingml/2006/main" xmlns:r="http://schemas.openxmlformats.org/officeDocument/2006/relationships" xmlns:p="http://schemas.openxmlformats.org/presentationml/2006/main">
-  <p:cSld>
-    <p:spTree>
-      <p:nvGrpSpPr>
-        <p:cNvPr id="1" name=""/>
-        <p:cNvGrpSpPr/>
-        <p:nvPr/>
-      </p:nvGrpSpPr>
-      <p:grpSpPr>
-        <a:xfrm>
-          <a:off x="0" y="0"/>
-          <a:ext cx="0" cy="0"/>
-          <a:chOff x="0" y="0"/>
-          <a:chExt cx="0" cy="0"/>
-        </a:xfrm>
-      </p:grpSpPr>
-      <p:sp>
-        <p:nvSpPr>
-          <p:cNvPr id="2" name="Slide Image Placeholder 1"/>
-          <p:cNvSpPr>
-            <a:spLocks noGrp="1" noRot="1" noChangeAspect="1"/>
-          </p:cNvSpPr>
-          <p:nvPr>
-            <p:ph type="sldImg"/>
-          </p:nvPr>
-        </p:nvSpPr>
-        <p:spPr/>
-      </p:sp>
-      <p:sp>
-        <p:nvSpPr>
-          <p:cNvPr id="3" name="Notes Placeholder 2"/>
-          <p:cNvSpPr>
-            <a:spLocks noGrp="1"/>
-          </p:cNvSpPr>
-          <p:nvPr>
-            <p:ph type="body" idx="1"/>
-          </p:nvPr>
-        </p:nvSpPr>
-        <p:spPr/>
-        <p:txBody>
-          <a:bodyPr/>
-          <a:lstStyle/>
-          <a:p>
-            <a:r>
-              <a:rPr lang="en-US" dirty="0"/>
-              <a:t/>
-            </a:r>
-            <a:endParaRPr lang="en-US" dirty="0"/>
-          </a:p>
-        </p:txBody>
-      </p:sp>
-      <p:sp>
-        <p:nvSpPr>
-          <p:cNvPr id="4" name="Slide Number Placeholder 3"/>
-          <p:cNvSpPr>
-            <a:spLocks noGrp="1"/>
-          </p:cNvSpPr>
-          <p:nvPr>
-            <p:ph type="sldNum" sz="quarter" idx="10"/>
-          </p:nvPr>
-        </p:nvSpPr>
-        <p:spPr/>
-        <p:txBody>
-          <a:bodyPr/>
-          <a:lstStyle/>
-          <a:p>
-            <a:fld id="{F7021451-1387-4CA6-816F-3879F97B5CBC}" type="slidenum">
-              <a:rPr lang="en-US"/>
-              <a:t>4</a:t>
             </a:fld>
             <a:endParaRPr lang="en-US"/>
           </a:p>
@@ -7530,6 +7383,1121 @@
           </a:p>
         </p:txBody>
       </p:sp>
+      <p:sp>
+        <p:nvSpPr>
+          <p:cNvPr id="54" name="Instrucciones IA" hidden="1"/>
+          <p:cNvSpPr txBox="1"/>
+          <p:nvPr/>
+        </p:nvSpPr>
+        <p:spPr>
+          <a:xfrm>
+            <a:off x="12648895" y="0"/>
+            <a:ext cx="5486400" cy="8732520"/>
+          </a:xfrm>
+          <a:prstGeom prst="rect">
+            <a:avLst/>
+          </a:prstGeom>
+          <a:noFill/>
+          <a:ln/>
+        </p:spPr>
+        <p:txBody>
+          <a:bodyPr wrap="square" lIns="0" tIns="0" rIns="0" bIns="0" rtlCol="0" anchor="t"/>
+          <a:lstStyle/>
+          <a:p>
+            <a:pPr indent="0" marL="0">
+              <a:buNone/>
+            </a:pPr>
+            <a:r>
+              <a:rPr lang="en-US" sz="600" dirty="0">
+                <a:solidFill>
+                  <a:srgbClr val="222222"/>
+                </a:solidFill>
+                <a:latin typeface="Arial" pitchFamily="34" charset="0"/>
+                <a:ea typeface="Arial" pitchFamily="34" charset="-122"/>
+                <a:cs typeface="Arial" pitchFamily="34" charset="-120"/>
+              </a:rPr>
+              <a:t>INSTRUCCIONES PARA ASISTENTES IA – FORMATO ASSURANCE ITO v1.0</a:t>
+            </a:r>
+            <a:endParaRPr lang="en-US" sz="600" dirty="0"/>
+          </a:p>
+          <a:p>
+            <a:pPr indent="0" marL="0">
+              <a:buNone/>
+            </a:pPr>
+            <a:endParaRPr lang="en-US" sz="600" dirty="0"/>
+          </a:p>
+          <a:p>
+            <a:pPr indent="0" marL="0">
+              <a:buNone/>
+            </a:pPr>
+            <a:r>
+              <a:rPr lang="en-US" sz="600" dirty="0">
+                <a:solidFill>
+                  <a:srgbClr val="222222"/>
+                </a:solidFill>
+                <a:latin typeface="Arial" pitchFamily="34" charset="0"/>
+                <a:ea typeface="Arial" pitchFamily="34" charset="-122"/>
+                <a:cs typeface="Arial" pitchFamily="34" charset="-120"/>
+              </a:rPr>
+              <a:t>OBJETIVO</a:t>
+            </a:r>
+            <a:endParaRPr lang="en-US" sz="600" dirty="0"/>
+          </a:p>
+          <a:p>
+            <a:pPr indent="0" marL="0">
+              <a:buNone/>
+            </a:pPr>
+            <a:r>
+              <a:rPr lang="en-US" sz="600" dirty="0">
+                <a:solidFill>
+                  <a:srgbClr val="222222"/>
+                </a:solidFill>
+                <a:latin typeface="Arial" pitchFamily="34" charset="0"/>
+                <a:ea typeface="Arial" pitchFamily="34" charset="-122"/>
+                <a:cs typeface="Arial" pitchFamily="34" charset="-120"/>
+              </a:rPr>
+              <a:t>Con el Excel de eventos de seguridad que entrega el usuario (CAAP, HAP, CBP, HBP), completar la lámina 1 "PLANTILLA" de este archivo con los focos prioritarios de verificación en terreno para el turno y período indicados. La lámina 3 "EJEMPLO" muestra el resultado esperado: úsala como referencia de largo, tono y formato.</a:t>
+            </a:r>
+            <a:endParaRPr lang="en-US" sz="600" dirty="0"/>
+          </a:p>
+          <a:p>
+            <a:pPr indent="0" marL="0">
+              <a:buNone/>
+            </a:pPr>
+            <a:endParaRPr lang="en-US" sz="600" dirty="0"/>
+          </a:p>
+          <a:p>
+            <a:pPr indent="0" marL="0">
+              <a:buNone/>
+            </a:pPr>
+            <a:r>
+              <a:rPr lang="en-US" sz="600" dirty="0">
+                <a:solidFill>
+                  <a:srgbClr val="222222"/>
+                </a:solidFill>
+                <a:latin typeface="Arial" pitchFamily="34" charset="0"/>
+                <a:ea typeface="Arial" pitchFamily="34" charset="-122"/>
+                <a:cs typeface="Arial" pitchFamily="34" charset="-120"/>
+              </a:rPr>
+              <a:t>1. ENTRADAS Y DATOS</a:t>
+            </a:r>
+            <a:endParaRPr lang="en-US" sz="600" dirty="0"/>
+          </a:p>
+          <a:p>
+            <a:pPr indent="0" marL="0">
+              <a:buNone/>
+            </a:pPr>
+            <a:r>
+              <a:rPr lang="en-US" sz="600" dirty="0">
+                <a:solidFill>
+                  <a:srgbClr val="222222"/>
+                </a:solidFill>
+                <a:latin typeface="Arial" pitchFamily="34" charset="0"/>
+                <a:ea typeface="Arial" pitchFamily="34" charset="-122"/>
+                <a:cs typeface="Arial" pitchFamily="34" charset="-120"/>
+              </a:rPr>
+              <a:t>- Identifica en el Excel las columnas de: ID del evento, tipo (CAAP/HAP/CBP/HBP), fecha, turno, empresa contratista (EECC), área/sector y descripción. Si existen, también acciones y estado.</a:t>
+            </a:r>
+            <a:endParaRPr lang="en-US" sz="600" dirty="0"/>
+          </a:p>
+          <a:p>
+            <a:pPr indent="0" marL="0">
+              <a:buNone/>
+            </a:pPr>
+            <a:r>
+              <a:rPr lang="en-US" sz="600" dirty="0">
+                <a:solidFill>
+                  <a:srgbClr val="222222"/>
+                </a:solidFill>
+                <a:latin typeface="Arial" pitchFamily="34" charset="0"/>
+                <a:ea typeface="Arial" pitchFamily="34" charset="-122"/>
+                <a:cs typeface="Arial" pitchFamily="34" charset="-120"/>
+              </a:rPr>
+              <a:t>- Usa solo eventos del turno (1-3 o 2-4) y del período que indique el usuario. Si el turno o el período no están claros, pregunta antes de completar.</a:t>
+            </a:r>
+            <a:endParaRPr lang="en-US" sz="600" dirty="0"/>
+          </a:p>
+          <a:p>
+            <a:pPr indent="0" marL="0">
+              <a:buNone/>
+            </a:pPr>
+            <a:r>
+              <a:rPr lang="en-US" sz="600" dirty="0">
+                <a:solidFill>
+                  <a:srgbClr val="222222"/>
+                </a:solidFill>
+                <a:latin typeface="Arial" pitchFamily="34" charset="0"/>
+                <a:ea typeface="Arial" pitchFamily="34" charset="-122"/>
+                <a:cs typeface="Arial" pitchFamily="34" charset="-120"/>
+              </a:rPr>
+              <a:t>- Usa exclusivamente datos del Excel. Nunca inventes IDs, empresas, fechas, áreas ni eventos. Copia los IDs exactamente como aparecen.</a:t>
+            </a:r>
+            <a:endParaRPr lang="en-US" sz="600" dirty="0"/>
+          </a:p>
+          <a:p>
+            <a:pPr indent="0" marL="0">
+              <a:buNone/>
+            </a:pPr>
+            <a:r>
+              <a:rPr lang="en-US" sz="600" dirty="0">
+                <a:solidFill>
+                  <a:srgbClr val="222222"/>
+                </a:solidFill>
+                <a:latin typeface="Arial" pitchFamily="34" charset="0"/>
+                <a:ea typeface="Arial" pitchFamily="34" charset="-122"/>
+                <a:cs typeface="Arial" pitchFamily="34" charset="-120"/>
+              </a:rPr>
+              <a:t>- Si falta un dato necesario, escribe [DATO FALTANTE] en esa casilla e infórmalo al usuario.</a:t>
+            </a:r>
+            <a:endParaRPr lang="en-US" sz="600" dirty="0"/>
+          </a:p>
+          <a:p>
+            <a:pPr indent="0" marL="0">
+              <a:buNone/>
+            </a:pPr>
+            <a:r>
+              <a:rPr lang="en-US" sz="600" dirty="0">
+                <a:solidFill>
+                  <a:srgbClr val="222222"/>
+                </a:solidFill>
+                <a:latin typeface="Arial" pitchFamily="34" charset="0"/>
+                <a:ea typeface="Arial" pitchFamily="34" charset="-122"/>
+                <a:cs typeface="Arial" pitchFamily="34" charset="-120"/>
+              </a:rPr>
+              <a:t>- No incluyas nombres de personas; usa el cargo o rol (trabajador, rigger, operador, supervisor).</a:t>
+            </a:r>
+            <a:endParaRPr lang="en-US" sz="600" dirty="0"/>
+          </a:p>
+          <a:p>
+            <a:pPr indent="0" marL="0">
+              <a:buNone/>
+            </a:pPr>
+            <a:endParaRPr lang="en-US" sz="600" dirty="0"/>
+          </a:p>
+          <a:p>
+            <a:pPr indent="0" marL="0">
+              <a:buNone/>
+            </a:pPr>
+            <a:r>
+              <a:rPr lang="en-US" sz="600" dirty="0">
+                <a:solidFill>
+                  <a:srgbClr val="222222"/>
+                </a:solidFill>
+                <a:latin typeface="Arial" pitchFamily="34" charset="0"/>
+                <a:ea typeface="Arial" pitchFamily="34" charset="-122"/>
+                <a:cs typeface="Arial" pitchFamily="34" charset="-120"/>
+              </a:rPr>
+              <a:t>2. SELECCIÓN DE FOCOS (4 a 6)</a:t>
+            </a:r>
+            <a:endParaRPr lang="en-US" sz="600" dirty="0"/>
+          </a:p>
+          <a:p>
+            <a:pPr indent="0" marL="0">
+              <a:buNone/>
+            </a:pPr>
+            <a:r>
+              <a:rPr lang="en-US" sz="600" dirty="0">
+                <a:solidFill>
+                  <a:srgbClr val="222222"/>
+                </a:solidFill>
+                <a:latin typeface="Arial" pitchFamily="34" charset="0"/>
+                <a:ea typeface="Arial" pitchFamily="34" charset="-122"/>
+                <a:cs typeface="Arial" pitchFamily="34" charset="-120"/>
+              </a:rPr>
+              <a:t>- Agrupa los eventos por riesgo (p. ej.: izaje, trabajo en altura/andamios, vehículos y equipos, energía eléctrica, excavaciones/zanjas, orden y aseo). Un foco = un riesgo.</a:t>
+            </a:r>
+            <a:endParaRPr lang="en-US" sz="600" dirty="0"/>
+          </a:p>
+          <a:p>
+            <a:pPr indent="0" marL="0">
+              <a:buNone/>
+            </a:pPr>
+            <a:r>
+              <a:rPr lang="en-US" sz="600" dirty="0">
+                <a:solidFill>
+                  <a:srgbClr val="222222"/>
+                </a:solidFill>
+                <a:latin typeface="Arial" pitchFamily="34" charset="0"/>
+                <a:ea typeface="Arial" pitchFamily="34" charset="-122"/>
+                <a:cs typeface="Arial" pitchFamily="34" charset="-120"/>
+              </a:rPr>
+              <a:t>- Prioriza en este orden: CAAP &gt; HAP &gt; CBP &gt; HBP. A igual tipo: más eventos del mismo riesgo y, luego, más recientes.</a:t>
+            </a:r>
+            <a:endParaRPr lang="en-US" sz="600" dirty="0"/>
+          </a:p>
+          <a:p>
+            <a:pPr indent="0" marL="0">
+              <a:buNone/>
+            </a:pPr>
+            <a:r>
+              <a:rPr lang="en-US" sz="600" dirty="0">
+                <a:solidFill>
+                  <a:srgbClr val="222222"/>
+                </a:solidFill>
+                <a:latin typeface="Arial" pitchFamily="34" charset="0"/>
+                <a:ea typeface="Arial" pitchFamily="34" charset="-122"/>
+                <a:cs typeface="Arial" pitchFamily="34" charset="-120"/>
+              </a:rPr>
+              <a:t>- Un tema de HBP con 3 o más eventos en el período puede ser foco propio (recurrente).</a:t>
+            </a:r>
+            <a:endParaRPr lang="en-US" sz="600" dirty="0"/>
+          </a:p>
+          <a:p>
+            <a:pPr indent="0" marL="0">
+              <a:buNone/>
+            </a:pPr>
+            <a:r>
+              <a:rPr lang="en-US" sz="600" dirty="0">
+                <a:solidFill>
+                  <a:srgbClr val="222222"/>
+                </a:solidFill>
+                <a:latin typeface="Arial" pitchFamily="34" charset="0"/>
+                <a:ea typeface="Arial" pitchFamily="34" charset="-122"/>
+                <a:cs typeface="Arial" pitchFamily="34" charset="-120"/>
+              </a:rPr>
+              <a:t>- Ordena los focos de mayor a menor prioridad y numéralos 1, 2, 3…</a:t>
+            </a:r>
+            <a:endParaRPr lang="en-US" sz="600" dirty="0"/>
+          </a:p>
+          <a:p>
+            <a:pPr indent="0" marL="0">
+              <a:buNone/>
+            </a:pPr>
+            <a:r>
+              <a:rPr lang="en-US" sz="600" dirty="0">
+                <a:solidFill>
+                  <a:srgbClr val="222222"/>
+                </a:solidFill>
+                <a:latin typeface="Arial" pitchFamily="34" charset="0"/>
+                <a:ea typeface="Arial" pitchFamily="34" charset="-122"/>
+                <a:cs typeface="Arial" pitchFamily="34" charset="-120"/>
+              </a:rPr>
+              <a:t>- Si hay menos de 6 focos, elimina las filas sobrantes de la tabla.</a:t>
+            </a:r>
+            <a:endParaRPr lang="en-US" sz="600" dirty="0"/>
+          </a:p>
+          <a:p>
+            <a:pPr indent="0" marL="0">
+              <a:buNone/>
+            </a:pPr>
+            <a:endParaRPr lang="en-US" sz="600" dirty="0"/>
+          </a:p>
+          <a:p>
+            <a:pPr indent="0" marL="0">
+              <a:buNone/>
+            </a:pPr>
+            <a:r>
+              <a:rPr lang="en-US" sz="600" dirty="0">
+                <a:solidFill>
+                  <a:srgbClr val="222222"/>
+                </a:solidFill>
+                <a:latin typeface="Arial" pitchFamily="34" charset="0"/>
+                <a:ea typeface="Arial" pitchFamily="34" charset="-122"/>
+                <a:cs typeface="Arial" pitchFamily="34" charset="-120"/>
+              </a:rPr>
+              <a:t>3. NIVEL / PRIORIDAD (primera columna)</a:t>
+            </a:r>
+            <a:endParaRPr lang="en-US" sz="600" dirty="0"/>
+          </a:p>
+          <a:p>
+            <a:pPr indent="0" marL="0">
+              <a:buNone/>
+            </a:pPr>
+            <a:r>
+              <a:rPr lang="en-US" sz="600" dirty="0">
+                <a:solidFill>
+                  <a:srgbClr val="222222"/>
+                </a:solidFill>
+                <a:latin typeface="Arial" pitchFamily="34" charset="0"/>
+                <a:ea typeface="Arial" pitchFamily="34" charset="-122"/>
+                <a:cs typeface="Arial" pitchFamily="34" charset="-120"/>
+              </a:rPr>
+              <a:t>- Estructura: número / "N1 · CRÍTICO" o "N2 · ALTO" / tipo del evento más grave del foco (CAAP, HAP, CBP o HBP).</a:t>
+            </a:r>
+            <a:endParaRPr lang="en-US" sz="600" dirty="0"/>
+          </a:p>
+          <a:p>
+            <a:pPr indent="0" marL="0">
+              <a:buNone/>
+            </a:pPr>
+            <a:r>
+              <a:rPr lang="en-US" sz="600" dirty="0">
+                <a:solidFill>
+                  <a:srgbClr val="222222"/>
+                </a:solidFill>
+                <a:latin typeface="Arial" pitchFamily="34" charset="0"/>
+                <a:ea typeface="Arial" pitchFamily="34" charset="-122"/>
+                <a:cs typeface="Arial" pitchFamily="34" charset="-120"/>
+              </a:rPr>
+              <a:t>- N1 · CRÍTICO (celda roja C62828): el foco incluye un CAAP o HAP, o involucra un riesgo crítico (izaje, trabajo en altura, energía eléctrica/energías peligrosas, vehículos o equipos móviles).</a:t>
+            </a:r>
+            <a:endParaRPr lang="en-US" sz="600" dirty="0"/>
+          </a:p>
+          <a:p>
+            <a:pPr indent="0" marL="0">
+              <a:buNone/>
+            </a:pPr>
+            <a:r>
+              <a:rPr lang="en-US" sz="600" dirty="0">
+                <a:solidFill>
+                  <a:srgbClr val="222222"/>
+                </a:solidFill>
+                <a:latin typeface="Arial" pitchFamily="34" charset="0"/>
+                <a:ea typeface="Arial" pitchFamily="34" charset="-122"/>
+                <a:cs typeface="Arial" pitchFamily="34" charset="-120"/>
+              </a:rPr>
+              <a:t>- N2 · ALTO (celda naranja E67E22): el resto.</a:t>
+            </a:r>
+            <a:endParaRPr lang="en-US" sz="600" dirty="0"/>
+          </a:p>
+          <a:p>
+            <a:pPr indent="0" marL="0">
+              <a:buNone/>
+            </a:pPr>
+            <a:endParaRPr lang="en-US" sz="600" dirty="0"/>
+          </a:p>
+          <a:p>
+            <a:pPr indent="0" marL="0">
+              <a:buNone/>
+            </a:pPr>
+            <a:r>
+              <a:rPr lang="en-US" sz="600" dirty="0">
+                <a:solidFill>
+                  <a:srgbClr val="222222"/>
+                </a:solidFill>
+                <a:latin typeface="Arial" pitchFamily="34" charset="0"/>
+                <a:ea typeface="Arial" pitchFamily="34" charset="-122"/>
+                <a:cs typeface="Arial" pitchFamily="34" charset="-120"/>
+              </a:rPr>
+              <a:t>4. FOCO DE ASSURANCE</a:t>
+            </a:r>
+            <a:endParaRPr lang="en-US" sz="600" dirty="0"/>
+          </a:p>
+          <a:p>
+            <a:pPr indent="0" marL="0">
+              <a:buNone/>
+            </a:pPr>
+            <a:r>
+              <a:rPr lang="en-US" sz="600" dirty="0">
+                <a:solidFill>
+                  <a:srgbClr val="222222"/>
+                </a:solidFill>
+                <a:latin typeface="Arial" pitchFamily="34" charset="0"/>
+                <a:ea typeface="Arial" pitchFamily="34" charset="-122"/>
+                <a:cs typeface="Arial" pitchFamily="34" charset="-120"/>
+              </a:rPr>
+              <a:t>- Formato: "Tema del foco." en negrita + instrucción que empieza con un verbo ("Verificar…"): qué se revisa, dónde y bajo qué estándar. Máximo unos 350 caracteres.</a:t>
+            </a:r>
+            <a:endParaRPr lang="en-US" sz="600" dirty="0"/>
+          </a:p>
+          <a:p>
+            <a:pPr indent="0" marL="0">
+              <a:buNone/>
+            </a:pPr>
+            <a:r>
+              <a:rPr lang="en-US" sz="600" dirty="0">
+                <a:solidFill>
+                  <a:srgbClr val="222222"/>
+                </a:solidFill>
+                <a:latin typeface="Arial" pitchFamily="34" charset="0"/>
+                <a:ea typeface="Arial" pitchFamily="34" charset="-122"/>
+                <a:cs typeface="Arial" pitchFamily="34" charset="-120"/>
+              </a:rPr>
+              <a:t>- Luego, en línea aparte, "Criterio de restricción:" (en negrita) + la condición en que se prohíbe o se detiene la tarea. Máximo unos 150 caracteres.</a:t>
+            </a:r>
+            <a:endParaRPr lang="en-US" sz="600" dirty="0"/>
+          </a:p>
+          <a:p>
+            <a:pPr indent="0" marL="0">
+              <a:buNone/>
+            </a:pPr>
+            <a:r>
+              <a:rPr lang="en-US" sz="600" dirty="0">
+                <a:solidFill>
+                  <a:srgbClr val="222222"/>
+                </a:solidFill>
+                <a:latin typeface="Arial" pitchFamily="34" charset="0"/>
+                <a:ea typeface="Arial" pitchFamily="34" charset="-122"/>
+                <a:cs typeface="Arial" pitchFamily="34" charset="-120"/>
+              </a:rPr>
+              <a:t>- Redacta a partir de las brechas reales de los eventos. No cites números de estándares o procedimientos que no estén en el Excel.</a:t>
+            </a:r>
+            <a:endParaRPr lang="en-US" sz="600" dirty="0"/>
+          </a:p>
+          <a:p>
+            <a:pPr indent="0" marL="0">
+              <a:buNone/>
+            </a:pPr>
+            <a:endParaRPr lang="en-US" sz="600" dirty="0"/>
+          </a:p>
+          <a:p>
+            <a:pPr indent="0" marL="0">
+              <a:buNone/>
+            </a:pPr>
+            <a:r>
+              <a:rPr lang="en-US" sz="600" dirty="0">
+                <a:solidFill>
+                  <a:srgbClr val="222222"/>
+                </a:solidFill>
+                <a:latin typeface="Arial" pitchFamily="34" charset="0"/>
+                <a:ea typeface="Arial" pitchFamily="34" charset="-122"/>
+                <a:cs typeface="Arial" pitchFamily="34" charset="-120"/>
+              </a:rPr>
+              <a:t>5. EVENTO / EVIDENCIA ORIGEN</a:t>
+            </a:r>
+            <a:endParaRPr lang="en-US" sz="600" dirty="0"/>
+          </a:p>
+          <a:p>
+            <a:pPr indent="0" marL="0">
+              <a:buNone/>
+            </a:pPr>
+            <a:r>
+              <a:rPr lang="en-US" sz="600" dirty="0">
+                <a:solidFill>
+                  <a:srgbClr val="222222"/>
+                </a:solidFill>
+                <a:latin typeface="Arial" pitchFamily="34" charset="0"/>
+                <a:ea typeface="Arial" pitchFamily="34" charset="-122"/>
+                <a:cs typeface="Arial" pitchFamily="34" charset="-120"/>
+              </a:rPr>
+              <a:t>- Formato fijo por evento: "[T1-3] TIPO ID – EECC:" (en negrita) + qué ocurrió, en una frase de hasta 120 caracteres.</a:t>
+            </a:r>
+            <a:endParaRPr lang="en-US" sz="600" dirty="0"/>
+          </a:p>
+          <a:p>
+            <a:pPr indent="0" marL="0">
+              <a:buNone/>
+            </a:pPr>
+            <a:r>
+              <a:rPr lang="en-US" sz="600" dirty="0">
+                <a:solidFill>
+                  <a:srgbClr val="222222"/>
+                </a:solidFill>
+                <a:latin typeface="Arial" pitchFamily="34" charset="0"/>
+                <a:ea typeface="Arial" pitchFamily="34" charset="-122"/>
+                <a:cs typeface="Arial" pitchFamily="34" charset="-120"/>
+              </a:rPr>
+              <a:t>- Máximo 3 eventos por foco; elige los de mayor potencial. Si un evento aparece en ambos turnos, usa [T1-3/T2-4].</a:t>
+            </a:r>
+            <a:endParaRPr lang="en-US" sz="600" dirty="0"/>
+          </a:p>
+          <a:p>
+            <a:pPr indent="0" marL="0">
+              <a:buNone/>
+            </a:pPr>
+            <a:r>
+              <a:rPr lang="en-US" sz="600" dirty="0">
+                <a:solidFill>
+                  <a:srgbClr val="222222"/>
+                </a:solidFill>
+                <a:latin typeface="Arial" pitchFamily="34" charset="0"/>
+                <a:ea typeface="Arial" pitchFamily="34" charset="-122"/>
+                <a:cs typeface="Arial" pitchFamily="34" charset="-120"/>
+              </a:rPr>
+              <a:t>- Para temas recurrentes se permite: "[T1-3] N eventos HBP: descripción del patrón."</a:t>
+            </a:r>
+            <a:endParaRPr lang="en-US" sz="600" dirty="0"/>
+          </a:p>
+          <a:p>
+            <a:pPr indent="0" marL="0">
+              <a:buNone/>
+            </a:pPr>
+            <a:endParaRPr lang="en-US" sz="600" dirty="0"/>
+          </a:p>
+          <a:p>
+            <a:pPr indent="0" marL="0">
+              <a:buNone/>
+            </a:pPr>
+            <a:r>
+              <a:rPr lang="en-US" sz="600" dirty="0">
+                <a:solidFill>
+                  <a:srgbClr val="222222"/>
+                </a:solidFill>
+                <a:latin typeface="Arial" pitchFamily="34" charset="0"/>
+                <a:ea typeface="Arial" pitchFamily="34" charset="-122"/>
+                <a:cs typeface="Arial" pitchFamily="34" charset="-120"/>
+              </a:rPr>
+              <a:t>6. HERRAMIENTA PREVENTIVA SGE</a:t>
+            </a:r>
+            <a:endParaRPr lang="en-US" sz="600" dirty="0"/>
+          </a:p>
+          <a:p>
+            <a:pPr indent="0" marL="0">
+              <a:buNone/>
+            </a:pPr>
+            <a:r>
+              <a:rPr lang="en-US" sz="600" dirty="0">
+                <a:solidFill>
+                  <a:srgbClr val="222222"/>
+                </a:solidFill>
+                <a:latin typeface="Arial" pitchFamily="34" charset="0"/>
+                <a:ea typeface="Arial" pitchFamily="34" charset="-122"/>
+                <a:cs typeface="Arial" pitchFamily="34" charset="-120"/>
+              </a:rPr>
+              <a:t>- Herramientas unidas con "+". Usa las que figuren en el Excel o las ya usadas en este formato: GCC, CdP [tema] (p. ej. CdP Maniobras de Izaje, CdP Trabajos en Altura, CdP Operación de Vehículos Livianos), ASP, PTS, Gestión del Cambio, Desafío en Terreno, Inspección de Plataformas de Andamios, EdC Vehículo Liviano, Inspección de Equipos, Acompañamiento ASP.</a:t>
+            </a:r>
+            <a:endParaRPr lang="en-US" sz="600" dirty="0"/>
+          </a:p>
+          <a:p>
+            <a:pPr indent="0" marL="0">
+              <a:buNone/>
+            </a:pPr>
+            <a:endParaRPr lang="en-US" sz="600" dirty="0"/>
+          </a:p>
+          <a:p>
+            <a:pPr indent="0" marL="0">
+              <a:buNone/>
+            </a:pPr>
+            <a:r>
+              <a:rPr lang="en-US" sz="600" dirty="0">
+                <a:solidFill>
+                  <a:srgbClr val="222222"/>
+                </a:solidFill>
+                <a:latin typeface="Arial" pitchFamily="34" charset="0"/>
+                <a:ea typeface="Arial" pitchFamily="34" charset="-122"/>
+                <a:cs typeface="Arial" pitchFamily="34" charset="-120"/>
+              </a:rPr>
+              <a:t>7. EVIDENCIA / REGISTRO ESPERADO</a:t>
+            </a:r>
+            <a:endParaRPr lang="en-US" sz="600" dirty="0"/>
+          </a:p>
+          <a:p>
+            <a:pPr indent="0" marL="0">
+              <a:buNone/>
+            </a:pPr>
+            <a:r>
+              <a:rPr lang="en-US" sz="600" dirty="0">
+                <a:solidFill>
+                  <a:srgbClr val="222222"/>
+                </a:solidFill>
+                <a:latin typeface="Arial" pitchFamily="34" charset="0"/>
+                <a:ea typeface="Arial" pitchFamily="34" charset="-122"/>
+                <a:cs typeface="Arial" pitchFamily="34" charset="-120"/>
+              </a:rPr>
+              <a:t>- Registros concretos y verificables separados por "/", terminando siempre en "registro fotográfico".</a:t>
+            </a:r>
+            <a:endParaRPr lang="en-US" sz="600" dirty="0"/>
+          </a:p>
+          <a:p>
+            <a:pPr indent="0" marL="0">
+              <a:buNone/>
+            </a:pPr>
+            <a:endParaRPr lang="en-US" sz="600" dirty="0"/>
+          </a:p>
+          <a:p>
+            <a:pPr indent="0" marL="0">
+              <a:buNone/>
+            </a:pPr>
+            <a:r>
+              <a:rPr lang="en-US" sz="600" dirty="0">
+                <a:solidFill>
+                  <a:srgbClr val="222222"/>
+                </a:solidFill>
+                <a:latin typeface="Arial" pitchFamily="34" charset="0"/>
+                <a:ea typeface="Arial" pitchFamily="34" charset="-122"/>
+                <a:cs typeface="Arial" pitchFamily="34" charset="-120"/>
+              </a:rPr>
+              <a:t>8. VERIFICACIÓN EN TERRENO</a:t>
+            </a:r>
+            <a:endParaRPr lang="en-US" sz="600" dirty="0"/>
+          </a:p>
+          <a:p>
+            <a:pPr indent="0" marL="0">
+              <a:buNone/>
+            </a:pPr>
+            <a:r>
+              <a:rPr lang="en-US" sz="600" dirty="0">
+                <a:solidFill>
+                  <a:srgbClr val="222222"/>
+                </a:solidFill>
+                <a:latin typeface="Arial" pitchFamily="34" charset="0"/>
+                <a:ea typeface="Arial" pitchFamily="34" charset="-122"/>
+                <a:cs typeface="Arial" pitchFamily="34" charset="-120"/>
+              </a:rPr>
+              <a:t>- No la modifiques: deja "☐ C ☐ NC ☐ NA / Obs.:" en blanco. La completa el Inspector ITO en terreno.</a:t>
+            </a:r>
+            <a:endParaRPr lang="en-US" sz="600" dirty="0"/>
+          </a:p>
+          <a:p>
+            <a:pPr indent="0" marL="0">
+              <a:buNone/>
+            </a:pPr>
+            <a:endParaRPr lang="en-US" sz="600" dirty="0"/>
+          </a:p>
+          <a:p>
+            <a:pPr indent="0" marL="0">
+              <a:buNone/>
+            </a:pPr>
+            <a:r>
+              <a:rPr lang="en-US" sz="600" dirty="0">
+                <a:solidFill>
+                  <a:srgbClr val="222222"/>
+                </a:solidFill>
+                <a:latin typeface="Arial" pitchFamily="34" charset="0"/>
+                <a:ea typeface="Arial" pitchFamily="34" charset="-122"/>
+                <a:cs typeface="Arial" pitchFamily="34" charset="-120"/>
+              </a:rPr>
+              <a:t>9. RECURRENTE</a:t>
+            </a:r>
+            <a:endParaRPr lang="en-US" sz="600" dirty="0"/>
+          </a:p>
+          <a:p>
+            <a:pPr indent="0" marL="0">
+              <a:buNone/>
+            </a:pPr>
+            <a:r>
+              <a:rPr lang="en-US" sz="600" dirty="0">
+                <a:solidFill>
+                  <a:srgbClr val="222222"/>
+                </a:solidFill>
+                <a:latin typeface="Arial" pitchFamily="34" charset="0"/>
+                <a:ea typeface="Arial" pitchFamily="34" charset="-122"/>
+                <a:cs typeface="Arial" pitchFamily="34" charset="-120"/>
+              </a:rPr>
+              <a:t>- "N eventos HBP — tema (n) · tema (n). Refuerzo transversal en todos los recorridos y al cierre de cada tarea."</a:t>
+            </a:r>
+            <a:endParaRPr lang="en-US" sz="600" dirty="0"/>
+          </a:p>
+          <a:p>
+            <a:pPr indent="0" marL="0">
+              <a:buNone/>
+            </a:pPr>
+            <a:r>
+              <a:rPr lang="en-US" sz="600" dirty="0">
+                <a:solidFill>
+                  <a:srgbClr val="222222"/>
+                </a:solidFill>
+                <a:latin typeface="Arial" pitchFamily="34" charset="0"/>
+                <a:ea typeface="Arial" pitchFamily="34" charset="-122"/>
+                <a:cs typeface="Arial" pitchFamily="34" charset="-120"/>
+              </a:rPr>
+              <a:t>- N = total de HBP del turno y período, incluidos los usados en los focos. Verifica la suma: los subtotales no pueden superar N.</a:t>
+            </a:r>
+            <a:endParaRPr lang="en-US" sz="600" dirty="0"/>
+          </a:p>
+          <a:p>
+            <a:pPr indent="0" marL="0">
+              <a:buNone/>
+            </a:pPr>
+            <a:endParaRPr lang="en-US" sz="600" dirty="0"/>
+          </a:p>
+          <a:p>
+            <a:pPr indent="0" marL="0">
+              <a:buNone/>
+            </a:pPr>
+            <a:r>
+              <a:rPr lang="en-US" sz="600" dirty="0">
+                <a:solidFill>
+                  <a:srgbClr val="222222"/>
+                </a:solidFill>
+                <a:latin typeface="Arial" pitchFamily="34" charset="0"/>
+                <a:ea typeface="Arial" pitchFamily="34" charset="-122"/>
+                <a:cs typeface="Arial" pitchFamily="34" charset="-120"/>
+              </a:rPr>
+              <a:t>10. SÍNTESIS Y RECORRIDOS</a:t>
+            </a:r>
+            <a:endParaRPr lang="en-US" sz="600" dirty="0"/>
+          </a:p>
+          <a:p>
+            <a:pPr indent="0" marL="0">
+              <a:buNone/>
+            </a:pPr>
+            <a:r>
+              <a:rPr lang="en-US" sz="600" dirty="0">
+                <a:solidFill>
+                  <a:srgbClr val="222222"/>
+                </a:solidFill>
+                <a:latin typeface="Arial" pitchFamily="34" charset="0"/>
+                <a:ea typeface="Arial" pitchFamily="34" charset="-122"/>
+                <a:cs typeface="Arial" pitchFamily="34" charset="-120"/>
+              </a:rPr>
+              <a:t>- Bloque AM y Bloque Mediodía: áreas reales tomadas del Excel + 3 o 4 controles, cada uno con el N° de foco entre paréntesis, p. ej. "Plan de izaje específico por maniobra (1)". Asigna al AM los focos de inicio de jornada (izaje, pre-uso de vehículos y equipos) y al Mediodía los de intervención (plataformas, instalaciones eléctricas, orden y aseo).</a:t>
+            </a:r>
+            <a:endParaRPr lang="en-US" sz="600" dirty="0"/>
+          </a:p>
+          <a:p>
+            <a:pPr indent="0" marL="0">
+              <a:buNone/>
+            </a:pPr>
+            <a:r>
+              <a:rPr lang="en-US" sz="600" dirty="0">
+                <a:solidFill>
+                  <a:srgbClr val="222222"/>
+                </a:solidFill>
+                <a:latin typeface="Arial" pitchFamily="34" charset="0"/>
+                <a:ea typeface="Arial" pitchFamily="34" charset="-122"/>
+                <a:cs typeface="Arial" pitchFamily="34" charset="-120"/>
+              </a:rPr>
+              <a:t>- Bloque PM: mantén "Gestión SAP · CdP pendientes · Entrega de turno" y sus líneas fijas. En "Actualizar PTS con brechas de CdP:" indica las brechas que el Excel respalde; si no hay, elimina esa línea.</a:t>
+            </a:r>
+            <a:endParaRPr lang="en-US" sz="600" dirty="0"/>
+          </a:p>
+          <a:p>
+            <a:pPr indent="0" marL="0">
+              <a:buNone/>
+            </a:pPr>
+            <a:r>
+              <a:rPr lang="en-US" sz="600" dirty="0">
+                <a:solidFill>
+                  <a:srgbClr val="222222"/>
+                </a:solidFill>
+                <a:latin typeface="Arial" pitchFamily="34" charset="0"/>
+                <a:ea typeface="Arial" pitchFamily="34" charset="-122"/>
+                <a:cs typeface="Arial" pitchFamily="34" charset="-120"/>
+              </a:rPr>
+              <a:t>- Brechas principales / Controles críticos no negociables / Detener la tarea si…: máximo 5 viñetas de 1 línea (unos 50 caracteres) en cada recuadro, coherentes con los focos. Brechas = lo que falló. Controles = lo que no se negocia. Detener si = condición concreta de detención.</a:t>
+            </a:r>
+            <a:endParaRPr lang="en-US" sz="600" dirty="0"/>
+          </a:p>
+          <a:p>
+            <a:pPr indent="0" marL="0">
+              <a:buNone/>
+            </a:pPr>
+            <a:endParaRPr lang="en-US" sz="600" dirty="0"/>
+          </a:p>
+          <a:p>
+            <a:pPr indent="0" marL="0">
+              <a:buNone/>
+            </a:pPr>
+            <a:r>
+              <a:rPr lang="en-US" sz="600" dirty="0">
+                <a:solidFill>
+                  <a:srgbClr val="222222"/>
+                </a:solidFill>
+                <a:latin typeface="Arial" pitchFamily="34" charset="0"/>
+                <a:ea typeface="Arial" pitchFamily="34" charset="-122"/>
+                <a:cs typeface="Arial" pitchFamily="34" charset="-120"/>
+              </a:rPr>
+              <a:t>11. ENCABEZADO, CIERRE Y FIRMAS</a:t>
+            </a:r>
+            <a:endParaRPr lang="en-US" sz="600" dirty="0"/>
+          </a:p>
+          <a:p>
+            <a:pPr indent="0" marL="0">
+              <a:buNone/>
+            </a:pPr>
+            <a:r>
+              <a:rPr lang="en-US" sz="600" dirty="0">
+                <a:solidFill>
+                  <a:srgbClr val="222222"/>
+                </a:solidFill>
+                <a:latin typeface="Arial" pitchFamily="34" charset="0"/>
+                <a:ea typeface="Arial" pitchFamily="34" charset="-122"/>
+                <a:cs typeface="Arial" pitchFamily="34" charset="-120"/>
+              </a:rPr>
+              <a:t>- Título: "ASSURANCE TURNO 1-3" o "ASSURANCE TURNO 2-4". Fecha/Período: "DD al DD MES". Turno: marca ☒ en el que corresponde.</a:t>
+            </a:r>
+            <a:endParaRPr lang="en-US" sz="600" dirty="0"/>
+          </a:p>
+          <a:p>
+            <a:pPr indent="0" marL="0">
+              <a:buNone/>
+            </a:pPr>
+            <a:r>
+              <a:rPr lang="en-US" sz="600" dirty="0">
+                <a:solidFill>
+                  <a:srgbClr val="222222"/>
+                </a:solidFill>
+                <a:latin typeface="Arial" pitchFamily="34" charset="0"/>
+                <a:ea typeface="Arial" pitchFamily="34" charset="-122"/>
+                <a:cs typeface="Arial" pitchFamily="34" charset="-120"/>
+              </a:rPr>
+              <a:t>- Inspector ITO, Proyecto/EECC y Área/Sector: complétalos solo si el usuario los entrega; si no, deja la línea en blanco.</a:t>
+            </a:r>
+            <a:endParaRPr lang="en-US" sz="600" dirty="0"/>
+          </a:p>
+          <a:p>
+            <a:pPr indent="0" marL="0">
+              <a:buNone/>
+            </a:pPr>
+            <a:r>
+              <a:rPr lang="en-US" sz="600" dirty="0">
+                <a:solidFill>
+                  <a:srgbClr val="222222"/>
+                </a:solidFill>
+                <a:latin typeface="Arial" pitchFamily="34" charset="0"/>
+                <a:ea typeface="Arial" pitchFamily="34" charset="-122"/>
+                <a:cs typeface="Arial" pitchFamily="34" charset="-120"/>
+              </a:rPr>
+              <a:t>- La franja CIERRE y las firmas se dejan en blanco.</a:t>
+            </a:r>
+            <a:endParaRPr lang="en-US" sz="600" dirty="0"/>
+          </a:p>
+          <a:p>
+            <a:pPr indent="0" marL="0">
+              <a:buNone/>
+            </a:pPr>
+            <a:endParaRPr lang="en-US" sz="600" dirty="0"/>
+          </a:p>
+          <a:p>
+            <a:pPr indent="0" marL="0">
+              <a:buNone/>
+            </a:pPr>
+            <a:r>
+              <a:rPr lang="en-US" sz="600" dirty="0">
+                <a:solidFill>
+                  <a:srgbClr val="222222"/>
+                </a:solidFill>
+                <a:latin typeface="Arial" pitchFamily="34" charset="0"/>
+                <a:ea typeface="Arial" pitchFamily="34" charset="-122"/>
+                <a:cs typeface="Arial" pitchFamily="34" charset="-120"/>
+              </a:rPr>
+              <a:t>12. FORMATO (obligatorio)</a:t>
+            </a:r>
+            <a:endParaRPr lang="en-US" sz="600" dirty="0"/>
+          </a:p>
+          <a:p>
+            <a:pPr indent="0" marL="0">
+              <a:buNone/>
+            </a:pPr>
+            <a:r>
+              <a:rPr lang="en-US" sz="600" dirty="0">
+                <a:solidFill>
+                  <a:srgbClr val="222222"/>
+                </a:solidFill>
+                <a:latin typeface="Arial" pitchFamily="34" charset="0"/>
+                <a:ea typeface="Arial" pitchFamily="34" charset="-122"/>
+                <a:cs typeface="Arial" pitchFamily="34" charset="-120"/>
+              </a:rPr>
+              <a:t>- No cambies estructura, columnas, colores, fuentes, íconos ni tamaño de la lámina.</a:t>
+            </a:r>
+            <a:endParaRPr lang="en-US" sz="600" dirty="0"/>
+          </a:p>
+          <a:p>
+            <a:pPr indent="0" marL="0">
+              <a:buNone/>
+            </a:pPr>
+            <a:r>
+              <a:rPr lang="en-US" sz="600" dirty="0">
+                <a:solidFill>
+                  <a:srgbClr val="222222"/>
+                </a:solidFill>
+                <a:latin typeface="Arial" pitchFamily="34" charset="0"/>
+                <a:ea typeface="Arial" pitchFamily="34" charset="-122"/>
+                <a:cs typeface="Arial" pitchFamily="34" charset="-120"/>
+              </a:rPr>
+              <a:t>- Reemplaza todo texto gris entre [corchetes] por contenido real en color de texto normal (negro, sin cursiva). No debe quedar ningún corchete, salvo [DATO FALTANTE] y las marcas de turno [T1-3]/[T2-4].</a:t>
+            </a:r>
+            <a:endParaRPr lang="en-US" sz="600" dirty="0"/>
+          </a:p>
+          <a:p>
+            <a:pPr indent="0" marL="0">
+              <a:buNone/>
+            </a:pPr>
+            <a:r>
+              <a:rPr lang="en-US" sz="600" dirty="0">
+                <a:solidFill>
+                  <a:srgbClr val="222222"/>
+                </a:solidFill>
+                <a:latin typeface="Arial" pitchFamily="34" charset="0"/>
+                <a:ea typeface="Arial" pitchFamily="34" charset="-122"/>
+                <a:cs typeface="Arial" pitchFamily="34" charset="-120"/>
+              </a:rPr>
+              <a:t>- Letra mínima 6 pt. Si el texto no cabe, resume; no reduzcas más la letra ni agrandes filas.</a:t>
+            </a:r>
+            <a:endParaRPr lang="en-US" sz="600" dirty="0"/>
+          </a:p>
+          <a:p>
+            <a:pPr indent="0" marL="0">
+              <a:buNone/>
+            </a:pPr>
+            <a:r>
+              <a:rPr lang="en-US" sz="600" dirty="0">
+                <a:solidFill>
+                  <a:srgbClr val="222222"/>
+                </a:solidFill>
+                <a:latin typeface="Arial" pitchFamily="34" charset="0"/>
+                <a:ea typeface="Arial" pitchFamily="34" charset="-122"/>
+                <a:cs typeface="Arial" pitchFamily="34" charset="-120"/>
+              </a:rPr>
+              <a:t>- Antes de entregar: elimina la lámina 2 (instructivo) y la lámina 3 (ejemplo). No modifiques ni muevas el cuadro de texto oculto "Instrucciones IA" de la lámina 1.</a:t>
+            </a:r>
+            <a:endParaRPr lang="en-US" sz="600" dirty="0"/>
+          </a:p>
+          <a:p>
+            <a:pPr indent="0" marL="0">
+              <a:buNone/>
+            </a:pPr>
+            <a:r>
+              <a:rPr lang="en-US" sz="600" dirty="0">
+                <a:solidFill>
+                  <a:srgbClr val="222222"/>
+                </a:solidFill>
+                <a:latin typeface="Arial" pitchFamily="34" charset="0"/>
+                <a:ea typeface="Arial" pitchFamily="34" charset="-122"/>
+                <a:cs typeface="Arial" pitchFamily="34" charset="-120"/>
+              </a:rPr>
+              <a:t>- Nombre del archivo: ASSURANCE_TURNO_[1-3 o 2-4]_[DD-DD]_[MES].pptx (ej.: ASSURANCE_TURNO_1-3_07-20_SEP.pptx).</a:t>
+            </a:r>
+            <a:endParaRPr lang="en-US" sz="600" dirty="0"/>
+          </a:p>
+          <a:p>
+            <a:pPr indent="0" marL="0">
+              <a:buNone/>
+            </a:pPr>
+            <a:endParaRPr lang="en-US" sz="600" dirty="0"/>
+          </a:p>
+          <a:p>
+            <a:pPr indent="0" marL="0">
+              <a:buNone/>
+            </a:pPr>
+            <a:r>
+              <a:rPr lang="en-US" sz="600" dirty="0">
+                <a:solidFill>
+                  <a:srgbClr val="222222"/>
+                </a:solidFill>
+                <a:latin typeface="Arial" pitchFamily="34" charset="0"/>
+                <a:ea typeface="Arial" pitchFamily="34" charset="-122"/>
+                <a:cs typeface="Arial" pitchFamily="34" charset="-120"/>
+              </a:rPr>
+              <a:t>13. ENTREGA</a:t>
+            </a:r>
+            <a:endParaRPr lang="en-US" sz="600" dirty="0"/>
+          </a:p>
+          <a:p>
+            <a:pPr indent="0" marL="0">
+              <a:buNone/>
+            </a:pPr>
+            <a:r>
+              <a:rPr lang="en-US" sz="600" dirty="0">
+                <a:solidFill>
+                  <a:srgbClr val="222222"/>
+                </a:solidFill>
+                <a:latin typeface="Arial" pitchFamily="34" charset="0"/>
+                <a:ea typeface="Arial" pitchFamily="34" charset="-122"/>
+                <a:cs typeface="Arial" pitchFamily="34" charset="-120"/>
+              </a:rPr>
+              <a:t>- Si puedes editar archivos .pptx: entrega el archivo completado.</a:t>
+            </a:r>
+            <a:endParaRPr lang="en-US" sz="600" dirty="0"/>
+          </a:p>
+          <a:p>
+            <a:pPr indent="0" marL="0">
+              <a:buNone/>
+            </a:pPr>
+            <a:r>
+              <a:rPr lang="en-US" sz="600" dirty="0">
+                <a:solidFill>
+                  <a:srgbClr val="222222"/>
+                </a:solidFill>
+                <a:latin typeface="Arial" pitchFamily="34" charset="0"/>
+                <a:ea typeface="Arial" pitchFamily="34" charset="-122"/>
+                <a:cs typeface="Arial" pitchFamily="34" charset="-120"/>
+              </a:rPr>
+              <a:t>- Si no puedes: entrega el contenido en texto, ordenado por sección y por fila de la plantilla (Encabezado; Foco 1 a 6 con sus 5 columnas; Recurrente; Bloques AM/Mediodía/PM; Brechas; Controles; Detener si), listo para copiar y pegar en cada casilla.</a:t>
+            </a:r>
+            <a:endParaRPr lang="en-US" sz="600" dirty="0"/>
+          </a:p>
+          <a:p>
+            <a:pPr indent="0" marL="0">
+              <a:buNone/>
+            </a:pPr>
+            <a:endParaRPr lang="en-US" sz="600" dirty="0"/>
+          </a:p>
+          <a:p>
+            <a:pPr indent="0" marL="0">
+              <a:buNone/>
+            </a:pPr>
+            <a:r>
+              <a:rPr lang="en-US" sz="600" dirty="0">
+                <a:solidFill>
+                  <a:srgbClr val="222222"/>
+                </a:solidFill>
+                <a:latin typeface="Arial" pitchFamily="34" charset="0"/>
+                <a:ea typeface="Arial" pitchFamily="34" charset="-122"/>
+                <a:cs typeface="Arial" pitchFamily="34" charset="-120"/>
+              </a:rPr>
+              <a:t>14. CONTROL DE CALIDAD (en tu respuesta al usuario, no dentro del archivo)</a:t>
+            </a:r>
+            <a:endParaRPr lang="en-US" sz="600" dirty="0"/>
+          </a:p>
+          <a:p>
+            <a:pPr indent="0" marL="0">
+              <a:buNone/>
+            </a:pPr>
+            <a:r>
+              <a:rPr lang="en-US" sz="600" dirty="0">
+                <a:solidFill>
+                  <a:srgbClr val="222222"/>
+                </a:solidFill>
+                <a:latin typeface="Arial" pitchFamily="34" charset="0"/>
+                <a:ea typeface="Arial" pitchFamily="34" charset="-122"/>
+                <a:cs typeface="Arial" pitchFamily="34" charset="-120"/>
+              </a:rPr>
+              <a:t>Al final de tu respuesta incluye un resumen breve con:</a:t>
+            </a:r>
+            <a:endParaRPr lang="en-US" sz="600" dirty="0"/>
+          </a:p>
+          <a:p>
+            <a:pPr indent="0" marL="0">
+              <a:buNone/>
+            </a:pPr>
+            <a:r>
+              <a:rPr lang="en-US" sz="600" dirty="0">
+                <a:solidFill>
+                  <a:srgbClr val="222222"/>
+                </a:solidFill>
+                <a:latin typeface="Arial" pitchFamily="34" charset="0"/>
+                <a:ea typeface="Arial" pitchFamily="34" charset="-122"/>
+                <a:cs typeface="Arial" pitchFamily="34" charset="-120"/>
+              </a:rPr>
+              <a:t>- total de eventos leídos y cuántos de cada tipo;</a:t>
+            </a:r>
+            <a:endParaRPr lang="en-US" sz="600" dirty="0"/>
+          </a:p>
+          <a:p>
+            <a:pPr indent="0" marL="0">
+              <a:buNone/>
+            </a:pPr>
+            <a:r>
+              <a:rPr lang="en-US" sz="600" dirty="0">
+                <a:solidFill>
+                  <a:srgbClr val="222222"/>
+                </a:solidFill>
+                <a:latin typeface="Arial" pitchFamily="34" charset="0"/>
+                <a:ea typeface="Arial" pitchFamily="34" charset="-122"/>
+                <a:cs typeface="Arial" pitchFamily="34" charset="-120"/>
+              </a:rPr>
+              <a:t>- eventos usados en cada foco y los de alto potencial que quedaron fuera, con el motivo;</a:t>
+            </a:r>
+            <a:endParaRPr lang="en-US" sz="600" dirty="0"/>
+          </a:p>
+          <a:p>
+            <a:pPr indent="0" marL="0">
+              <a:buNone/>
+            </a:pPr>
+            <a:r>
+              <a:rPr lang="en-US" sz="600" dirty="0">
+                <a:solidFill>
+                  <a:srgbClr val="222222"/>
+                </a:solidFill>
+                <a:latin typeface="Arial" pitchFamily="34" charset="0"/>
+                <a:ea typeface="Arial" pitchFamily="34" charset="-122"/>
+                <a:cs typeface="Arial" pitchFamily="34" charset="-120"/>
+              </a:rPr>
+              <a:t>- datos faltantes o inconsistentes y supuestos realizados.</a:t>
+            </a:r>
+            <a:endParaRPr lang="en-US" sz="600" dirty="0"/>
+          </a:p>
+          <a:p>
+            <a:pPr indent="0" marL="0">
+              <a:buNone/>
+            </a:pPr>
+            <a:r>
+              <a:rPr lang="en-US" sz="600" dirty="0">
+                <a:solidFill>
+                  <a:srgbClr val="222222"/>
+                </a:solidFill>
+                <a:latin typeface="Arial" pitchFamily="34" charset="0"/>
+                <a:ea typeface="Arial" pitchFamily="34" charset="-122"/>
+                <a:cs typeface="Arial" pitchFamily="34" charset="-120"/>
+              </a:rPr>
+              <a:t>Antes de entregar, confirma que: cada ID existe en el Excel; cada foco tiene al menos un evento de origen; los conteos del Recurrente cuadran; y no quedan textos guía.</a:t>
+            </a:r>
+            <a:endParaRPr lang="en-US" sz="600" dirty="0"/>
+          </a:p>
+        </p:txBody>
+      </p:sp>
     </p:spTree>
   </p:cSld>
   <p:clrMapOvr>
@@ -16562,1302 +17530,6 @@
       <p:sp>
         <p:nvSpPr>
           <p:cNvPr id="53" name="Text 46"/>
-          <p:cNvSpPr txBox="1"/>
-          <p:nvPr/>
-        </p:nvSpPr>
-        <p:spPr>
-          <a:xfrm>
-            <a:off x="7680960" y="8385048"/>
-            <a:ext cx="4142232" cy="347472"/>
-          </a:xfrm>
-          <a:prstGeom prst="rect">
-            <a:avLst/>
-          </a:prstGeom>
-          <a:noFill/>
-          <a:ln/>
-        </p:spPr>
-        <p:txBody>
-          <a:bodyPr wrap="square" lIns="0" tIns="0" rIns="0" bIns="0" rtlCol="0" anchor="ctr"/>
-          <a:lstStyle/>
-          <a:p>
-            <a:pPr algn="r" indent="0" marL="0">
-              <a:buNone/>
-            </a:pPr>
-            <a:r>
-              <a:rPr lang="en-US" sz="950" b="1" dirty="0">
-                <a:solidFill>
-                  <a:srgbClr val="FFFFFF"/>
-                </a:solidFill>
-                <a:latin typeface="Arial" pitchFamily="34" charset="0"/>
-                <a:ea typeface="Arial" pitchFamily="34" charset="-122"/>
-                <a:cs typeface="Arial" pitchFamily="34" charset="-120"/>
-              </a:rPr>
-              <a:t>SEGURIDAD, SALUD, PERSONAS Y MEDIO AMBIENTE</a:t>
-            </a:r>
-            <a:endParaRPr lang="en-US" sz="950" dirty="0"/>
-          </a:p>
-        </p:txBody>
-      </p:sp>
-    </p:spTree>
-  </p:cSld>
-  <p:clrMapOvr>
-    <a:masterClrMapping/>
-  </p:clrMapOvr>
-</p:sld>
-</file>
-
-<file path=ppt/slides/slide4.xml><?xml version="1.0" encoding="utf-8"?>
-<p:sld xmlns:a="http://schemas.openxmlformats.org/drawingml/2006/main" xmlns:r="http://schemas.openxmlformats.org/officeDocument/2006/relationships" xmlns:p="http://schemas.openxmlformats.org/presentationml/2006/main" show="0">
-  <p:cSld name="Slide 4">
-    <p:bg>
-      <p:bgPr>
-        <a:solidFill>
-          <a:srgbClr val="FFFFFF"/>
-        </a:solidFill>
-      </p:bgPr>
-    </p:bg>
-    <p:spTree>
-      <p:nvGrpSpPr>
-        <p:cNvPr id="1" name=""/>
-        <p:cNvGrpSpPr/>
-        <p:nvPr/>
-      </p:nvGrpSpPr>
-      <p:grpSpPr>
-        <a:xfrm>
-          <a:off x="0" y="0"/>
-          <a:ext cx="0" cy="0"/>
-          <a:chOff x="0" y="0"/>
-          <a:chExt cx="0" cy="0"/>
-        </a:xfrm>
-      </p:grpSpPr>
-      <p:sp>
-        <p:nvSpPr>
-          <p:cNvPr id="2" name="Text 0"/>
-          <p:cNvSpPr txBox="1"/>
-          <p:nvPr/>
-        </p:nvSpPr>
-        <p:spPr>
-          <a:xfrm>
-            <a:off x="365760" y="228600"/>
-            <a:ext cx="11457432" cy="365760"/>
-          </a:xfrm>
-          <a:prstGeom prst="rect">
-            <a:avLst/>
-          </a:prstGeom>
-          <a:noFill/>
-          <a:ln/>
-        </p:spPr>
-        <p:txBody>
-          <a:bodyPr wrap="square" lIns="0" tIns="0" rIns="0" bIns="0" rtlCol="0" anchor="ctr"/>
-          <a:lstStyle/>
-          <a:p>
-            <a:pPr indent="0" marL="0">
-              <a:buNone/>
-            </a:pPr>
-            <a:r>
-              <a:rPr lang="en-US" sz="1400" b="1" dirty="0">
-                <a:solidFill>
-                  <a:srgbClr val="1F3D6B"/>
-                </a:solidFill>
-                <a:latin typeface="Arial" pitchFamily="34" charset="0"/>
-                <a:ea typeface="Arial" pitchFamily="34" charset="-122"/>
-                <a:cs typeface="Arial" pitchFamily="34" charset="-120"/>
-              </a:rPr>
-              <a:t>INSTRUCCIONES PARA ASISTENTES IA – FORMATO ASSURANCE ITO v1.0  (lámina oculta: no se muestra al presentar ni se imprime)</a:t>
-            </a:r>
-            <a:endParaRPr lang="en-US" sz="1400" dirty="0"/>
-          </a:p>
-        </p:txBody>
-      </p:sp>
-      <p:sp>
-        <p:nvSpPr>
-          <p:cNvPr id="3" name="Text 1"/>
-          <p:cNvSpPr txBox="1"/>
-          <p:nvPr/>
-        </p:nvSpPr>
-        <p:spPr>
-          <a:xfrm>
-            <a:off x="365760" y="731520"/>
-            <a:ext cx="5632704" cy="7589520"/>
-          </a:xfrm>
-          <a:prstGeom prst="rect">
-            <a:avLst/>
-          </a:prstGeom>
-          <a:noFill/>
-          <a:ln/>
-        </p:spPr>
-        <p:txBody>
-          <a:bodyPr wrap="square" lIns="0" tIns="0" rIns="0" bIns="0" rtlCol="0" anchor="t"/>
-          <a:lstStyle/>
-          <a:p>
-            <a:pPr indent="0" marL="0">
-              <a:buNone/>
-            </a:pPr>
-            <a:r>
-              <a:rPr lang="en-US" sz="700" b="1" dirty="0">
-                <a:solidFill>
-                  <a:srgbClr val="1F3D6B"/>
-                </a:solidFill>
-                <a:latin typeface="Arial" pitchFamily="34" charset="0"/>
-                <a:ea typeface="Arial" pitchFamily="34" charset="-122"/>
-                <a:cs typeface="Arial" pitchFamily="34" charset="-120"/>
-              </a:rPr>
-              <a:t>OBJETIVO</a:t>
-            </a:r>
-            <a:endParaRPr lang="en-US" sz="700" dirty="0"/>
-          </a:p>
-          <a:p>
-            <a:pPr indent="0" marL="0">
-              <a:buNone/>
-            </a:pPr>
-            <a:r>
-              <a:rPr lang="en-US" sz="700" dirty="0">
-                <a:solidFill>
-                  <a:srgbClr val="222222"/>
-                </a:solidFill>
-                <a:latin typeface="Arial" pitchFamily="34" charset="0"/>
-                <a:ea typeface="Arial" pitchFamily="34" charset="-122"/>
-                <a:cs typeface="Arial" pitchFamily="34" charset="-120"/>
-              </a:rPr>
-              <a:t>Con el Excel de eventos de seguridad que entrega el usuario (CAAP, HAP, CBP, HBP), completar la lámina 1 "PLANTILLA" de este archivo con los focos prioritarios de verificación en terreno para el turno y período indicados. La lámina 3 "EJEMPLO" muestra el resultado esperado: úsala como referencia de largo, tono y formato.</a:t>
-            </a:r>
-            <a:endParaRPr lang="en-US" sz="700" dirty="0"/>
-          </a:p>
-          <a:p>
-            <a:pPr indent="0" marL="0">
-              <a:spcBef>
-                <a:spcPts val="500"/>
-              </a:spcBef>
-              <a:buNone/>
-            </a:pPr>
-            <a:r>
-              <a:rPr lang="en-US" sz="700" b="1" dirty="0">
-                <a:solidFill>
-                  <a:srgbClr val="1F3D6B"/>
-                </a:solidFill>
-                <a:latin typeface="Arial" pitchFamily="34" charset="0"/>
-                <a:ea typeface="Arial" pitchFamily="34" charset="-122"/>
-                <a:cs typeface="Arial" pitchFamily="34" charset="-120"/>
-              </a:rPr>
-              <a:t>1. ENTRADAS Y DATOS</a:t>
-            </a:r>
-            <a:endParaRPr lang="en-US" sz="700" dirty="0"/>
-          </a:p>
-          <a:p>
-            <a:pPr indent="0" marL="0">
-              <a:buNone/>
-            </a:pPr>
-            <a:r>
-              <a:rPr lang="en-US" sz="700" dirty="0">
-                <a:solidFill>
-                  <a:srgbClr val="222222"/>
-                </a:solidFill>
-                <a:latin typeface="Arial" pitchFamily="34" charset="0"/>
-                <a:ea typeface="Arial" pitchFamily="34" charset="-122"/>
-                <a:cs typeface="Arial" pitchFamily="34" charset="-120"/>
-              </a:rPr>
-              <a:t>- Identifica en el Excel las columnas de: ID del evento, tipo (CAAP/HAP/CBP/HBP), fecha, turno, empresa contratista (EECC), área/sector y descripción. Si existen, también acciones y estado.</a:t>
-            </a:r>
-            <a:endParaRPr lang="en-US" sz="700" dirty="0"/>
-          </a:p>
-          <a:p>
-            <a:pPr indent="0" marL="0">
-              <a:buNone/>
-            </a:pPr>
-            <a:r>
-              <a:rPr lang="en-US" sz="700" dirty="0">
-                <a:solidFill>
-                  <a:srgbClr val="222222"/>
-                </a:solidFill>
-                <a:latin typeface="Arial" pitchFamily="34" charset="0"/>
-                <a:ea typeface="Arial" pitchFamily="34" charset="-122"/>
-                <a:cs typeface="Arial" pitchFamily="34" charset="-120"/>
-              </a:rPr>
-              <a:t>- Usa solo eventos del turno (1-3 o 2-4) y del período que indique el usuario. Si el turno o el período no están claros, pregunta antes de completar.</a:t>
-            </a:r>
-            <a:endParaRPr lang="en-US" sz="700" dirty="0"/>
-          </a:p>
-          <a:p>
-            <a:pPr indent="0" marL="0">
-              <a:buNone/>
-            </a:pPr>
-            <a:r>
-              <a:rPr lang="en-US" sz="700" dirty="0">
-                <a:solidFill>
-                  <a:srgbClr val="222222"/>
-                </a:solidFill>
-                <a:latin typeface="Arial" pitchFamily="34" charset="0"/>
-                <a:ea typeface="Arial" pitchFamily="34" charset="-122"/>
-                <a:cs typeface="Arial" pitchFamily="34" charset="-120"/>
-              </a:rPr>
-              <a:t>- Usa exclusivamente datos del Excel. Nunca inventes IDs, empresas, fechas, áreas ni eventos. Copia los IDs exactamente como aparecen.</a:t>
-            </a:r>
-            <a:endParaRPr lang="en-US" sz="700" dirty="0"/>
-          </a:p>
-          <a:p>
-            <a:pPr indent="0" marL="0">
-              <a:buNone/>
-            </a:pPr>
-            <a:r>
-              <a:rPr lang="en-US" sz="700" dirty="0">
-                <a:solidFill>
-                  <a:srgbClr val="222222"/>
-                </a:solidFill>
-                <a:latin typeface="Arial" pitchFamily="34" charset="0"/>
-                <a:ea typeface="Arial" pitchFamily="34" charset="-122"/>
-                <a:cs typeface="Arial" pitchFamily="34" charset="-120"/>
-              </a:rPr>
-              <a:t>- Si falta un dato necesario, escribe [DATO FALTANTE] en esa casilla e infórmalo al usuario.</a:t>
-            </a:r>
-            <a:endParaRPr lang="en-US" sz="700" dirty="0"/>
-          </a:p>
-          <a:p>
-            <a:pPr indent="0" marL="0">
-              <a:buNone/>
-            </a:pPr>
-            <a:r>
-              <a:rPr lang="en-US" sz="700" dirty="0">
-                <a:solidFill>
-                  <a:srgbClr val="222222"/>
-                </a:solidFill>
-                <a:latin typeface="Arial" pitchFamily="34" charset="0"/>
-                <a:ea typeface="Arial" pitchFamily="34" charset="-122"/>
-                <a:cs typeface="Arial" pitchFamily="34" charset="-120"/>
-              </a:rPr>
-              <a:t>- No incluyas nombres de personas; usa el cargo o rol (trabajador, rigger, operador, supervisor).</a:t>
-            </a:r>
-            <a:endParaRPr lang="en-US" sz="700" dirty="0"/>
-          </a:p>
-          <a:p>
-            <a:pPr indent="0" marL="0">
-              <a:spcBef>
-                <a:spcPts val="500"/>
-              </a:spcBef>
-              <a:buNone/>
-            </a:pPr>
-            <a:r>
-              <a:rPr lang="en-US" sz="700" b="1" dirty="0">
-                <a:solidFill>
-                  <a:srgbClr val="1F3D6B"/>
-                </a:solidFill>
-                <a:latin typeface="Arial" pitchFamily="34" charset="0"/>
-                <a:ea typeface="Arial" pitchFamily="34" charset="-122"/>
-                <a:cs typeface="Arial" pitchFamily="34" charset="-120"/>
-              </a:rPr>
-              <a:t>2. SELECCIÓN DE FOCOS (4 a 6)</a:t>
-            </a:r>
-            <a:endParaRPr lang="en-US" sz="700" dirty="0"/>
-          </a:p>
-          <a:p>
-            <a:pPr indent="0" marL="0">
-              <a:buNone/>
-            </a:pPr>
-            <a:r>
-              <a:rPr lang="en-US" sz="700" dirty="0">
-                <a:solidFill>
-                  <a:srgbClr val="222222"/>
-                </a:solidFill>
-                <a:latin typeface="Arial" pitchFamily="34" charset="0"/>
-                <a:ea typeface="Arial" pitchFamily="34" charset="-122"/>
-                <a:cs typeface="Arial" pitchFamily="34" charset="-120"/>
-              </a:rPr>
-              <a:t>- Agrupa los eventos por riesgo (p. ej.: izaje, trabajo en altura/andamios, vehículos y equipos, energía eléctrica, excavaciones/zanjas, orden y aseo). Un foco = un riesgo.</a:t>
-            </a:r>
-            <a:endParaRPr lang="en-US" sz="700" dirty="0"/>
-          </a:p>
-          <a:p>
-            <a:pPr indent="0" marL="0">
-              <a:buNone/>
-            </a:pPr>
-            <a:r>
-              <a:rPr lang="en-US" sz="700" dirty="0">
-                <a:solidFill>
-                  <a:srgbClr val="222222"/>
-                </a:solidFill>
-                <a:latin typeface="Arial" pitchFamily="34" charset="0"/>
-                <a:ea typeface="Arial" pitchFamily="34" charset="-122"/>
-                <a:cs typeface="Arial" pitchFamily="34" charset="-120"/>
-              </a:rPr>
-              <a:t>- Prioriza en este orden: CAAP &gt; HAP &gt; CBP &gt; HBP. A igual tipo: más eventos del mismo riesgo y, luego, más recientes.</a:t>
-            </a:r>
-            <a:endParaRPr lang="en-US" sz="700" dirty="0"/>
-          </a:p>
-          <a:p>
-            <a:pPr indent="0" marL="0">
-              <a:buNone/>
-            </a:pPr>
-            <a:r>
-              <a:rPr lang="en-US" sz="700" dirty="0">
-                <a:solidFill>
-                  <a:srgbClr val="222222"/>
-                </a:solidFill>
-                <a:latin typeface="Arial" pitchFamily="34" charset="0"/>
-                <a:ea typeface="Arial" pitchFamily="34" charset="-122"/>
-                <a:cs typeface="Arial" pitchFamily="34" charset="-120"/>
-              </a:rPr>
-              <a:t>- Un tema de HBP con 3 o más eventos en el período puede ser foco propio (recurrente).</a:t>
-            </a:r>
-            <a:endParaRPr lang="en-US" sz="700" dirty="0"/>
-          </a:p>
-          <a:p>
-            <a:pPr indent="0" marL="0">
-              <a:buNone/>
-            </a:pPr>
-            <a:r>
-              <a:rPr lang="en-US" sz="700" dirty="0">
-                <a:solidFill>
-                  <a:srgbClr val="222222"/>
-                </a:solidFill>
-                <a:latin typeface="Arial" pitchFamily="34" charset="0"/>
-                <a:ea typeface="Arial" pitchFamily="34" charset="-122"/>
-                <a:cs typeface="Arial" pitchFamily="34" charset="-120"/>
-              </a:rPr>
-              <a:t>- Ordena los focos de mayor a menor prioridad y numéralos 1, 2, 3…</a:t>
-            </a:r>
-            <a:endParaRPr lang="en-US" sz="700" dirty="0"/>
-          </a:p>
-          <a:p>
-            <a:pPr indent="0" marL="0">
-              <a:buNone/>
-            </a:pPr>
-            <a:r>
-              <a:rPr lang="en-US" sz="700" dirty="0">
-                <a:solidFill>
-                  <a:srgbClr val="222222"/>
-                </a:solidFill>
-                <a:latin typeface="Arial" pitchFamily="34" charset="0"/>
-                <a:ea typeface="Arial" pitchFamily="34" charset="-122"/>
-                <a:cs typeface="Arial" pitchFamily="34" charset="-120"/>
-              </a:rPr>
-              <a:t>- Si hay menos de 6 focos, elimina las filas sobrantes de la tabla.</a:t>
-            </a:r>
-            <a:endParaRPr lang="en-US" sz="700" dirty="0"/>
-          </a:p>
-          <a:p>
-            <a:pPr indent="0" marL="0">
-              <a:spcBef>
-                <a:spcPts val="500"/>
-              </a:spcBef>
-              <a:buNone/>
-            </a:pPr>
-            <a:r>
-              <a:rPr lang="en-US" sz="700" b="1" dirty="0">
-                <a:solidFill>
-                  <a:srgbClr val="1F3D6B"/>
-                </a:solidFill>
-                <a:latin typeface="Arial" pitchFamily="34" charset="0"/>
-                <a:ea typeface="Arial" pitchFamily="34" charset="-122"/>
-                <a:cs typeface="Arial" pitchFamily="34" charset="-120"/>
-              </a:rPr>
-              <a:t>3. NIVEL / PRIORIDAD (primera columna)</a:t>
-            </a:r>
-            <a:endParaRPr lang="en-US" sz="700" dirty="0"/>
-          </a:p>
-          <a:p>
-            <a:pPr indent="0" marL="0">
-              <a:buNone/>
-            </a:pPr>
-            <a:r>
-              <a:rPr lang="en-US" sz="700" dirty="0">
-                <a:solidFill>
-                  <a:srgbClr val="222222"/>
-                </a:solidFill>
-                <a:latin typeface="Arial" pitchFamily="34" charset="0"/>
-                <a:ea typeface="Arial" pitchFamily="34" charset="-122"/>
-                <a:cs typeface="Arial" pitchFamily="34" charset="-120"/>
-              </a:rPr>
-              <a:t>- Estructura: número / "N1 · CRÍTICO" o "N2 · ALTO" / tipo del evento más grave del foco (CAAP, HAP, CBP o HBP).</a:t>
-            </a:r>
-            <a:endParaRPr lang="en-US" sz="700" dirty="0"/>
-          </a:p>
-          <a:p>
-            <a:pPr indent="0" marL="0">
-              <a:buNone/>
-            </a:pPr>
-            <a:r>
-              <a:rPr lang="en-US" sz="700" dirty="0">
-                <a:solidFill>
-                  <a:srgbClr val="222222"/>
-                </a:solidFill>
-                <a:latin typeface="Arial" pitchFamily="34" charset="0"/>
-                <a:ea typeface="Arial" pitchFamily="34" charset="-122"/>
-                <a:cs typeface="Arial" pitchFamily="34" charset="-120"/>
-              </a:rPr>
-              <a:t>- N1 · CRÍTICO (celda roja C62828): el foco incluye un CAAP o HAP, o involucra un riesgo crítico (izaje, trabajo en altura, energía eléctrica/energías peligrosas, vehículos o equipos móviles).</a:t>
-            </a:r>
-            <a:endParaRPr lang="en-US" sz="700" dirty="0"/>
-          </a:p>
-          <a:p>
-            <a:pPr indent="0" marL="0">
-              <a:buNone/>
-            </a:pPr>
-            <a:r>
-              <a:rPr lang="en-US" sz="700" dirty="0">
-                <a:solidFill>
-                  <a:srgbClr val="222222"/>
-                </a:solidFill>
-                <a:latin typeface="Arial" pitchFamily="34" charset="0"/>
-                <a:ea typeface="Arial" pitchFamily="34" charset="-122"/>
-                <a:cs typeface="Arial" pitchFamily="34" charset="-120"/>
-              </a:rPr>
-              <a:t>- N2 · ALTO (celda naranja E67E22): el resto.</a:t>
-            </a:r>
-            <a:endParaRPr lang="en-US" sz="700" dirty="0"/>
-          </a:p>
-          <a:p>
-            <a:pPr indent="0" marL="0">
-              <a:spcBef>
-                <a:spcPts val="500"/>
-              </a:spcBef>
-              <a:buNone/>
-            </a:pPr>
-            <a:r>
-              <a:rPr lang="en-US" sz="700" b="1" dirty="0">
-                <a:solidFill>
-                  <a:srgbClr val="1F3D6B"/>
-                </a:solidFill>
-                <a:latin typeface="Arial" pitchFamily="34" charset="0"/>
-                <a:ea typeface="Arial" pitchFamily="34" charset="-122"/>
-                <a:cs typeface="Arial" pitchFamily="34" charset="-120"/>
-              </a:rPr>
-              <a:t>4. FOCO DE ASSURANCE</a:t>
-            </a:r>
-            <a:endParaRPr lang="en-US" sz="700" dirty="0"/>
-          </a:p>
-          <a:p>
-            <a:pPr indent="0" marL="0">
-              <a:buNone/>
-            </a:pPr>
-            <a:r>
-              <a:rPr lang="en-US" sz="700" dirty="0">
-                <a:solidFill>
-                  <a:srgbClr val="222222"/>
-                </a:solidFill>
-                <a:latin typeface="Arial" pitchFamily="34" charset="0"/>
-                <a:ea typeface="Arial" pitchFamily="34" charset="-122"/>
-                <a:cs typeface="Arial" pitchFamily="34" charset="-120"/>
-              </a:rPr>
-              <a:t>- Formato: "Tema del foco." en negrita + instrucción que empieza con un verbo ("Verificar…"): qué se revisa, dónde y bajo qué estándar. Máximo unos 350 caracteres.</a:t>
-            </a:r>
-            <a:endParaRPr lang="en-US" sz="700" dirty="0"/>
-          </a:p>
-          <a:p>
-            <a:pPr indent="0" marL="0">
-              <a:buNone/>
-            </a:pPr>
-            <a:r>
-              <a:rPr lang="en-US" sz="700" dirty="0">
-                <a:solidFill>
-                  <a:srgbClr val="222222"/>
-                </a:solidFill>
-                <a:latin typeface="Arial" pitchFamily="34" charset="0"/>
-                <a:ea typeface="Arial" pitchFamily="34" charset="-122"/>
-                <a:cs typeface="Arial" pitchFamily="34" charset="-120"/>
-              </a:rPr>
-              <a:t>- Luego, en línea aparte, "Criterio de restricción:" (en negrita) + la condición en que se prohíbe o se detiene la tarea. Máximo unos 150 caracteres.</a:t>
-            </a:r>
-            <a:endParaRPr lang="en-US" sz="700" dirty="0"/>
-          </a:p>
-          <a:p>
-            <a:pPr indent="0" marL="0">
-              <a:buNone/>
-            </a:pPr>
-            <a:r>
-              <a:rPr lang="en-US" sz="700" dirty="0">
-                <a:solidFill>
-                  <a:srgbClr val="222222"/>
-                </a:solidFill>
-                <a:latin typeface="Arial" pitchFamily="34" charset="0"/>
-                <a:ea typeface="Arial" pitchFamily="34" charset="-122"/>
-                <a:cs typeface="Arial" pitchFamily="34" charset="-120"/>
-              </a:rPr>
-              <a:t>- Redacta a partir de las brechas reales de los eventos. No cites números de estándares o procedimientos que no estén en el Excel.</a:t>
-            </a:r>
-            <a:endParaRPr lang="en-US" sz="700" dirty="0"/>
-          </a:p>
-          <a:p>
-            <a:pPr indent="0" marL="0">
-              <a:spcBef>
-                <a:spcPts val="500"/>
-              </a:spcBef>
-              <a:buNone/>
-            </a:pPr>
-            <a:r>
-              <a:rPr lang="en-US" sz="700" b="1" dirty="0">
-                <a:solidFill>
-                  <a:srgbClr val="1F3D6B"/>
-                </a:solidFill>
-                <a:latin typeface="Arial" pitchFamily="34" charset="0"/>
-                <a:ea typeface="Arial" pitchFamily="34" charset="-122"/>
-                <a:cs typeface="Arial" pitchFamily="34" charset="-120"/>
-              </a:rPr>
-              <a:t>5. EVENTO / EVIDENCIA ORIGEN</a:t>
-            </a:r>
-            <a:endParaRPr lang="en-US" sz="700" dirty="0"/>
-          </a:p>
-          <a:p>
-            <a:pPr indent="0" marL="0">
-              <a:buNone/>
-            </a:pPr>
-            <a:r>
-              <a:rPr lang="en-US" sz="700" dirty="0">
-                <a:solidFill>
-                  <a:srgbClr val="222222"/>
-                </a:solidFill>
-                <a:latin typeface="Arial" pitchFamily="34" charset="0"/>
-                <a:ea typeface="Arial" pitchFamily="34" charset="-122"/>
-                <a:cs typeface="Arial" pitchFamily="34" charset="-120"/>
-              </a:rPr>
-              <a:t>- Formato fijo por evento: "[T1-3] TIPO ID – EECC:" (en negrita) + qué ocurrió, en una frase de hasta 120 caracteres.</a:t>
-            </a:r>
-            <a:endParaRPr lang="en-US" sz="700" dirty="0"/>
-          </a:p>
-          <a:p>
-            <a:pPr indent="0" marL="0">
-              <a:buNone/>
-            </a:pPr>
-            <a:r>
-              <a:rPr lang="en-US" sz="700" dirty="0">
-                <a:solidFill>
-                  <a:srgbClr val="222222"/>
-                </a:solidFill>
-                <a:latin typeface="Arial" pitchFamily="34" charset="0"/>
-                <a:ea typeface="Arial" pitchFamily="34" charset="-122"/>
-                <a:cs typeface="Arial" pitchFamily="34" charset="-120"/>
-              </a:rPr>
-              <a:t>- Máximo 3 eventos por foco; elige los de mayor potencial. Si un evento aparece en ambos turnos, usa [T1-3/T2-4].</a:t>
-            </a:r>
-            <a:endParaRPr lang="en-US" sz="700" dirty="0"/>
-          </a:p>
-          <a:p>
-            <a:pPr indent="0" marL="0">
-              <a:buNone/>
-            </a:pPr>
-            <a:r>
-              <a:rPr lang="en-US" sz="700" dirty="0">
-                <a:solidFill>
-                  <a:srgbClr val="222222"/>
-                </a:solidFill>
-                <a:latin typeface="Arial" pitchFamily="34" charset="0"/>
-                <a:ea typeface="Arial" pitchFamily="34" charset="-122"/>
-                <a:cs typeface="Arial" pitchFamily="34" charset="-120"/>
-              </a:rPr>
-              <a:t>- Para temas recurrentes se permite: "[T1-3] N eventos HBP: descripción del patrón."</a:t>
-            </a:r>
-            <a:endParaRPr lang="en-US" sz="700" dirty="0"/>
-          </a:p>
-          <a:p>
-            <a:pPr indent="0" marL="0">
-              <a:spcBef>
-                <a:spcPts val="500"/>
-              </a:spcBef>
-              <a:buNone/>
-            </a:pPr>
-            <a:r>
-              <a:rPr lang="en-US" sz="700" b="1" dirty="0">
-                <a:solidFill>
-                  <a:srgbClr val="1F3D6B"/>
-                </a:solidFill>
-                <a:latin typeface="Arial" pitchFamily="34" charset="0"/>
-                <a:ea typeface="Arial" pitchFamily="34" charset="-122"/>
-                <a:cs typeface="Arial" pitchFamily="34" charset="-120"/>
-              </a:rPr>
-              <a:t>6. HERRAMIENTA PREVENTIVA SGE</a:t>
-            </a:r>
-            <a:endParaRPr lang="en-US" sz="700" dirty="0"/>
-          </a:p>
-          <a:p>
-            <a:pPr indent="0" marL="0">
-              <a:buNone/>
-            </a:pPr>
-            <a:r>
-              <a:rPr lang="en-US" sz="700" dirty="0">
-                <a:solidFill>
-                  <a:srgbClr val="222222"/>
-                </a:solidFill>
-                <a:latin typeface="Arial" pitchFamily="34" charset="0"/>
-                <a:ea typeface="Arial" pitchFamily="34" charset="-122"/>
-                <a:cs typeface="Arial" pitchFamily="34" charset="-120"/>
-              </a:rPr>
-              <a:t>- Herramientas unidas con "+". Usa las que figuren en el Excel o las ya usadas en este formato: GCC, CdP [tema] (p. ej. CdP Maniobras de Izaje, CdP Trabajos en Altura, CdP Operación de Vehículos Livianos), ASP, PTS, Gestión del Cambio, Desafío en Terreno, Inspección de Plataformas de Andamios, EdC Vehículo Liviano, Inspección de Equipos, Acompañamiento ASP.</a:t>
-            </a:r>
-            <a:endParaRPr lang="en-US" sz="700" dirty="0"/>
-          </a:p>
-          <a:p>
-            <a:pPr indent="0" marL="0">
-              <a:spcBef>
-                <a:spcPts val="500"/>
-              </a:spcBef>
-              <a:buNone/>
-            </a:pPr>
-            <a:r>
-              <a:rPr lang="en-US" sz="700" b="1" dirty="0">
-                <a:solidFill>
-                  <a:srgbClr val="1F3D6B"/>
-                </a:solidFill>
-                <a:latin typeface="Arial" pitchFamily="34" charset="0"/>
-                <a:ea typeface="Arial" pitchFamily="34" charset="-122"/>
-                <a:cs typeface="Arial" pitchFamily="34" charset="-120"/>
-              </a:rPr>
-              <a:t>7. EVIDENCIA / REGISTRO ESPERADO</a:t>
-            </a:r>
-            <a:endParaRPr lang="en-US" sz="700" dirty="0"/>
-          </a:p>
-          <a:p>
-            <a:pPr indent="0" marL="0">
-              <a:buNone/>
-            </a:pPr>
-            <a:r>
-              <a:rPr lang="en-US" sz="700" dirty="0">
-                <a:solidFill>
-                  <a:srgbClr val="222222"/>
-                </a:solidFill>
-                <a:latin typeface="Arial" pitchFamily="34" charset="0"/>
-                <a:ea typeface="Arial" pitchFamily="34" charset="-122"/>
-                <a:cs typeface="Arial" pitchFamily="34" charset="-120"/>
-              </a:rPr>
-              <a:t>- Registros concretos y verificables separados por "/", terminando siempre en "registro fotográfico".</a:t>
-            </a:r>
-            <a:endParaRPr lang="en-US" sz="700" dirty="0"/>
-          </a:p>
-        </p:txBody>
-      </p:sp>
-      <p:sp>
-        <p:nvSpPr>
-          <p:cNvPr id="4" name="Text 2"/>
-          <p:cNvSpPr txBox="1"/>
-          <p:nvPr/>
-        </p:nvSpPr>
-        <p:spPr>
-          <a:xfrm>
-            <a:off x="6190488" y="731520"/>
-            <a:ext cx="5632704" cy="7589520"/>
-          </a:xfrm>
-          <a:prstGeom prst="rect">
-            <a:avLst/>
-          </a:prstGeom>
-          <a:noFill/>
-          <a:ln/>
-        </p:spPr>
-        <p:txBody>
-          <a:bodyPr wrap="square" lIns="0" tIns="0" rIns="0" bIns="0" rtlCol="0" anchor="t"/>
-          <a:lstStyle/>
-          <a:p>
-            <a:pPr indent="0" marL="0">
-              <a:buNone/>
-            </a:pPr>
-            <a:r>
-              <a:rPr lang="en-US" sz="700" b="1" dirty="0">
-                <a:solidFill>
-                  <a:srgbClr val="1F3D6B"/>
-                </a:solidFill>
-                <a:latin typeface="Arial" pitchFamily="34" charset="0"/>
-                <a:ea typeface="Arial" pitchFamily="34" charset="-122"/>
-                <a:cs typeface="Arial" pitchFamily="34" charset="-120"/>
-              </a:rPr>
-              <a:t>8. VERIFICACIÓN EN TERRENO</a:t>
-            </a:r>
-            <a:endParaRPr lang="en-US" sz="700" dirty="0"/>
-          </a:p>
-          <a:p>
-            <a:pPr indent="0" marL="0">
-              <a:buNone/>
-            </a:pPr>
-            <a:r>
-              <a:rPr lang="en-US" sz="700" dirty="0">
-                <a:solidFill>
-                  <a:srgbClr val="222222"/>
-                </a:solidFill>
-                <a:latin typeface="Arial" pitchFamily="34" charset="0"/>
-                <a:ea typeface="Arial" pitchFamily="34" charset="-122"/>
-                <a:cs typeface="Arial" pitchFamily="34" charset="-120"/>
-              </a:rPr>
-              <a:t>- No la modifiques: deja "☐ C ☐ NC ☐ NA / Obs.:" en blanco. La completa el Inspector ITO en terreno.</a:t>
-            </a:r>
-            <a:endParaRPr lang="en-US" sz="700" dirty="0"/>
-          </a:p>
-          <a:p>
-            <a:pPr indent="0" marL="0">
-              <a:spcBef>
-                <a:spcPts val="500"/>
-              </a:spcBef>
-              <a:buNone/>
-            </a:pPr>
-            <a:r>
-              <a:rPr lang="en-US" sz="700" b="1" dirty="0">
-                <a:solidFill>
-                  <a:srgbClr val="1F3D6B"/>
-                </a:solidFill>
-                <a:latin typeface="Arial" pitchFamily="34" charset="0"/>
-                <a:ea typeface="Arial" pitchFamily="34" charset="-122"/>
-                <a:cs typeface="Arial" pitchFamily="34" charset="-120"/>
-              </a:rPr>
-              <a:t>9. RECURRENTE</a:t>
-            </a:r>
-            <a:endParaRPr lang="en-US" sz="700" dirty="0"/>
-          </a:p>
-          <a:p>
-            <a:pPr indent="0" marL="0">
-              <a:buNone/>
-            </a:pPr>
-            <a:r>
-              <a:rPr lang="en-US" sz="700" dirty="0">
-                <a:solidFill>
-                  <a:srgbClr val="222222"/>
-                </a:solidFill>
-                <a:latin typeface="Arial" pitchFamily="34" charset="0"/>
-                <a:ea typeface="Arial" pitchFamily="34" charset="-122"/>
-                <a:cs typeface="Arial" pitchFamily="34" charset="-120"/>
-              </a:rPr>
-              <a:t>- "N eventos HBP — tema (n) · tema (n). Refuerzo transversal en todos los recorridos y al cierre de cada tarea."</a:t>
-            </a:r>
-            <a:endParaRPr lang="en-US" sz="700" dirty="0"/>
-          </a:p>
-          <a:p>
-            <a:pPr indent="0" marL="0">
-              <a:buNone/>
-            </a:pPr>
-            <a:r>
-              <a:rPr lang="en-US" sz="700" dirty="0">
-                <a:solidFill>
-                  <a:srgbClr val="222222"/>
-                </a:solidFill>
-                <a:latin typeface="Arial" pitchFamily="34" charset="0"/>
-                <a:ea typeface="Arial" pitchFamily="34" charset="-122"/>
-                <a:cs typeface="Arial" pitchFamily="34" charset="-120"/>
-              </a:rPr>
-              <a:t>- N = total de HBP del turno y período, incluidos los usados en los focos. Verifica la suma: los subtotales no pueden superar N.</a:t>
-            </a:r>
-            <a:endParaRPr lang="en-US" sz="700" dirty="0"/>
-          </a:p>
-          <a:p>
-            <a:pPr indent="0" marL="0">
-              <a:spcBef>
-                <a:spcPts val="500"/>
-              </a:spcBef>
-              <a:buNone/>
-            </a:pPr>
-            <a:r>
-              <a:rPr lang="en-US" sz="700" b="1" dirty="0">
-                <a:solidFill>
-                  <a:srgbClr val="1F3D6B"/>
-                </a:solidFill>
-                <a:latin typeface="Arial" pitchFamily="34" charset="0"/>
-                <a:ea typeface="Arial" pitchFamily="34" charset="-122"/>
-                <a:cs typeface="Arial" pitchFamily="34" charset="-120"/>
-              </a:rPr>
-              <a:t>10. SÍNTESIS Y RECORRIDOS</a:t>
-            </a:r>
-            <a:endParaRPr lang="en-US" sz="700" dirty="0"/>
-          </a:p>
-          <a:p>
-            <a:pPr indent="0" marL="0">
-              <a:buNone/>
-            </a:pPr>
-            <a:r>
-              <a:rPr lang="en-US" sz="700" dirty="0">
-                <a:solidFill>
-                  <a:srgbClr val="222222"/>
-                </a:solidFill>
-                <a:latin typeface="Arial" pitchFamily="34" charset="0"/>
-                <a:ea typeface="Arial" pitchFamily="34" charset="-122"/>
-                <a:cs typeface="Arial" pitchFamily="34" charset="-120"/>
-              </a:rPr>
-              <a:t>- Bloque AM y Bloque Mediodía: áreas reales tomadas del Excel + 3 o 4 controles, cada uno con el N° de foco entre paréntesis, p. ej. "Plan de izaje específico por maniobra (1)". Asigna al AM los focos de inicio de jornada (izaje, pre-uso de vehículos y equipos) y al Mediodía los de intervención (plataformas, instalaciones eléctricas, orden y aseo).</a:t>
-            </a:r>
-            <a:endParaRPr lang="en-US" sz="700" dirty="0"/>
-          </a:p>
-          <a:p>
-            <a:pPr indent="0" marL="0">
-              <a:buNone/>
-            </a:pPr>
-            <a:r>
-              <a:rPr lang="en-US" sz="700" dirty="0">
-                <a:solidFill>
-                  <a:srgbClr val="222222"/>
-                </a:solidFill>
-                <a:latin typeface="Arial" pitchFamily="34" charset="0"/>
-                <a:ea typeface="Arial" pitchFamily="34" charset="-122"/>
-                <a:cs typeface="Arial" pitchFamily="34" charset="-120"/>
-              </a:rPr>
-              <a:t>- Bloque PM: mantén "Gestión SAP · CdP pendientes · Entrega de turno" y sus líneas fijas. En "Actualizar PTS con brechas de CdP:" indica las brechas que el Excel respalde; si no hay, elimina esa línea.</a:t>
-            </a:r>
-            <a:endParaRPr lang="en-US" sz="700" dirty="0"/>
-          </a:p>
-          <a:p>
-            <a:pPr indent="0" marL="0">
-              <a:buNone/>
-            </a:pPr>
-            <a:r>
-              <a:rPr lang="en-US" sz="700" dirty="0">
-                <a:solidFill>
-                  <a:srgbClr val="222222"/>
-                </a:solidFill>
-                <a:latin typeface="Arial" pitchFamily="34" charset="0"/>
-                <a:ea typeface="Arial" pitchFamily="34" charset="-122"/>
-                <a:cs typeface="Arial" pitchFamily="34" charset="-120"/>
-              </a:rPr>
-              <a:t>- Brechas principales / Controles críticos no negociables / Detener la tarea si…: máximo 5 viñetas de 1 línea (unos 50 caracteres) en cada recuadro, coherentes con los focos. Brechas = lo que falló. Controles = lo que no se negocia. Detener si = condición concreta de detención.</a:t>
-            </a:r>
-            <a:endParaRPr lang="en-US" sz="700" dirty="0"/>
-          </a:p>
-          <a:p>
-            <a:pPr indent="0" marL="0">
-              <a:spcBef>
-                <a:spcPts val="500"/>
-              </a:spcBef>
-              <a:buNone/>
-            </a:pPr>
-            <a:r>
-              <a:rPr lang="en-US" sz="700" b="1" dirty="0">
-                <a:solidFill>
-                  <a:srgbClr val="1F3D6B"/>
-                </a:solidFill>
-                <a:latin typeface="Arial" pitchFamily="34" charset="0"/>
-                <a:ea typeface="Arial" pitchFamily="34" charset="-122"/>
-                <a:cs typeface="Arial" pitchFamily="34" charset="-120"/>
-              </a:rPr>
-              <a:t>11. ENCABEZADO, CIERRE Y FIRMAS</a:t>
-            </a:r>
-            <a:endParaRPr lang="en-US" sz="700" dirty="0"/>
-          </a:p>
-          <a:p>
-            <a:pPr indent="0" marL="0">
-              <a:buNone/>
-            </a:pPr>
-            <a:r>
-              <a:rPr lang="en-US" sz="700" dirty="0">
-                <a:solidFill>
-                  <a:srgbClr val="222222"/>
-                </a:solidFill>
-                <a:latin typeface="Arial" pitchFamily="34" charset="0"/>
-                <a:ea typeface="Arial" pitchFamily="34" charset="-122"/>
-                <a:cs typeface="Arial" pitchFamily="34" charset="-120"/>
-              </a:rPr>
-              <a:t>- Título: "ASSURANCE TURNO 1-3" o "ASSURANCE TURNO 2-4". Fecha/Período: "DD al DD MES". Turno: marca ☒ en el que corresponde.</a:t>
-            </a:r>
-            <a:endParaRPr lang="en-US" sz="700" dirty="0"/>
-          </a:p>
-          <a:p>
-            <a:pPr indent="0" marL="0">
-              <a:buNone/>
-            </a:pPr>
-            <a:r>
-              <a:rPr lang="en-US" sz="700" dirty="0">
-                <a:solidFill>
-                  <a:srgbClr val="222222"/>
-                </a:solidFill>
-                <a:latin typeface="Arial" pitchFamily="34" charset="0"/>
-                <a:ea typeface="Arial" pitchFamily="34" charset="-122"/>
-                <a:cs typeface="Arial" pitchFamily="34" charset="-120"/>
-              </a:rPr>
-              <a:t>- Inspector ITO, Proyecto/EECC y Área/Sector: complétalos solo si el usuario los entrega; si no, deja la línea en blanco.</a:t>
-            </a:r>
-            <a:endParaRPr lang="en-US" sz="700" dirty="0"/>
-          </a:p>
-          <a:p>
-            <a:pPr indent="0" marL="0">
-              <a:buNone/>
-            </a:pPr>
-            <a:r>
-              <a:rPr lang="en-US" sz="700" dirty="0">
-                <a:solidFill>
-                  <a:srgbClr val="222222"/>
-                </a:solidFill>
-                <a:latin typeface="Arial" pitchFamily="34" charset="0"/>
-                <a:ea typeface="Arial" pitchFamily="34" charset="-122"/>
-                <a:cs typeface="Arial" pitchFamily="34" charset="-120"/>
-              </a:rPr>
-              <a:t>- La franja CIERRE y las firmas se dejan en blanco.</a:t>
-            </a:r>
-            <a:endParaRPr lang="en-US" sz="700" dirty="0"/>
-          </a:p>
-          <a:p>
-            <a:pPr indent="0" marL="0">
-              <a:spcBef>
-                <a:spcPts val="500"/>
-              </a:spcBef>
-              <a:buNone/>
-            </a:pPr>
-            <a:r>
-              <a:rPr lang="en-US" sz="700" b="1" dirty="0">
-                <a:solidFill>
-                  <a:srgbClr val="1F3D6B"/>
-                </a:solidFill>
-                <a:latin typeface="Arial" pitchFamily="34" charset="0"/>
-                <a:ea typeface="Arial" pitchFamily="34" charset="-122"/>
-                <a:cs typeface="Arial" pitchFamily="34" charset="-120"/>
-              </a:rPr>
-              <a:t>12. FORMATO (obligatorio)</a:t>
-            </a:r>
-            <a:endParaRPr lang="en-US" sz="700" dirty="0"/>
-          </a:p>
-          <a:p>
-            <a:pPr indent="0" marL="0">
-              <a:buNone/>
-            </a:pPr>
-            <a:r>
-              <a:rPr lang="en-US" sz="700" dirty="0">
-                <a:solidFill>
-                  <a:srgbClr val="222222"/>
-                </a:solidFill>
-                <a:latin typeface="Arial" pitchFamily="34" charset="0"/>
-                <a:ea typeface="Arial" pitchFamily="34" charset="-122"/>
-                <a:cs typeface="Arial" pitchFamily="34" charset="-120"/>
-              </a:rPr>
-              <a:t>- No cambies estructura, columnas, colores, fuentes, íconos ni tamaño de la lámina.</a:t>
-            </a:r>
-            <a:endParaRPr lang="en-US" sz="700" dirty="0"/>
-          </a:p>
-          <a:p>
-            <a:pPr indent="0" marL="0">
-              <a:buNone/>
-            </a:pPr>
-            <a:r>
-              <a:rPr lang="en-US" sz="700" dirty="0">
-                <a:solidFill>
-                  <a:srgbClr val="222222"/>
-                </a:solidFill>
-                <a:latin typeface="Arial" pitchFamily="34" charset="0"/>
-                <a:ea typeface="Arial" pitchFamily="34" charset="-122"/>
-                <a:cs typeface="Arial" pitchFamily="34" charset="-120"/>
-              </a:rPr>
-              <a:t>- Reemplaza todo texto gris entre [corchetes] por contenido real en color de texto normal (negro, sin cursiva). No debe quedar ningún corchete, salvo [DATO FALTANTE] y las marcas de turno [T1-3]/[T2-4].</a:t>
-            </a:r>
-            <a:endParaRPr lang="en-US" sz="700" dirty="0"/>
-          </a:p>
-          <a:p>
-            <a:pPr indent="0" marL="0">
-              <a:buNone/>
-            </a:pPr>
-            <a:r>
-              <a:rPr lang="en-US" sz="700" dirty="0">
-                <a:solidFill>
-                  <a:srgbClr val="222222"/>
-                </a:solidFill>
-                <a:latin typeface="Arial" pitchFamily="34" charset="0"/>
-                <a:ea typeface="Arial" pitchFamily="34" charset="-122"/>
-                <a:cs typeface="Arial" pitchFamily="34" charset="-120"/>
-              </a:rPr>
-              <a:t>- Letra mínima 6 pt. Si el texto no cabe, resume; no reduzcas más la letra ni agrandes filas.</a:t>
-            </a:r>
-            <a:endParaRPr lang="en-US" sz="700" dirty="0"/>
-          </a:p>
-          <a:p>
-            <a:pPr indent="0" marL="0">
-              <a:buNone/>
-            </a:pPr>
-            <a:r>
-              <a:rPr lang="en-US" sz="700" dirty="0">
-                <a:solidFill>
-                  <a:srgbClr val="222222"/>
-                </a:solidFill>
-                <a:latin typeface="Arial" pitchFamily="34" charset="0"/>
-                <a:ea typeface="Arial" pitchFamily="34" charset="-122"/>
-                <a:cs typeface="Arial" pitchFamily="34" charset="-120"/>
-              </a:rPr>
-              <a:t>- Antes de entregar: elimina la lámina 2 (instructivo), la lámina 3 (ejemplo) y esta lámina oculta, y borra las notas del orador de la lámina 1.</a:t>
-            </a:r>
-            <a:endParaRPr lang="en-US" sz="700" dirty="0"/>
-          </a:p>
-          <a:p>
-            <a:pPr indent="0" marL="0">
-              <a:buNone/>
-            </a:pPr>
-            <a:r>
-              <a:rPr lang="en-US" sz="700" dirty="0">
-                <a:solidFill>
-                  <a:srgbClr val="222222"/>
-                </a:solidFill>
-                <a:latin typeface="Arial" pitchFamily="34" charset="0"/>
-                <a:ea typeface="Arial" pitchFamily="34" charset="-122"/>
-                <a:cs typeface="Arial" pitchFamily="34" charset="-120"/>
-              </a:rPr>
-              <a:t>- Nombre del archivo: ASSURANCE_TURNO_[1-3 o 2-4]_[DD-DD]_[MES].pptx (ej.: ASSURANCE_TURNO_1-3_07-20_SEP.pptx).</a:t>
-            </a:r>
-            <a:endParaRPr lang="en-US" sz="700" dirty="0"/>
-          </a:p>
-          <a:p>
-            <a:pPr indent="0" marL="0">
-              <a:spcBef>
-                <a:spcPts val="500"/>
-              </a:spcBef>
-              <a:buNone/>
-            </a:pPr>
-            <a:r>
-              <a:rPr lang="en-US" sz="700" b="1" dirty="0">
-                <a:solidFill>
-                  <a:srgbClr val="1F3D6B"/>
-                </a:solidFill>
-                <a:latin typeface="Arial" pitchFamily="34" charset="0"/>
-                <a:ea typeface="Arial" pitchFamily="34" charset="-122"/>
-                <a:cs typeface="Arial" pitchFamily="34" charset="-120"/>
-              </a:rPr>
-              <a:t>13. ENTREGA</a:t>
-            </a:r>
-            <a:endParaRPr lang="en-US" sz="700" dirty="0"/>
-          </a:p>
-          <a:p>
-            <a:pPr indent="0" marL="0">
-              <a:buNone/>
-            </a:pPr>
-            <a:r>
-              <a:rPr lang="en-US" sz="700" dirty="0">
-                <a:solidFill>
-                  <a:srgbClr val="222222"/>
-                </a:solidFill>
-                <a:latin typeface="Arial" pitchFamily="34" charset="0"/>
-                <a:ea typeface="Arial" pitchFamily="34" charset="-122"/>
-                <a:cs typeface="Arial" pitchFamily="34" charset="-120"/>
-              </a:rPr>
-              <a:t>- Si puedes editar archivos .pptx: entrega el archivo completado.</a:t>
-            </a:r>
-            <a:endParaRPr lang="en-US" sz="700" dirty="0"/>
-          </a:p>
-          <a:p>
-            <a:pPr indent="0" marL="0">
-              <a:buNone/>
-            </a:pPr>
-            <a:r>
-              <a:rPr lang="en-US" sz="700" dirty="0">
-                <a:solidFill>
-                  <a:srgbClr val="222222"/>
-                </a:solidFill>
-                <a:latin typeface="Arial" pitchFamily="34" charset="0"/>
-                <a:ea typeface="Arial" pitchFamily="34" charset="-122"/>
-                <a:cs typeface="Arial" pitchFamily="34" charset="-120"/>
-              </a:rPr>
-              <a:t>- Si no puedes: entrega el contenido en texto, ordenado por sección y por fila de la plantilla (Encabezado; Foco 1 a 6 con sus 5 columnas; Recurrente; Bloques AM/Mediodía/PM; Brechas; Controles; Detener si), listo para copiar y pegar en cada casilla.</a:t>
-            </a:r>
-            <a:endParaRPr lang="en-US" sz="700" dirty="0"/>
-          </a:p>
-          <a:p>
-            <a:pPr indent="0" marL="0">
-              <a:spcBef>
-                <a:spcPts val="500"/>
-              </a:spcBef>
-              <a:buNone/>
-            </a:pPr>
-            <a:r>
-              <a:rPr lang="en-US" sz="700" b="1" dirty="0">
-                <a:solidFill>
-                  <a:srgbClr val="1F3D6B"/>
-                </a:solidFill>
-                <a:latin typeface="Arial" pitchFamily="34" charset="0"/>
-                <a:ea typeface="Arial" pitchFamily="34" charset="-122"/>
-                <a:cs typeface="Arial" pitchFamily="34" charset="-120"/>
-              </a:rPr>
-              <a:t>14. CONTROL DE CALIDAD (en tu respuesta al usuario, no dentro del archivo)</a:t>
-            </a:r>
-            <a:endParaRPr lang="en-US" sz="700" dirty="0"/>
-          </a:p>
-          <a:p>
-            <a:pPr indent="0" marL="0">
-              <a:buNone/>
-            </a:pPr>
-            <a:r>
-              <a:rPr lang="en-US" sz="700" dirty="0">
-                <a:solidFill>
-                  <a:srgbClr val="222222"/>
-                </a:solidFill>
-                <a:latin typeface="Arial" pitchFamily="34" charset="0"/>
-                <a:ea typeface="Arial" pitchFamily="34" charset="-122"/>
-                <a:cs typeface="Arial" pitchFamily="34" charset="-120"/>
-              </a:rPr>
-              <a:t>Al final de tu respuesta incluye un resumen breve con:</a:t>
-            </a:r>
-            <a:endParaRPr lang="en-US" sz="700" dirty="0"/>
-          </a:p>
-          <a:p>
-            <a:pPr indent="0" marL="0">
-              <a:buNone/>
-            </a:pPr>
-            <a:r>
-              <a:rPr lang="en-US" sz="700" dirty="0">
-                <a:solidFill>
-                  <a:srgbClr val="222222"/>
-                </a:solidFill>
-                <a:latin typeface="Arial" pitchFamily="34" charset="0"/>
-                <a:ea typeface="Arial" pitchFamily="34" charset="-122"/>
-                <a:cs typeface="Arial" pitchFamily="34" charset="-120"/>
-              </a:rPr>
-              <a:t>- total de eventos leídos y cuántos de cada tipo;</a:t>
-            </a:r>
-            <a:endParaRPr lang="en-US" sz="700" dirty="0"/>
-          </a:p>
-          <a:p>
-            <a:pPr indent="0" marL="0">
-              <a:buNone/>
-            </a:pPr>
-            <a:r>
-              <a:rPr lang="en-US" sz="700" dirty="0">
-                <a:solidFill>
-                  <a:srgbClr val="222222"/>
-                </a:solidFill>
-                <a:latin typeface="Arial" pitchFamily="34" charset="0"/>
-                <a:ea typeface="Arial" pitchFamily="34" charset="-122"/>
-                <a:cs typeface="Arial" pitchFamily="34" charset="-120"/>
-              </a:rPr>
-              <a:t>- eventos usados en cada foco y los de alto potencial que quedaron fuera, con el motivo;</a:t>
-            </a:r>
-            <a:endParaRPr lang="en-US" sz="700" dirty="0"/>
-          </a:p>
-          <a:p>
-            <a:pPr indent="0" marL="0">
-              <a:buNone/>
-            </a:pPr>
-            <a:r>
-              <a:rPr lang="en-US" sz="700" dirty="0">
-                <a:solidFill>
-                  <a:srgbClr val="222222"/>
-                </a:solidFill>
-                <a:latin typeface="Arial" pitchFamily="34" charset="0"/>
-                <a:ea typeface="Arial" pitchFamily="34" charset="-122"/>
-                <a:cs typeface="Arial" pitchFamily="34" charset="-120"/>
-              </a:rPr>
-              <a:t>- datos faltantes o inconsistentes y supuestos realizados.</a:t>
-            </a:r>
-            <a:endParaRPr lang="en-US" sz="700" dirty="0"/>
-          </a:p>
-          <a:p>
-            <a:pPr indent="0" marL="0">
-              <a:buNone/>
-            </a:pPr>
-            <a:r>
-              <a:rPr lang="en-US" sz="700" dirty="0">
-                <a:solidFill>
-                  <a:srgbClr val="222222"/>
-                </a:solidFill>
-                <a:latin typeface="Arial" pitchFamily="34" charset="0"/>
-                <a:ea typeface="Arial" pitchFamily="34" charset="-122"/>
-                <a:cs typeface="Arial" pitchFamily="34" charset="-120"/>
-              </a:rPr>
-              <a:t>Antes de entregar, confirma que: cada ID existe en el Excel; cada foco tiene al menos un evento de origen; los conteos del Recurrente cuadran; y no quedan textos guía.</a:t>
-            </a:r>
-            <a:endParaRPr lang="en-US" sz="700" dirty="0"/>
-          </a:p>
-        </p:txBody>
-      </p:sp>
-      <p:sp>
-        <p:nvSpPr>
-          <p:cNvPr id="5" name="Shape 3"/>
-          <p:cNvSpPr/>
-          <p:nvPr/>
-        </p:nvSpPr>
-        <p:spPr>
-          <a:xfrm>
-            <a:off x="0" y="8385048"/>
-            <a:ext cx="12191695" cy="347472"/>
-          </a:xfrm>
-          <a:prstGeom prst="rect">
-            <a:avLst/>
-          </a:prstGeom>
-          <a:solidFill>
-            <a:srgbClr val="1F3D6B"/>
-          </a:solidFill>
-          <a:ln w="12700">
-            <a:solidFill>
-              <a:srgbClr val="1F3D6B"/>
-            </a:solidFill>
-            <a:prstDash val="solid"/>
-          </a:ln>
-        </p:spPr>
-      </p:sp>
-      <p:sp>
-        <p:nvSpPr>
-          <p:cNvPr id="6" name="Text 4"/>
-          <p:cNvSpPr txBox="1"/>
-          <p:nvPr/>
-        </p:nvSpPr>
-        <p:spPr>
-          <a:xfrm>
-            <a:off x="365760" y="8385048"/>
-            <a:ext cx="4206240" cy="347472"/>
-          </a:xfrm>
-          <a:prstGeom prst="rect">
-            <a:avLst/>
-          </a:prstGeom>
-          <a:noFill/>
-          <a:ln/>
-        </p:spPr>
-        <p:txBody>
-          <a:bodyPr wrap="square" lIns="0" tIns="0" rIns="0" bIns="0" rtlCol="0" anchor="ctr"/>
-          <a:lstStyle/>
-          <a:p>
-            <a:pPr indent="0" marL="0">
-              <a:buNone/>
-            </a:pPr>
-            <a:r>
-              <a:rPr lang="en-US" sz="950" b="1" dirty="0">
-                <a:solidFill>
-                  <a:srgbClr val="FFFFFF"/>
-                </a:solidFill>
-                <a:latin typeface="Arial" pitchFamily="34" charset="0"/>
-                <a:ea typeface="Arial" pitchFamily="34" charset="-122"/>
-                <a:cs typeface="Arial" pitchFamily="34" charset="-120"/>
-              </a:rPr>
-              <a:t>NUESTRO COMPROMISO: CERO DAÑO A LAS PERSONAS</a:t>
-            </a:r>
-            <a:endParaRPr lang="en-US" sz="950" dirty="0"/>
-          </a:p>
-        </p:txBody>
-      </p:sp>
-      <p:sp>
-        <p:nvSpPr>
-          <p:cNvPr id="7" name="Text 5"/>
-          <p:cNvSpPr txBox="1"/>
-          <p:nvPr/>
-        </p:nvSpPr>
-        <p:spPr>
-          <a:xfrm>
-            <a:off x="4206240" y="8385048"/>
-            <a:ext cx="3840480" cy="347472"/>
-          </a:xfrm>
-          <a:prstGeom prst="rect">
-            <a:avLst/>
-          </a:prstGeom>
-          <a:noFill/>
-          <a:ln/>
-        </p:spPr>
-        <p:txBody>
-          <a:bodyPr wrap="square" lIns="0" tIns="0" rIns="0" bIns="0" rtlCol="0" anchor="ctr"/>
-          <a:lstStyle/>
-          <a:p>
-            <a:pPr algn="ctr" indent="0" marL="0">
-              <a:buNone/>
-            </a:pPr>
-            <a:r>
-              <a:rPr lang="en-US" sz="800" b="1" dirty="0">
-                <a:solidFill>
-                  <a:srgbClr val="E53935"/>
-                </a:solidFill>
-                <a:latin typeface="Arial" pitchFamily="34" charset="0"/>
-                <a:ea typeface="Arial" pitchFamily="34" charset="-122"/>
-                <a:cs typeface="Arial" pitchFamily="34" charset="-120"/>
-              </a:rPr>
-              <a:t>▲▲  </a:t>
-            </a:r>
-            <a:pPr algn="ctr" indent="0" marL="0">
-              <a:buNone/>
-            </a:pPr>
-            <a:r>
-              <a:rPr lang="en-US" sz="800" b="1" dirty="0">
-                <a:solidFill>
-                  <a:srgbClr val="FFFFFF"/>
-                </a:solidFill>
-                <a:latin typeface="Arial" pitchFamily="34" charset="0"/>
-                <a:ea typeface="Arial" pitchFamily="34" charset="-122"/>
-                <a:cs typeface="Arial" pitchFamily="34" charset="-120"/>
-              </a:rPr>
-              <a:t>FORMATO ASSURANCE ITO · v1.0 · INSTRUCCIONES IA</a:t>
-            </a:r>
-            <a:endParaRPr lang="en-US" sz="800" dirty="0"/>
-          </a:p>
-        </p:txBody>
-      </p:sp>
-      <p:sp>
-        <p:nvSpPr>
-          <p:cNvPr id="8" name="Text 6"/>
           <p:cNvSpPr txBox="1"/>
           <p:nvPr/>
         </p:nvSpPr>

</xml_diff>

<commit_message>
Formato Assurance ITO: eliminar columna de verificación en terreno
Co-Authored-By: Claude Opus 5.5 <noreply@anthropic.com>
Claude-Session: https://claude.ai/code/session_017MaLNPnWzNhW9Tdfmjv67V
</commit_message>
<xml_diff>
--- a/FORMATO_ASSURANCE_ITO_v1.0.pptx
+++ b/FORMATO_ASSURANCE_ITO_v1.0.pptx
@@ -1711,35 +1711,7 @@
                 <a:ea typeface="Arial" pitchFamily="34" charset="-122"/>
                 <a:cs typeface="Arial" pitchFamily="34" charset="-120"/>
               </a:rPr>
-              <a:t> turno que lo reportó  ·  </a:t>
-            </a:r>
-            <a:pPr indent="0" marL="0">
-              <a:buNone/>
-            </a:pPr>
-            <a:r>
-              <a:rPr lang="en-US" sz="700" b="1" dirty="0">
-                <a:solidFill>
-                  <a:srgbClr val="222222"/>
-                </a:solidFill>
-                <a:latin typeface="Arial" pitchFamily="34" charset="0"/>
-                <a:ea typeface="Arial" pitchFamily="34" charset="-122"/>
-                <a:cs typeface="Arial" pitchFamily="34" charset="-120"/>
-              </a:rPr>
-              <a:t>Verificación:</a:t>
-            </a:r>
-            <a:pPr indent="0" marL="0">
-              <a:buNone/>
-            </a:pPr>
-            <a:r>
-              <a:rPr lang="en-US" sz="700" dirty="0">
-                <a:solidFill>
-                  <a:srgbClr val="222222"/>
-                </a:solidFill>
-                <a:latin typeface="Arial" pitchFamily="34" charset="0"/>
-                <a:ea typeface="Arial" pitchFamily="34" charset="-122"/>
-                <a:cs typeface="Arial" pitchFamily="34" charset="-120"/>
-              </a:rPr>
-              <a:t> C cumple · NC no cumple · NA no aplica</a:t>
+              <a:t> turno que lo reportó</a:t>
             </a:r>
             <a:endParaRPr lang="en-US" sz="700" dirty="0"/>
           </a:p>
@@ -1769,11 +1741,10 @@
               <a:tblPr/>
               <a:tblGrid>
                 <a:gridCol w="960120"/>
-                <a:gridCol w="3657600"/>
-                <a:gridCol w="2560320"/>
-                <a:gridCol w="1508760"/>
-                <a:gridCol w="1536192"/>
-                <a:gridCol w="1234440"/>
+                <a:gridCol w="4206240"/>
+                <a:gridCol w="2926080"/>
+                <a:gridCol w="1645920"/>
+                <a:gridCol w="1719072"/>
               </a:tblGrid>
               <a:tr h="310896">
                 <a:tc>
@@ -2066,74 +2037,6 @@
                           <a:cs typeface="Arial" pitchFamily="34" charset="-120"/>
                         </a:rPr>
                         <a:t>EVIDENCIA / REGISTRO ESPERADO</a:t>
-                      </a:r>
-                      <a:endParaRPr lang="en-US" sz="680" dirty="0">
-                        <a:latin typeface="Arial" charset="0"/>
-                        <a:ea typeface="Arial" charset="0"/>
-                        <a:cs typeface="Arial" charset="0"/>
-                      </a:endParaRPr>
-                    </a:p>
-                  </a:txBody>
-                  <a:tcPr marL="50800" marR="50800" marT="25400" marB="25400" anchor="ctr">
-                    <a:lnL w="9525" cap="flat" cmpd="sng" algn="ctr">
-                      <a:solidFill>
-                        <a:srgbClr val="C9D3E0"/>
-                      </a:solidFill>
-                      <a:prstDash val="solid"/>
-                      <a:round/>
-                      <a:headEnd type="none" w="med" len="med"/>
-                      <a:tailEnd type="none" w="med" len="med"/>
-                    </a:lnL>
-                    <a:lnR w="9525" cap="flat" cmpd="sng" algn="ctr">
-                      <a:solidFill>
-                        <a:srgbClr val="C9D3E0"/>
-                      </a:solidFill>
-                      <a:prstDash val="solid"/>
-                      <a:round/>
-                      <a:headEnd type="none" w="med" len="med"/>
-                      <a:tailEnd type="none" w="med" len="med"/>
-                    </a:lnR>
-                    <a:lnT w="9525" cap="flat" cmpd="sng" algn="ctr">
-                      <a:solidFill>
-                        <a:srgbClr val="C9D3E0"/>
-                      </a:solidFill>
-                      <a:prstDash val="solid"/>
-                      <a:round/>
-                      <a:headEnd type="none" w="med" len="med"/>
-                      <a:tailEnd type="none" w="med" len="med"/>
-                    </a:lnT>
-                    <a:lnB w="9525" cap="flat" cmpd="sng" algn="ctr">
-                      <a:solidFill>
-                        <a:srgbClr val="C9D3E0"/>
-                      </a:solidFill>
-                      <a:prstDash val="solid"/>
-                      <a:round/>
-                      <a:headEnd type="none" w="med" len="med"/>
-                      <a:tailEnd type="none" w="med" len="med"/>
-                    </a:lnB>
-                    <a:solidFill>
-                      <a:srgbClr val="1F3D6B"/>
-                    </a:solidFill>
-                  </a:tcPr>
-                </a:tc>
-                <a:tc>
-                  <a:txBody>
-                    <a:bodyPr/>
-                    <a:lstStyle/>
-                    <a:p>
-                      <a:pPr algn="ctr" indent="0" marL="0">
-                        <a:buNone/>
-                      </a:pPr>
-                      <a:r>
-                        <a:rPr lang="en-US" sz="680" b="1" dirty="0">
-                          <a:solidFill>
-                            <a:srgbClr val="FFFFFF"/>
-                          </a:solidFill>
-                          <a:latin typeface="Arial" pitchFamily="34" charset="0"/>
-                          <a:ea typeface="Arial" pitchFamily="34" charset="-122"/>
-                          <a:cs typeface="Arial" pitchFamily="34" charset="-120"/>
-                        </a:rPr>
-                        <a:t>VERIFICACIÓN EN TERRENO</a:t>
                       </a:r>
                       <a:endParaRPr lang="en-US" sz="680" dirty="0">
                         <a:latin typeface="Arial" charset="0"/>
@@ -2666,95 +2569,6 @@
                     </a:solidFill>
                   </a:tcPr>
                 </a:tc>
-                <a:tc>
-                  <a:txBody>
-                    <a:bodyPr/>
-                    <a:lstStyle/>
-                    <a:p>
-                      <a:pPr indent="0" marL="0">
-                        <a:buNone/>
-                      </a:pPr>
-                      <a:r>
-                        <a:rPr lang="en-US" sz="700" b="1" dirty="0">
-                          <a:solidFill>
-                            <a:srgbClr val="222222"/>
-                          </a:solidFill>
-                          <a:latin typeface="Arial" pitchFamily="34" charset="0"/>
-                          <a:ea typeface="Arial" pitchFamily="34" charset="-122"/>
-                          <a:cs typeface="Arial" pitchFamily="34" charset="-120"/>
-                        </a:rPr>
-                        <a:t>☐ C   ☐ NC   ☐ NA</a:t>
-                      </a:r>
-                      <a:endParaRPr lang="en-US" sz="700" dirty="0">
-                        <a:latin typeface="Arial" charset="0"/>
-                        <a:ea typeface="Arial" charset="0"/>
-                        <a:cs typeface="Arial" charset="0"/>
-                      </a:endParaRPr>
-                    </a:p>
-                    <a:p>
-                      <a:pPr indent="0" marL="0">
-                        <a:buNone/>
-                      </a:pPr>
-                      <a:r>
-                        <a:rPr lang="en-US" sz="700" dirty="0">
-                          <a:solidFill>
-                            <a:srgbClr val="7A8594"/>
-                          </a:solidFill>
-                          <a:latin typeface="Arial" pitchFamily="34" charset="0"/>
-                          <a:ea typeface="Arial" pitchFamily="34" charset="-122"/>
-                          <a:cs typeface="Arial" pitchFamily="34" charset="-120"/>
-                        </a:rPr>
-                        <a:t>Obs.: ______________</a:t>
-                      </a:r>
-                      <a:endParaRPr lang="en-US" sz="700" dirty="0">
-                        <a:latin typeface="Arial" charset="0"/>
-                        <a:ea typeface="Arial" charset="0"/>
-                        <a:cs typeface="Arial" charset="0"/>
-                      </a:endParaRPr>
-                    </a:p>
-                  </a:txBody>
-                  <a:tcPr marL="50800" marR="50800" marT="25400" marB="25400" anchor="ctr">
-                    <a:lnL w="9525" cap="flat" cmpd="sng" algn="ctr">
-                      <a:solidFill>
-                        <a:srgbClr val="C9D3E0"/>
-                      </a:solidFill>
-                      <a:prstDash val="solid"/>
-                      <a:round/>
-                      <a:headEnd type="none" w="med" len="med"/>
-                      <a:tailEnd type="none" w="med" len="med"/>
-                    </a:lnL>
-                    <a:lnR w="9525" cap="flat" cmpd="sng" algn="ctr">
-                      <a:solidFill>
-                        <a:srgbClr val="C9D3E0"/>
-                      </a:solidFill>
-                      <a:prstDash val="solid"/>
-                      <a:round/>
-                      <a:headEnd type="none" w="med" len="med"/>
-                      <a:tailEnd type="none" w="med" len="med"/>
-                    </a:lnR>
-                    <a:lnT w="9525" cap="flat" cmpd="sng" algn="ctr">
-                      <a:solidFill>
-                        <a:srgbClr val="C9D3E0"/>
-                      </a:solidFill>
-                      <a:prstDash val="solid"/>
-                      <a:round/>
-                      <a:headEnd type="none" w="med" len="med"/>
-                      <a:tailEnd type="none" w="med" len="med"/>
-                    </a:lnT>
-                    <a:lnB w="9525" cap="flat" cmpd="sng" algn="ctr">
-                      <a:solidFill>
-                        <a:srgbClr val="C9D3E0"/>
-                      </a:solidFill>
-                      <a:prstDash val="solid"/>
-                      <a:round/>
-                      <a:headEnd type="none" w="med" len="med"/>
-                      <a:tailEnd type="none" w="med" len="med"/>
-                    </a:lnB>
-                    <a:solidFill>
-                      <a:srgbClr val="FFFFFF"/>
-                    </a:solidFill>
-                  </a:tcPr>
-                </a:tc>
               </a:tr>
               <a:tr h="676656">
                 <a:tc>
@@ -3237,95 +3051,6 @@
                     </a:solidFill>
                   </a:tcPr>
                 </a:tc>
-                <a:tc>
-                  <a:txBody>
-                    <a:bodyPr/>
-                    <a:lstStyle/>
-                    <a:p>
-                      <a:pPr indent="0" marL="0">
-                        <a:buNone/>
-                      </a:pPr>
-                      <a:r>
-                        <a:rPr lang="en-US" sz="700" b="1" dirty="0">
-                          <a:solidFill>
-                            <a:srgbClr val="222222"/>
-                          </a:solidFill>
-                          <a:latin typeface="Arial" pitchFamily="34" charset="0"/>
-                          <a:ea typeface="Arial" pitchFamily="34" charset="-122"/>
-                          <a:cs typeface="Arial" pitchFamily="34" charset="-120"/>
-                        </a:rPr>
-                        <a:t>☐ C   ☐ NC   ☐ NA</a:t>
-                      </a:r>
-                      <a:endParaRPr lang="en-US" sz="700" dirty="0">
-                        <a:latin typeface="Arial" charset="0"/>
-                        <a:ea typeface="Arial" charset="0"/>
-                        <a:cs typeface="Arial" charset="0"/>
-                      </a:endParaRPr>
-                    </a:p>
-                    <a:p>
-                      <a:pPr indent="0" marL="0">
-                        <a:buNone/>
-                      </a:pPr>
-                      <a:r>
-                        <a:rPr lang="en-US" sz="700" dirty="0">
-                          <a:solidFill>
-                            <a:srgbClr val="7A8594"/>
-                          </a:solidFill>
-                          <a:latin typeface="Arial" pitchFamily="34" charset="0"/>
-                          <a:ea typeface="Arial" pitchFamily="34" charset="-122"/>
-                          <a:cs typeface="Arial" pitchFamily="34" charset="-120"/>
-                        </a:rPr>
-                        <a:t>Obs.: ______________</a:t>
-                      </a:r>
-                      <a:endParaRPr lang="en-US" sz="700" dirty="0">
-                        <a:latin typeface="Arial" charset="0"/>
-                        <a:ea typeface="Arial" charset="0"/>
-                        <a:cs typeface="Arial" charset="0"/>
-                      </a:endParaRPr>
-                    </a:p>
-                  </a:txBody>
-                  <a:tcPr marL="50800" marR="50800" marT="25400" marB="25400" anchor="ctr">
-                    <a:lnL w="9525" cap="flat" cmpd="sng" algn="ctr">
-                      <a:solidFill>
-                        <a:srgbClr val="C9D3E0"/>
-                      </a:solidFill>
-                      <a:prstDash val="solid"/>
-                      <a:round/>
-                      <a:headEnd type="none" w="med" len="med"/>
-                      <a:tailEnd type="none" w="med" len="med"/>
-                    </a:lnL>
-                    <a:lnR w="9525" cap="flat" cmpd="sng" algn="ctr">
-                      <a:solidFill>
-                        <a:srgbClr val="C9D3E0"/>
-                      </a:solidFill>
-                      <a:prstDash val="solid"/>
-                      <a:round/>
-                      <a:headEnd type="none" w="med" len="med"/>
-                      <a:tailEnd type="none" w="med" len="med"/>
-                    </a:lnR>
-                    <a:lnT w="9525" cap="flat" cmpd="sng" algn="ctr">
-                      <a:solidFill>
-                        <a:srgbClr val="C9D3E0"/>
-                      </a:solidFill>
-                      <a:prstDash val="solid"/>
-                      <a:round/>
-                      <a:headEnd type="none" w="med" len="med"/>
-                      <a:tailEnd type="none" w="med" len="med"/>
-                    </a:lnT>
-                    <a:lnB w="9525" cap="flat" cmpd="sng" algn="ctr">
-                      <a:solidFill>
-                        <a:srgbClr val="C9D3E0"/>
-                      </a:solidFill>
-                      <a:prstDash val="solid"/>
-                      <a:round/>
-                      <a:headEnd type="none" w="med" len="med"/>
-                      <a:tailEnd type="none" w="med" len="med"/>
-                    </a:lnB>
-                    <a:solidFill>
-                      <a:srgbClr val="F3F6FA"/>
-                    </a:solidFill>
-                  </a:tcPr>
-                </a:tc>
               </a:tr>
               <a:tr h="676656">
                 <a:tc>
@@ -3808,95 +3533,6 @@
                     </a:solidFill>
                   </a:tcPr>
                 </a:tc>
-                <a:tc>
-                  <a:txBody>
-                    <a:bodyPr/>
-                    <a:lstStyle/>
-                    <a:p>
-                      <a:pPr indent="0" marL="0">
-                        <a:buNone/>
-                      </a:pPr>
-                      <a:r>
-                        <a:rPr lang="en-US" sz="700" b="1" dirty="0">
-                          <a:solidFill>
-                            <a:srgbClr val="222222"/>
-                          </a:solidFill>
-                          <a:latin typeface="Arial" pitchFamily="34" charset="0"/>
-                          <a:ea typeface="Arial" pitchFamily="34" charset="-122"/>
-                          <a:cs typeface="Arial" pitchFamily="34" charset="-120"/>
-                        </a:rPr>
-                        <a:t>☐ C   ☐ NC   ☐ NA</a:t>
-                      </a:r>
-                      <a:endParaRPr lang="en-US" sz="700" dirty="0">
-                        <a:latin typeface="Arial" charset="0"/>
-                        <a:ea typeface="Arial" charset="0"/>
-                        <a:cs typeface="Arial" charset="0"/>
-                      </a:endParaRPr>
-                    </a:p>
-                    <a:p>
-                      <a:pPr indent="0" marL="0">
-                        <a:buNone/>
-                      </a:pPr>
-                      <a:r>
-                        <a:rPr lang="en-US" sz="700" dirty="0">
-                          <a:solidFill>
-                            <a:srgbClr val="7A8594"/>
-                          </a:solidFill>
-                          <a:latin typeface="Arial" pitchFamily="34" charset="0"/>
-                          <a:ea typeface="Arial" pitchFamily="34" charset="-122"/>
-                          <a:cs typeface="Arial" pitchFamily="34" charset="-120"/>
-                        </a:rPr>
-                        <a:t>Obs.: ______________</a:t>
-                      </a:r>
-                      <a:endParaRPr lang="en-US" sz="700" dirty="0">
-                        <a:latin typeface="Arial" charset="0"/>
-                        <a:ea typeface="Arial" charset="0"/>
-                        <a:cs typeface="Arial" charset="0"/>
-                      </a:endParaRPr>
-                    </a:p>
-                  </a:txBody>
-                  <a:tcPr marL="50800" marR="50800" marT="25400" marB="25400" anchor="ctr">
-                    <a:lnL w="9525" cap="flat" cmpd="sng" algn="ctr">
-                      <a:solidFill>
-                        <a:srgbClr val="C9D3E0"/>
-                      </a:solidFill>
-                      <a:prstDash val="solid"/>
-                      <a:round/>
-                      <a:headEnd type="none" w="med" len="med"/>
-                      <a:tailEnd type="none" w="med" len="med"/>
-                    </a:lnL>
-                    <a:lnR w="9525" cap="flat" cmpd="sng" algn="ctr">
-                      <a:solidFill>
-                        <a:srgbClr val="C9D3E0"/>
-                      </a:solidFill>
-                      <a:prstDash val="solid"/>
-                      <a:round/>
-                      <a:headEnd type="none" w="med" len="med"/>
-                      <a:tailEnd type="none" w="med" len="med"/>
-                    </a:lnR>
-                    <a:lnT w="9525" cap="flat" cmpd="sng" algn="ctr">
-                      <a:solidFill>
-                        <a:srgbClr val="C9D3E0"/>
-                      </a:solidFill>
-                      <a:prstDash val="solid"/>
-                      <a:round/>
-                      <a:headEnd type="none" w="med" len="med"/>
-                      <a:tailEnd type="none" w="med" len="med"/>
-                    </a:lnT>
-                    <a:lnB w="9525" cap="flat" cmpd="sng" algn="ctr">
-                      <a:solidFill>
-                        <a:srgbClr val="C9D3E0"/>
-                      </a:solidFill>
-                      <a:prstDash val="solid"/>
-                      <a:round/>
-                      <a:headEnd type="none" w="med" len="med"/>
-                      <a:tailEnd type="none" w="med" len="med"/>
-                    </a:lnB>
-                    <a:solidFill>
-                      <a:srgbClr val="FFFFFF"/>
-                    </a:solidFill>
-                  </a:tcPr>
-                </a:tc>
               </a:tr>
               <a:tr h="676656">
                 <a:tc>
@@ -4379,95 +4015,6 @@
                     </a:solidFill>
                   </a:tcPr>
                 </a:tc>
-                <a:tc>
-                  <a:txBody>
-                    <a:bodyPr/>
-                    <a:lstStyle/>
-                    <a:p>
-                      <a:pPr indent="0" marL="0">
-                        <a:buNone/>
-                      </a:pPr>
-                      <a:r>
-                        <a:rPr lang="en-US" sz="700" b="1" dirty="0">
-                          <a:solidFill>
-                            <a:srgbClr val="222222"/>
-                          </a:solidFill>
-                          <a:latin typeface="Arial" pitchFamily="34" charset="0"/>
-                          <a:ea typeface="Arial" pitchFamily="34" charset="-122"/>
-                          <a:cs typeface="Arial" pitchFamily="34" charset="-120"/>
-                        </a:rPr>
-                        <a:t>☐ C   ☐ NC   ☐ NA</a:t>
-                      </a:r>
-                      <a:endParaRPr lang="en-US" sz="700" dirty="0">
-                        <a:latin typeface="Arial" charset="0"/>
-                        <a:ea typeface="Arial" charset="0"/>
-                        <a:cs typeface="Arial" charset="0"/>
-                      </a:endParaRPr>
-                    </a:p>
-                    <a:p>
-                      <a:pPr indent="0" marL="0">
-                        <a:buNone/>
-                      </a:pPr>
-                      <a:r>
-                        <a:rPr lang="en-US" sz="700" dirty="0">
-                          <a:solidFill>
-                            <a:srgbClr val="7A8594"/>
-                          </a:solidFill>
-                          <a:latin typeface="Arial" pitchFamily="34" charset="0"/>
-                          <a:ea typeface="Arial" pitchFamily="34" charset="-122"/>
-                          <a:cs typeface="Arial" pitchFamily="34" charset="-120"/>
-                        </a:rPr>
-                        <a:t>Obs.: ______________</a:t>
-                      </a:r>
-                      <a:endParaRPr lang="en-US" sz="700" dirty="0">
-                        <a:latin typeface="Arial" charset="0"/>
-                        <a:ea typeface="Arial" charset="0"/>
-                        <a:cs typeface="Arial" charset="0"/>
-                      </a:endParaRPr>
-                    </a:p>
-                  </a:txBody>
-                  <a:tcPr marL="50800" marR="50800" marT="25400" marB="25400" anchor="ctr">
-                    <a:lnL w="9525" cap="flat" cmpd="sng" algn="ctr">
-                      <a:solidFill>
-                        <a:srgbClr val="C9D3E0"/>
-                      </a:solidFill>
-                      <a:prstDash val="solid"/>
-                      <a:round/>
-                      <a:headEnd type="none" w="med" len="med"/>
-                      <a:tailEnd type="none" w="med" len="med"/>
-                    </a:lnL>
-                    <a:lnR w="9525" cap="flat" cmpd="sng" algn="ctr">
-                      <a:solidFill>
-                        <a:srgbClr val="C9D3E0"/>
-                      </a:solidFill>
-                      <a:prstDash val="solid"/>
-                      <a:round/>
-                      <a:headEnd type="none" w="med" len="med"/>
-                      <a:tailEnd type="none" w="med" len="med"/>
-                    </a:lnR>
-                    <a:lnT w="9525" cap="flat" cmpd="sng" algn="ctr">
-                      <a:solidFill>
-                        <a:srgbClr val="C9D3E0"/>
-                      </a:solidFill>
-                      <a:prstDash val="solid"/>
-                      <a:round/>
-                      <a:headEnd type="none" w="med" len="med"/>
-                      <a:tailEnd type="none" w="med" len="med"/>
-                    </a:lnT>
-                    <a:lnB w="9525" cap="flat" cmpd="sng" algn="ctr">
-                      <a:solidFill>
-                        <a:srgbClr val="C9D3E0"/>
-                      </a:solidFill>
-                      <a:prstDash val="solid"/>
-                      <a:round/>
-                      <a:headEnd type="none" w="med" len="med"/>
-                      <a:tailEnd type="none" w="med" len="med"/>
-                    </a:lnB>
-                    <a:solidFill>
-                      <a:srgbClr val="F3F6FA"/>
-                    </a:solidFill>
-                  </a:tcPr>
-                </a:tc>
               </a:tr>
               <a:tr h="676656">
                 <a:tc>
@@ -4950,95 +4497,6 @@
                     </a:solidFill>
                   </a:tcPr>
                 </a:tc>
-                <a:tc>
-                  <a:txBody>
-                    <a:bodyPr/>
-                    <a:lstStyle/>
-                    <a:p>
-                      <a:pPr indent="0" marL="0">
-                        <a:buNone/>
-                      </a:pPr>
-                      <a:r>
-                        <a:rPr lang="en-US" sz="700" b="1" dirty="0">
-                          <a:solidFill>
-                            <a:srgbClr val="222222"/>
-                          </a:solidFill>
-                          <a:latin typeface="Arial" pitchFamily="34" charset="0"/>
-                          <a:ea typeface="Arial" pitchFamily="34" charset="-122"/>
-                          <a:cs typeface="Arial" pitchFamily="34" charset="-120"/>
-                        </a:rPr>
-                        <a:t>☐ C   ☐ NC   ☐ NA</a:t>
-                      </a:r>
-                      <a:endParaRPr lang="en-US" sz="700" dirty="0">
-                        <a:latin typeface="Arial" charset="0"/>
-                        <a:ea typeface="Arial" charset="0"/>
-                        <a:cs typeface="Arial" charset="0"/>
-                      </a:endParaRPr>
-                    </a:p>
-                    <a:p>
-                      <a:pPr indent="0" marL="0">
-                        <a:buNone/>
-                      </a:pPr>
-                      <a:r>
-                        <a:rPr lang="en-US" sz="700" dirty="0">
-                          <a:solidFill>
-                            <a:srgbClr val="7A8594"/>
-                          </a:solidFill>
-                          <a:latin typeface="Arial" pitchFamily="34" charset="0"/>
-                          <a:ea typeface="Arial" pitchFamily="34" charset="-122"/>
-                          <a:cs typeface="Arial" pitchFamily="34" charset="-120"/>
-                        </a:rPr>
-                        <a:t>Obs.: ______________</a:t>
-                      </a:r>
-                      <a:endParaRPr lang="en-US" sz="700" dirty="0">
-                        <a:latin typeface="Arial" charset="0"/>
-                        <a:ea typeface="Arial" charset="0"/>
-                        <a:cs typeface="Arial" charset="0"/>
-                      </a:endParaRPr>
-                    </a:p>
-                  </a:txBody>
-                  <a:tcPr marL="50800" marR="50800" marT="25400" marB="25400" anchor="ctr">
-                    <a:lnL w="9525" cap="flat" cmpd="sng" algn="ctr">
-                      <a:solidFill>
-                        <a:srgbClr val="C9D3E0"/>
-                      </a:solidFill>
-                      <a:prstDash val="solid"/>
-                      <a:round/>
-                      <a:headEnd type="none" w="med" len="med"/>
-                      <a:tailEnd type="none" w="med" len="med"/>
-                    </a:lnL>
-                    <a:lnR w="9525" cap="flat" cmpd="sng" algn="ctr">
-                      <a:solidFill>
-                        <a:srgbClr val="C9D3E0"/>
-                      </a:solidFill>
-                      <a:prstDash val="solid"/>
-                      <a:round/>
-                      <a:headEnd type="none" w="med" len="med"/>
-                      <a:tailEnd type="none" w="med" len="med"/>
-                    </a:lnR>
-                    <a:lnT w="9525" cap="flat" cmpd="sng" algn="ctr">
-                      <a:solidFill>
-                        <a:srgbClr val="C9D3E0"/>
-                      </a:solidFill>
-                      <a:prstDash val="solid"/>
-                      <a:round/>
-                      <a:headEnd type="none" w="med" len="med"/>
-                      <a:tailEnd type="none" w="med" len="med"/>
-                    </a:lnT>
-                    <a:lnB w="9525" cap="flat" cmpd="sng" algn="ctr">
-                      <a:solidFill>
-                        <a:srgbClr val="C9D3E0"/>
-                      </a:solidFill>
-                      <a:prstDash val="solid"/>
-                      <a:round/>
-                      <a:headEnd type="none" w="med" len="med"/>
-                      <a:tailEnd type="none" w="med" len="med"/>
-                    </a:lnB>
-                    <a:solidFill>
-                      <a:srgbClr val="FFFFFF"/>
-                    </a:solidFill>
-                  </a:tcPr>
-                </a:tc>
               </a:tr>
               <a:tr h="676656">
                 <a:tc>
@@ -5521,95 +4979,6 @@
                     </a:solidFill>
                   </a:tcPr>
                 </a:tc>
-                <a:tc>
-                  <a:txBody>
-                    <a:bodyPr/>
-                    <a:lstStyle/>
-                    <a:p>
-                      <a:pPr indent="0" marL="0">
-                        <a:buNone/>
-                      </a:pPr>
-                      <a:r>
-                        <a:rPr lang="en-US" sz="700" b="1" dirty="0">
-                          <a:solidFill>
-                            <a:srgbClr val="222222"/>
-                          </a:solidFill>
-                          <a:latin typeface="Arial" pitchFamily="34" charset="0"/>
-                          <a:ea typeface="Arial" pitchFamily="34" charset="-122"/>
-                          <a:cs typeface="Arial" pitchFamily="34" charset="-120"/>
-                        </a:rPr>
-                        <a:t>☐ C   ☐ NC   ☐ NA</a:t>
-                      </a:r>
-                      <a:endParaRPr lang="en-US" sz="700" dirty="0">
-                        <a:latin typeface="Arial" charset="0"/>
-                        <a:ea typeface="Arial" charset="0"/>
-                        <a:cs typeface="Arial" charset="0"/>
-                      </a:endParaRPr>
-                    </a:p>
-                    <a:p>
-                      <a:pPr indent="0" marL="0">
-                        <a:buNone/>
-                      </a:pPr>
-                      <a:r>
-                        <a:rPr lang="en-US" sz="700" dirty="0">
-                          <a:solidFill>
-                            <a:srgbClr val="7A8594"/>
-                          </a:solidFill>
-                          <a:latin typeface="Arial" pitchFamily="34" charset="0"/>
-                          <a:ea typeface="Arial" pitchFamily="34" charset="-122"/>
-                          <a:cs typeface="Arial" pitchFamily="34" charset="-120"/>
-                        </a:rPr>
-                        <a:t>Obs.: ______________</a:t>
-                      </a:r>
-                      <a:endParaRPr lang="en-US" sz="700" dirty="0">
-                        <a:latin typeface="Arial" charset="0"/>
-                        <a:ea typeface="Arial" charset="0"/>
-                        <a:cs typeface="Arial" charset="0"/>
-                      </a:endParaRPr>
-                    </a:p>
-                  </a:txBody>
-                  <a:tcPr marL="50800" marR="50800" marT="25400" marB="25400" anchor="ctr">
-                    <a:lnL w="9525" cap="flat" cmpd="sng" algn="ctr">
-                      <a:solidFill>
-                        <a:srgbClr val="C9D3E0"/>
-                      </a:solidFill>
-                      <a:prstDash val="solid"/>
-                      <a:round/>
-                      <a:headEnd type="none" w="med" len="med"/>
-                      <a:tailEnd type="none" w="med" len="med"/>
-                    </a:lnL>
-                    <a:lnR w="9525" cap="flat" cmpd="sng" algn="ctr">
-                      <a:solidFill>
-                        <a:srgbClr val="C9D3E0"/>
-                      </a:solidFill>
-                      <a:prstDash val="solid"/>
-                      <a:round/>
-                      <a:headEnd type="none" w="med" len="med"/>
-                      <a:tailEnd type="none" w="med" len="med"/>
-                    </a:lnR>
-                    <a:lnT w="9525" cap="flat" cmpd="sng" algn="ctr">
-                      <a:solidFill>
-                        <a:srgbClr val="C9D3E0"/>
-                      </a:solidFill>
-                      <a:prstDash val="solid"/>
-                      <a:round/>
-                      <a:headEnd type="none" w="med" len="med"/>
-                      <a:tailEnd type="none" w="med" len="med"/>
-                    </a:lnT>
-                    <a:lnB w="9525" cap="flat" cmpd="sng" algn="ctr">
-                      <a:solidFill>
-                        <a:srgbClr val="C9D3E0"/>
-                      </a:solidFill>
-                      <a:prstDash val="solid"/>
-                      <a:round/>
-                      <a:headEnd type="none" w="med" len="med"/>
-                      <a:tailEnd type="none" w="med" len="med"/>
-                    </a:lnB>
-                    <a:solidFill>
-                      <a:srgbClr val="F3F6FA"/>
-                    </a:solidFill>
-                  </a:tcPr>
-                </a:tc>
               </a:tr>
             </a:tbl>
           </a:graphicData>
@@ -7051,7 +6420,7 @@
                 <a:ea typeface="Arial" pitchFamily="34" charset="-122"/>
                 <a:cs typeface="Arial" pitchFamily="34" charset="-120"/>
               </a:rPr>
-              <a:t>Focos verificados ____ / ____   ·   % cumplimiento ______   ·   Tareas detenidas ____   ·   Hallazgos a SAP ____</a:t>
+              <a:t>Focos verificados ____ / ____   ·   Tareas detenidas ____   ·   Hallazgos a SAP ____</a:t>
             </a:r>
             <a:endParaRPr lang="en-US" sz="750" dirty="0"/>
           </a:p>
@@ -7908,7 +7277,7 @@
                 <a:ea typeface="Arial" pitchFamily="34" charset="-122"/>
                 <a:cs typeface="Arial" pitchFamily="34" charset="-120"/>
               </a:rPr>
-              <a:t>8. VERIFICACIÓN EN TERRENO</a:t>
+              <a:t>8. RECURRENTE</a:t>
             </a:r>
             <a:endParaRPr lang="en-US" sz="600" dirty="0"/>
           </a:p>
@@ -7925,7 +7294,7 @@
                 <a:ea typeface="Arial" pitchFamily="34" charset="-122"/>
                 <a:cs typeface="Arial" pitchFamily="34" charset="-120"/>
               </a:rPr>
-              <a:t>- No la modifiques: deja "☐ C ☐ NC ☐ NA / Obs.:" en blanco. La completa el Inspector ITO en terreno.</a:t>
+              <a:t>- "N eventos HBP — tema (n) · tema (n). Refuerzo transversal en todos los recorridos y al cierre de cada tarea."</a:t>
             </a:r>
             <a:endParaRPr lang="en-US" sz="600" dirty="0"/>
           </a:p>
@@ -7933,12 +7302,29 @@
             <a:pPr indent="0" marL="0">
               <a:buNone/>
             </a:pPr>
+            <a:r>
+              <a:rPr lang="en-US" sz="600" dirty="0">
+                <a:solidFill>
+                  <a:srgbClr val="222222"/>
+                </a:solidFill>
+                <a:latin typeface="Arial" pitchFamily="34" charset="0"/>
+                <a:ea typeface="Arial" pitchFamily="34" charset="-122"/>
+                <a:cs typeface="Arial" pitchFamily="34" charset="-120"/>
+              </a:rPr>
+              <a:t>- N = total de HBP del turno y período, incluidos los usados en los focos. Verifica la suma: los subtotales no pueden superar N.</a:t>
+            </a:r>
             <a:endParaRPr lang="en-US" sz="600" dirty="0"/>
           </a:p>
           <a:p>
             <a:pPr indent="0" marL="0">
               <a:buNone/>
             </a:pPr>
+            <a:endParaRPr lang="en-US" sz="600" dirty="0"/>
+          </a:p>
+          <a:p>
+            <a:pPr indent="0" marL="0">
+              <a:buNone/>
+            </a:pPr>
             <a:r>
               <a:rPr lang="en-US" sz="600" dirty="0">
                 <a:solidFill>
@@ -7948,7 +7334,7 @@
                 <a:ea typeface="Arial" pitchFamily="34" charset="-122"/>
                 <a:cs typeface="Arial" pitchFamily="34" charset="-120"/>
               </a:rPr>
-              <a:t>9. RECURRENTE</a:t>
+              <a:t>9. SÍNTESIS Y RECORRIDOS</a:t>
             </a:r>
             <a:endParaRPr lang="en-US" sz="600" dirty="0"/>
           </a:p>
@@ -7965,7 +7351,7 @@
                 <a:ea typeface="Arial" pitchFamily="34" charset="-122"/>
                 <a:cs typeface="Arial" pitchFamily="34" charset="-120"/>
               </a:rPr>
-              <a:t>- "N eventos HBP — tema (n) · tema (n). Refuerzo transversal en todos los recorridos y al cierre de cada tarea."</a:t>
+              <a:t>- Bloque AM y Bloque Mediodía: áreas reales tomadas del Excel + 3 o 4 controles, cada uno con el N° de foco entre paréntesis, p. ej. "Plan de izaje específico por maniobra (1)". Asigna al AM los focos de inicio de jornada (izaje, pre-uso de vehículos y equipos) y al Mediodía los de intervención (plataformas, instalaciones eléctricas, orden y aseo).</a:t>
             </a:r>
             <a:endParaRPr lang="en-US" sz="600" dirty="0"/>
           </a:p>
@@ -7982,7 +7368,7 @@
                 <a:ea typeface="Arial" pitchFamily="34" charset="-122"/>
                 <a:cs typeface="Arial" pitchFamily="34" charset="-120"/>
               </a:rPr>
-              <a:t>- N = total de HBP del turno y período, incluidos los usados en los focos. Verifica la suma: los subtotales no pueden superar N.</a:t>
+              <a:t>- Bloque PM: mantén "Gestión SAP · CdP pendientes · Entrega de turno" y sus líneas fijas. En "Actualizar PTS con brechas de CdP:" indica las brechas que el Excel respalde; si no hay, elimina esa línea.</a:t>
             </a:r>
             <a:endParaRPr lang="en-US" sz="600" dirty="0"/>
           </a:p>
@@ -7990,12 +7376,29 @@
             <a:pPr indent="0" marL="0">
               <a:buNone/>
             </a:pPr>
+            <a:r>
+              <a:rPr lang="en-US" sz="600" dirty="0">
+                <a:solidFill>
+                  <a:srgbClr val="222222"/>
+                </a:solidFill>
+                <a:latin typeface="Arial" pitchFamily="34" charset="0"/>
+                <a:ea typeface="Arial" pitchFamily="34" charset="-122"/>
+                <a:cs typeface="Arial" pitchFamily="34" charset="-120"/>
+              </a:rPr>
+              <a:t>- Brechas principales / Controles críticos no negociables / Detener la tarea si…: máximo 5 viñetas de 1 línea (unos 50 caracteres) en cada recuadro, coherentes con los focos. Brechas = lo que falló. Controles = lo que no se negocia. Detener si = condición concreta de detención.</a:t>
+            </a:r>
             <a:endParaRPr lang="en-US" sz="600" dirty="0"/>
           </a:p>
           <a:p>
             <a:pPr indent="0" marL="0">
               <a:buNone/>
             </a:pPr>
+            <a:endParaRPr lang="en-US" sz="600" dirty="0"/>
+          </a:p>
+          <a:p>
+            <a:pPr indent="0" marL="0">
+              <a:buNone/>
+            </a:pPr>
             <a:r>
               <a:rPr lang="en-US" sz="600" dirty="0">
                 <a:solidFill>
@@ -8005,7 +7408,7 @@
                 <a:ea typeface="Arial" pitchFamily="34" charset="-122"/>
                 <a:cs typeface="Arial" pitchFamily="34" charset="-120"/>
               </a:rPr>
-              <a:t>10. SÍNTESIS Y RECORRIDOS</a:t>
+              <a:t>10. ENCABEZADO, CIERRE Y FIRMAS</a:t>
             </a:r>
             <a:endParaRPr lang="en-US" sz="600" dirty="0"/>
           </a:p>
@@ -8022,7 +7425,7 @@
                 <a:ea typeface="Arial" pitchFamily="34" charset="-122"/>
                 <a:cs typeface="Arial" pitchFamily="34" charset="-120"/>
               </a:rPr>
-              <a:t>- Bloque AM y Bloque Mediodía: áreas reales tomadas del Excel + 3 o 4 controles, cada uno con el N° de foco entre paréntesis, p. ej. "Plan de izaje específico por maniobra (1)". Asigna al AM los focos de inicio de jornada (izaje, pre-uso de vehículos y equipos) y al Mediodía los de intervención (plataformas, instalaciones eléctricas, orden y aseo).</a:t>
+              <a:t>- Título: "ASSURANCE TURNO 1-3" o "ASSURANCE TURNO 2-4". Fecha/Período: "DD al DD MES". Turno: marca ☒ en el que corresponde.</a:t>
             </a:r>
             <a:endParaRPr lang="en-US" sz="600" dirty="0"/>
           </a:p>
@@ -8039,7 +7442,7 @@
                 <a:ea typeface="Arial" pitchFamily="34" charset="-122"/>
                 <a:cs typeface="Arial" pitchFamily="34" charset="-120"/>
               </a:rPr>
-              <a:t>- Bloque PM: mantén "Gestión SAP · CdP pendientes · Entrega de turno" y sus líneas fijas. En "Actualizar PTS con brechas de CdP:" indica las brechas que el Excel respalde; si no hay, elimina esa línea.</a:t>
+              <a:t>- Inspector ITO, Proyecto/EECC y Área/Sector: complétalos solo si el usuario los entrega; si no, deja la línea en blanco.</a:t>
             </a:r>
             <a:endParaRPr lang="en-US" sz="600" dirty="0"/>
           </a:p>
@@ -8056,7 +7459,7 @@
                 <a:ea typeface="Arial" pitchFamily="34" charset="-122"/>
                 <a:cs typeface="Arial" pitchFamily="34" charset="-120"/>
               </a:rPr>
-              <a:t>- Brechas principales / Controles críticos no negociables / Detener la tarea si…: máximo 5 viñetas de 1 línea (unos 50 caracteres) en cada recuadro, coherentes con los focos. Brechas = lo que falló. Controles = lo que no se negocia. Detener si = condición concreta de detención.</a:t>
+              <a:t>- La franja CIERRE y las firmas se dejan en blanco.</a:t>
             </a:r>
             <a:endParaRPr lang="en-US" sz="600" dirty="0"/>
           </a:p>
@@ -8079,7 +7482,7 @@
                 <a:ea typeface="Arial" pitchFamily="34" charset="-122"/>
                 <a:cs typeface="Arial" pitchFamily="34" charset="-120"/>
               </a:rPr>
-              <a:t>11. ENCABEZADO, CIERRE Y FIRMAS</a:t>
+              <a:t>11. FORMATO (obligatorio)</a:t>
             </a:r>
             <a:endParaRPr lang="en-US" sz="600" dirty="0"/>
           </a:p>
@@ -8096,7 +7499,7 @@
                 <a:ea typeface="Arial" pitchFamily="34" charset="-122"/>
                 <a:cs typeface="Arial" pitchFamily="34" charset="-120"/>
               </a:rPr>
-              <a:t>- Título: "ASSURANCE TURNO 1-3" o "ASSURANCE TURNO 2-4". Fecha/Período: "DD al DD MES". Turno: marca ☒ en el que corresponde.</a:t>
+              <a:t>- No cambies estructura, columnas, colores, fuentes, íconos ni tamaño de la lámina.</a:t>
             </a:r>
             <a:endParaRPr lang="en-US" sz="600" dirty="0"/>
           </a:p>
@@ -8113,7 +7516,7 @@
                 <a:ea typeface="Arial" pitchFamily="34" charset="-122"/>
                 <a:cs typeface="Arial" pitchFamily="34" charset="-120"/>
               </a:rPr>
-              <a:t>- Inspector ITO, Proyecto/EECC y Área/Sector: complétalos solo si el usuario los entrega; si no, deja la línea en blanco.</a:t>
+              <a:t>- Reemplaza todo texto gris entre [corchetes] por contenido real en color de texto normal (negro, sin cursiva). No debe quedar ningún corchete, salvo [DATO FALTANTE] y las marcas de turno [T1-3]/[T2-4].</a:t>
             </a:r>
             <a:endParaRPr lang="en-US" sz="600" dirty="0"/>
           </a:p>
@@ -8130,7 +7533,7 @@
                 <a:ea typeface="Arial" pitchFamily="34" charset="-122"/>
                 <a:cs typeface="Arial" pitchFamily="34" charset="-120"/>
               </a:rPr>
-              <a:t>- La franja CIERRE y las firmas se dejan en blanco.</a:t>
+              <a:t>- Letra mínima 6 pt. Si el texto no cabe, resume; no reduzcas más la letra ni agrandes filas.</a:t>
             </a:r>
             <a:endParaRPr lang="en-US" sz="600" dirty="0"/>
           </a:p>
@@ -8138,6 +7541,17 @@
             <a:pPr indent="0" marL="0">
               <a:buNone/>
             </a:pPr>
+            <a:r>
+              <a:rPr lang="en-US" sz="600" dirty="0">
+                <a:solidFill>
+                  <a:srgbClr val="222222"/>
+                </a:solidFill>
+                <a:latin typeface="Arial" pitchFamily="34" charset="0"/>
+                <a:ea typeface="Arial" pitchFamily="34" charset="-122"/>
+                <a:cs typeface="Arial" pitchFamily="34" charset="-120"/>
+              </a:rPr>
+              <a:t>- Antes de entregar: elimina la lámina 2 (instructivo). No modifiques ni muevas el cuadro de texto oculto "Instrucciones IA" de la lámina 1.</a:t>
+            </a:r>
             <a:endParaRPr lang="en-US" sz="600" dirty="0"/>
           </a:p>
           <a:p>
@@ -8153,7 +7567,7 @@
                 <a:ea typeface="Arial" pitchFamily="34" charset="-122"/>
                 <a:cs typeface="Arial" pitchFamily="34" charset="-120"/>
               </a:rPr>
-              <a:t>12. FORMATO (obligatorio)</a:t>
+              <a:t>- Nombre del archivo: ASSURANCE_TURNO_[1-3 o 2-4]_[DD-DD]_[MES].pptx (ej.: ASSURANCE_TURNO_1-3_07-20_SEP.pptx).</a:t>
             </a:r>
             <a:endParaRPr lang="en-US" sz="600" dirty="0"/>
           </a:p>
@@ -8161,6 +7575,12 @@
             <a:pPr indent="0" marL="0">
               <a:buNone/>
             </a:pPr>
+            <a:endParaRPr lang="en-US" sz="600" dirty="0"/>
+          </a:p>
+          <a:p>
+            <a:pPr indent="0" marL="0">
+              <a:buNone/>
+            </a:pPr>
             <a:r>
               <a:rPr lang="en-US" sz="600" dirty="0">
                 <a:solidFill>
@@ -8170,7 +7590,7 @@
                 <a:ea typeface="Arial" pitchFamily="34" charset="-122"/>
                 <a:cs typeface="Arial" pitchFamily="34" charset="-120"/>
               </a:rPr>
-              <a:t>- No cambies estructura, columnas, colores, fuentes, íconos ni tamaño de la lámina.</a:t>
+              <a:t>12. ENTREGA</a:t>
             </a:r>
             <a:endParaRPr lang="en-US" sz="600" dirty="0"/>
           </a:p>
@@ -8187,7 +7607,7 @@
                 <a:ea typeface="Arial" pitchFamily="34" charset="-122"/>
                 <a:cs typeface="Arial" pitchFamily="34" charset="-120"/>
               </a:rPr>
-              <a:t>- Reemplaza todo texto gris entre [corchetes] por contenido real en color de texto normal (negro, sin cursiva). No debe quedar ningún corchete, salvo [DATO FALTANTE] y las marcas de turno [T1-3]/[T2-4].</a:t>
+              <a:t>- Si puedes editar archivos .pptx: entrega el archivo completado.</a:t>
             </a:r>
             <a:endParaRPr lang="en-US" sz="600" dirty="0"/>
           </a:p>
@@ -8204,7 +7624,7 @@
                 <a:ea typeface="Arial" pitchFamily="34" charset="-122"/>
                 <a:cs typeface="Arial" pitchFamily="34" charset="-120"/>
               </a:rPr>
-              <a:t>- Letra mínima 6 pt. Si el texto no cabe, resume; no reduzcas más la letra ni agrandes filas.</a:t>
+              <a:t>- Si no puedes: entrega el contenido en texto, ordenado por sección y por fila de la plantilla (Encabezado; Foco 1 a 6 con sus 5 columnas; Recurrente; Bloques AM/Mediodía/PM; Brechas; Controles; Detener si), listo para copiar y pegar en cada casilla.</a:t>
             </a:r>
             <a:endParaRPr lang="en-US" sz="600" dirty="0"/>
           </a:p>
@@ -8212,6 +7632,12 @@
             <a:pPr indent="0" marL="0">
               <a:buNone/>
             </a:pPr>
+            <a:endParaRPr lang="en-US" sz="600" dirty="0"/>
+          </a:p>
+          <a:p>
+            <a:pPr indent="0" marL="0">
+              <a:buNone/>
+            </a:pPr>
             <a:r>
               <a:rPr lang="en-US" sz="600" dirty="0">
                 <a:solidFill>
@@ -8221,104 +7647,7 @@
                 <a:ea typeface="Arial" pitchFamily="34" charset="-122"/>
                 <a:cs typeface="Arial" pitchFamily="34" charset="-120"/>
               </a:rPr>
-              <a:t>- Antes de entregar: elimina la lámina 2 (instructivo). No modifiques ni muevas el cuadro de texto oculto "Instrucciones IA" de la lámina 1.</a:t>
-            </a:r>
-            <a:endParaRPr lang="en-US" sz="600" dirty="0"/>
-          </a:p>
-          <a:p>
-            <a:pPr indent="0" marL="0">
-              <a:buNone/>
-            </a:pPr>
-            <a:r>
-              <a:rPr lang="en-US" sz="600" dirty="0">
-                <a:solidFill>
-                  <a:srgbClr val="222222"/>
-                </a:solidFill>
-                <a:latin typeface="Arial" pitchFamily="34" charset="0"/>
-                <a:ea typeface="Arial" pitchFamily="34" charset="-122"/>
-                <a:cs typeface="Arial" pitchFamily="34" charset="-120"/>
-              </a:rPr>
-              <a:t>- Nombre del archivo: ASSURANCE_TURNO_[1-3 o 2-4]_[DD-DD]_[MES].pptx (ej.: ASSURANCE_TURNO_1-3_07-20_SEP.pptx).</a:t>
-            </a:r>
-            <a:endParaRPr lang="en-US" sz="600" dirty="0"/>
-          </a:p>
-          <a:p>
-            <a:pPr indent="0" marL="0">
-              <a:buNone/>
-            </a:pPr>
-            <a:endParaRPr lang="en-US" sz="600" dirty="0"/>
-          </a:p>
-          <a:p>
-            <a:pPr indent="0" marL="0">
-              <a:buNone/>
-            </a:pPr>
-            <a:r>
-              <a:rPr lang="en-US" sz="600" dirty="0">
-                <a:solidFill>
-                  <a:srgbClr val="222222"/>
-                </a:solidFill>
-                <a:latin typeface="Arial" pitchFamily="34" charset="0"/>
-                <a:ea typeface="Arial" pitchFamily="34" charset="-122"/>
-                <a:cs typeface="Arial" pitchFamily="34" charset="-120"/>
-              </a:rPr>
-              <a:t>13. ENTREGA</a:t>
-            </a:r>
-            <a:endParaRPr lang="en-US" sz="600" dirty="0"/>
-          </a:p>
-          <a:p>
-            <a:pPr indent="0" marL="0">
-              <a:buNone/>
-            </a:pPr>
-            <a:r>
-              <a:rPr lang="en-US" sz="600" dirty="0">
-                <a:solidFill>
-                  <a:srgbClr val="222222"/>
-                </a:solidFill>
-                <a:latin typeface="Arial" pitchFamily="34" charset="0"/>
-                <a:ea typeface="Arial" pitchFamily="34" charset="-122"/>
-                <a:cs typeface="Arial" pitchFamily="34" charset="-120"/>
-              </a:rPr>
-              <a:t>- Si puedes editar archivos .pptx: entrega el archivo completado.</a:t>
-            </a:r>
-            <a:endParaRPr lang="en-US" sz="600" dirty="0"/>
-          </a:p>
-          <a:p>
-            <a:pPr indent="0" marL="0">
-              <a:buNone/>
-            </a:pPr>
-            <a:r>
-              <a:rPr lang="en-US" sz="600" dirty="0">
-                <a:solidFill>
-                  <a:srgbClr val="222222"/>
-                </a:solidFill>
-                <a:latin typeface="Arial" pitchFamily="34" charset="0"/>
-                <a:ea typeface="Arial" pitchFamily="34" charset="-122"/>
-                <a:cs typeface="Arial" pitchFamily="34" charset="-120"/>
-              </a:rPr>
-              <a:t>- Si no puedes: entrega el contenido en texto, ordenado por sección y por fila de la plantilla (Encabezado; Foco 1 a 6 con sus 5 columnas; Recurrente; Bloques AM/Mediodía/PM; Brechas; Controles; Detener si), listo para copiar y pegar en cada casilla.</a:t>
-            </a:r>
-            <a:endParaRPr lang="en-US" sz="600" dirty="0"/>
-          </a:p>
-          <a:p>
-            <a:pPr indent="0" marL="0">
-              <a:buNone/>
-            </a:pPr>
-            <a:endParaRPr lang="en-US" sz="600" dirty="0"/>
-          </a:p>
-          <a:p>
-            <a:pPr indent="0" marL="0">
-              <a:buNone/>
-            </a:pPr>
-            <a:r>
-              <a:rPr lang="en-US" sz="600" dirty="0">
-                <a:solidFill>
-                  <a:srgbClr val="222222"/>
-                </a:solidFill>
-                <a:latin typeface="Arial" pitchFamily="34" charset="0"/>
-                <a:ea typeface="Arial" pitchFamily="34" charset="-122"/>
-                <a:cs typeface="Arial" pitchFamily="34" charset="-120"/>
-              </a:rPr>
-              <a:t>14. CONTROL DE CALIDAD (en tu respuesta al usuario, no dentro del archivo)</a:t>
+              <a:t>13. CONTROL DE CALIDAD (en tu respuesta al usuario, no dentro del archivo)</a:t>
             </a:r>
             <a:endParaRPr lang="en-US" sz="600" dirty="0"/>
           </a:p>
@@ -9918,7 +9247,7 @@
                 <a:ea typeface="Arial" pitchFamily="34" charset="-122"/>
                 <a:cs typeface="Arial" pitchFamily="34" charset="-120"/>
               </a:rPr>
-              <a:t>VERIFICACIÓN EN TERRENO</a:t>
+              <a:t>RECURRENTE</a:t>
             </a:r>
             <a:endParaRPr lang="en-US" sz="1050" dirty="0"/>
           </a:p>
@@ -9957,7 +9286,24 @@
                 <a:ea typeface="Arial" pitchFamily="34" charset="-122"/>
                 <a:cs typeface="Arial" pitchFamily="34" charset="-120"/>
               </a:rPr>
-              <a:t>Se deja en blanco al preparar el formato. El Inspector ITO marca en terreno C (cumple), NC (no cumple) o NA (no aplica); si es NC, anota la observación.</a:t>
+              <a:t>Total de eventos HBP del período y los temas más repetidos con su cantidad.</a:t>
+            </a:r>
+            <a:endParaRPr lang="en-US" sz="930" dirty="0"/>
+          </a:p>
+          <a:p>
+            <a:pPr indent="0" marL="0">
+              <a:buNone/>
+            </a:pPr>
+            <a:r>
+              <a:rPr lang="en-US" sz="930" dirty="0">
+                <a:solidFill>
+                  <a:srgbClr val="222222"/>
+                </a:solidFill>
+                <a:latin typeface="Arial" pitchFamily="34" charset="0"/>
+                <a:ea typeface="Arial" pitchFamily="34" charset="-122"/>
+                <a:cs typeface="Arial" pitchFamily="34" charset="-120"/>
+              </a:rPr>
+              <a:t>Ej.: 7 eventos HBP — acopio deficiente (4) · extensiones sin pasacable (3).</a:t>
             </a:r>
             <a:endParaRPr lang="en-US" sz="930" dirty="0"/>
           </a:p>
@@ -10087,7 +9433,7 @@
                 <a:ea typeface="Arial" pitchFamily="34" charset="-122"/>
                 <a:cs typeface="Arial" pitchFamily="34" charset="-120"/>
               </a:rPr>
-              <a:t>RECURRENTE</a:t>
+              <a:t>RECORRIDOS AM · MEDIODÍA · PM</a:t>
             </a:r>
             <a:endParaRPr lang="en-US" sz="1050" dirty="0"/>
           </a:p>
@@ -10126,24 +9472,7 @@
                 <a:ea typeface="Arial" pitchFamily="34" charset="-122"/>
                 <a:cs typeface="Arial" pitchFamily="34" charset="-120"/>
               </a:rPr>
-              <a:t>Total de eventos HBP del período y los temas más repetidos con su cantidad.</a:t>
-            </a:r>
-            <a:endParaRPr lang="en-US" sz="930" dirty="0"/>
-          </a:p>
-          <a:p>
-            <a:pPr indent="0" marL="0">
-              <a:buNone/>
-            </a:pPr>
-            <a:r>
-              <a:rPr lang="en-US" sz="930" dirty="0">
-                <a:solidFill>
-                  <a:srgbClr val="222222"/>
-                </a:solidFill>
-                <a:latin typeface="Arial" pitchFamily="34" charset="0"/>
-                <a:ea typeface="Arial" pitchFamily="34" charset="-122"/>
-                <a:cs typeface="Arial" pitchFamily="34" charset="-120"/>
-              </a:rPr>
-              <a:t>Ej.: 7 eventos HBP — acopio deficiente (4) · extensiones sin pasacable (3).</a:t>
+              <a:t>Por bloque: áreas a recorrer y 3–4 controles con el N° de foco entre paréntesis. El bloque PM se reserva para gestión SAP, CdP pendientes, actualización de PTS y entrega de turno.</a:t>
             </a:r>
             <a:endParaRPr lang="en-US" sz="930" dirty="0"/>
           </a:p>
@@ -10158,7 +9487,7 @@
         <p:spPr>
           <a:xfrm>
             <a:off x="365760" y="5413248"/>
-            <a:ext cx="3749040" cy="1298448"/>
+            <a:ext cx="5676138" cy="1298448"/>
           </a:xfrm>
           <a:prstGeom prst="roundRect">
             <a:avLst>
@@ -10249,7 +9578,7 @@
         <p:spPr>
           <a:xfrm>
             <a:off x="932688" y="5532120"/>
-            <a:ext cx="3063240" cy="329184"/>
+            <a:ext cx="4990338" cy="329184"/>
           </a:xfrm>
           <a:prstGeom prst="rect">
             <a:avLst/>
@@ -10273,7 +9602,7 @@
                 <a:ea typeface="Arial" pitchFamily="34" charset="-122"/>
                 <a:cs typeface="Arial" pitchFamily="34" charset="-120"/>
               </a:rPr>
-              <a:t>RECORRIDOS AM · MEDIODÍA · PM</a:t>
+              <a:t>BRECHAS · CONTROLES · DETENER SI</a:t>
             </a:r>
             <a:endParaRPr lang="en-US" sz="1050" dirty="0"/>
           </a:p>
@@ -10288,7 +9617,7 @@
         <p:spPr>
           <a:xfrm>
             <a:off x="530352" y="5943600"/>
-            <a:ext cx="3447288" cy="713232"/>
+            <a:ext cx="5374386" cy="713232"/>
           </a:xfrm>
           <a:prstGeom prst="rect">
             <a:avLst/>
@@ -10312,7 +9641,7 @@
                 <a:ea typeface="Arial" pitchFamily="34" charset="-122"/>
                 <a:cs typeface="Arial" pitchFamily="34" charset="-120"/>
               </a:rPr>
-              <a:t>Por bloque: áreas a recorrer y 3–4 controles con el N° de foco entre paréntesis. El bloque PM se reserva para gestión SAP, CdP pendientes, actualización de PTS y entrega de turno.</a:t>
+              <a:t>Máx. 5 viñetas de 1 línea por recuadro. Brechas = lo que falló. Controles = lo que no se negocia. Detener si = condición concreta de detención.</a:t>
             </a:r>
             <a:endParaRPr lang="en-US" sz="930" dirty="0"/>
           </a:p>
@@ -10326,8 +9655,8 @@
         </p:nvSpPr>
         <p:spPr>
           <a:xfrm>
-            <a:off x="4219956" y="5413248"/>
-            <a:ext cx="3749040" cy="1298448"/>
+            <a:off x="6147054" y="5413248"/>
+            <a:ext cx="5676138" cy="1298448"/>
           </a:xfrm>
           <a:prstGeom prst="roundRect">
             <a:avLst>
@@ -10353,7 +9682,7 @@
         </p:nvSpPr>
         <p:spPr>
           <a:xfrm>
-            <a:off x="4357116" y="5532120"/>
+            <a:off x="6284214" y="5532120"/>
             <a:ext cx="329184" cy="329184"/>
           </a:xfrm>
           <a:prstGeom prst="ellipse">
@@ -10378,7 +9707,7 @@
         </p:nvSpPr>
         <p:spPr>
           <a:xfrm>
-            <a:off x="4357116" y="5532120"/>
+            <a:off x="6284214" y="5532120"/>
             <a:ext cx="329184" cy="329184"/>
           </a:xfrm>
           <a:prstGeom prst="rect">
@@ -10417,8 +9746,8 @@
         </p:nvSpPr>
         <p:spPr>
           <a:xfrm>
-            <a:off x="4786884" y="5532120"/>
-            <a:ext cx="3063240" cy="329184"/>
+            <a:off x="6713982" y="5532120"/>
+            <a:ext cx="4990338" cy="329184"/>
           </a:xfrm>
           <a:prstGeom prst="rect">
             <a:avLst/>
@@ -10442,7 +9771,7 @@
                 <a:ea typeface="Arial" pitchFamily="34" charset="-122"/>
                 <a:cs typeface="Arial" pitchFamily="34" charset="-120"/>
               </a:rPr>
-              <a:t>BRECHAS · CONTROLES · DETENER SI</a:t>
+              <a:t>CIERRE Y FIRMAS</a:t>
             </a:r>
             <a:endParaRPr lang="en-US" sz="1050" dirty="0"/>
           </a:p>
@@ -10456,8 +9785,8 @@
         </p:nvSpPr>
         <p:spPr>
           <a:xfrm>
-            <a:off x="4384548" y="5943600"/>
-            <a:ext cx="3447288" cy="713232"/>
+            <a:off x="6311646" y="5943600"/>
+            <a:ext cx="5374386" cy="713232"/>
           </a:xfrm>
           <a:prstGeom prst="rect">
             <a:avLst/>
@@ -10481,7 +9810,7 @@
                 <a:ea typeface="Arial" pitchFamily="34" charset="-122"/>
                 <a:cs typeface="Arial" pitchFamily="34" charset="-120"/>
               </a:rPr>
-              <a:t>Máx. 5 viñetas de 1 línea por recuadro. Brechas = lo que falló. Controles = lo que no se negocia. Detener si = condición concreta de detención.</a:t>
+              <a:t>Lo completa el Inspector ITO al terminar el turno: focos verificados, tareas detenidas y hallazgos subidos a SAP. Firman ITO y Supervisor EECC.</a:t>
             </a:r>
             <a:endParaRPr lang="en-US" sz="930" dirty="0"/>
           </a:p>
@@ -10495,20 +9824,20 @@
         </p:nvSpPr>
         <p:spPr>
           <a:xfrm>
-            <a:off x="8074152" y="5413248"/>
-            <a:ext cx="3749040" cy="1298448"/>
+            <a:off x="365760" y="6839712"/>
+            <a:ext cx="11457432" cy="1435608"/>
           </a:xfrm>
           <a:prstGeom prst="roundRect">
             <a:avLst>
-              <a:gd name="adj" fmla="val 4225"/>
+              <a:gd name="adj" fmla="val 3822"/>
             </a:avLst>
           </a:prstGeom>
           <a:solidFill>
-            <a:srgbClr val="F3F6FA"/>
+            <a:srgbClr val="FDF1F1"/>
           </a:solidFill>
-          <a:ln w="9525">
+          <a:ln w="12700">
             <a:solidFill>
-              <a:srgbClr val="C9D3E0"/>
+              <a:srgbClr val="C62828"/>
             </a:solidFill>
             <a:prstDash val="solid"/>
           </a:ln>
@@ -10516,16 +9845,182 @@
       </p:sp>
       <p:sp>
         <p:nvSpPr>
-          <p:cNvPr id="61" name="Shape 58"/>
+          <p:cNvPr id="61" name="Text 58"/>
+          <p:cNvSpPr txBox="1"/>
+          <p:nvPr/>
+        </p:nvSpPr>
+        <p:spPr>
+          <a:xfrm>
+            <a:off x="548640" y="6912864"/>
+            <a:ext cx="2743200" cy="274320"/>
+          </a:xfrm>
+          <a:prstGeom prst="rect">
+            <a:avLst/>
+          </a:prstGeom>
+          <a:noFill/>
+          <a:ln/>
+        </p:spPr>
+        <p:txBody>
+          <a:bodyPr wrap="square" lIns="0" tIns="0" rIns="0" bIns="0" rtlCol="0" anchor="ctr"/>
+          <a:lstStyle/>
+          <a:p>
+            <a:pPr indent="0" marL="0">
+              <a:buNone/>
+            </a:pPr>
+            <a:r>
+              <a:rPr lang="en-US" sz="1050" b="1" dirty="0">
+                <a:solidFill>
+                  <a:srgbClr val="C62828"/>
+                </a:solidFill>
+                <a:latin typeface="Arial" pitchFamily="34" charset="0"/>
+                <a:ea typeface="Arial" pitchFamily="34" charset="-122"/>
+                <a:cs typeface="Arial" pitchFamily="34" charset="-120"/>
+              </a:rPr>
+              <a:t>REGLAS GENERALES</a:t>
+            </a:r>
+            <a:endParaRPr lang="en-US" sz="1050" dirty="0"/>
+          </a:p>
+        </p:txBody>
+      </p:sp>
+      <p:sp>
+        <p:nvSpPr>
+          <p:cNvPr id="62" name="Text 59"/>
+          <p:cNvSpPr txBox="1"/>
+          <p:nvPr/>
+        </p:nvSpPr>
+        <p:spPr>
+          <a:xfrm>
+            <a:off x="548640" y="7223760"/>
+            <a:ext cx="11064240" cy="978408"/>
+          </a:xfrm>
+          <a:prstGeom prst="rect">
+            <a:avLst/>
+          </a:prstGeom>
+          <a:noFill/>
+          <a:ln/>
+        </p:spPr>
+        <p:txBody>
+          <a:bodyPr wrap="square" lIns="0" tIns="0" rIns="0" bIns="0" rtlCol="0" anchor="t"/>
+          <a:lstStyle/>
+          <a:p>
+            <a:pPr marL="152400" indent="-152400">
+              <a:spcAft>
+                <a:spcPts val="200"/>
+              </a:spcAft>
+              <a:buSzPct val="100000"/>
+              <a:buChar char="•"/>
+            </a:pPr>
+            <a:r>
+              <a:rPr lang="en-US" sz="930" dirty="0">
+                <a:solidFill>
+                  <a:srgbClr val="222222"/>
+                </a:solidFill>
+                <a:latin typeface="Arial" pitchFamily="34" charset="0"/>
+                <a:ea typeface="Arial" pitchFamily="34" charset="-122"/>
+                <a:cs typeface="Arial" pitchFamily="34" charset="-120"/>
+              </a:rPr>
+              <a:t>No modificar columnas, colores, orden de secciones ni tamaño de la lámina.</a:t>
+            </a:r>
+            <a:endParaRPr lang="en-US" sz="930" dirty="0"/>
+          </a:p>
+          <a:p>
+            <a:pPr marL="152400" indent="-152400">
+              <a:spcAft>
+                <a:spcPts val="200"/>
+              </a:spcAft>
+              <a:buSzPct val="100000"/>
+              <a:buChar char="•"/>
+            </a:pPr>
+            <a:r>
+              <a:rPr lang="en-US" sz="930" dirty="0">
+                <a:solidFill>
+                  <a:srgbClr val="222222"/>
+                </a:solidFill>
+                <a:latin typeface="Arial" pitchFamily="34" charset="0"/>
+                <a:ea typeface="Arial" pitchFamily="34" charset="-122"/>
+                <a:cs typeface="Arial" pitchFamily="34" charset="-120"/>
+              </a:rPr>
+              <a:t>Reemplazar todo texto gris entre [corchetes]; el formato publicado no debe tener corchetes ni texto gris.</a:t>
+            </a:r>
+            <a:endParaRPr lang="en-US" sz="930" dirty="0"/>
+          </a:p>
+          <a:p>
+            <a:pPr marL="152400" indent="-152400">
+              <a:spcAft>
+                <a:spcPts val="200"/>
+              </a:spcAft>
+              <a:buSzPct val="100000"/>
+              <a:buChar char="•"/>
+            </a:pPr>
+            <a:r>
+              <a:rPr lang="en-US" sz="930" dirty="0">
+                <a:solidFill>
+                  <a:srgbClr val="222222"/>
+                </a:solidFill>
+                <a:latin typeface="Arial" pitchFamily="34" charset="0"/>
+                <a:ea typeface="Arial" pitchFamily="34" charset="-122"/>
+                <a:cs typeface="Arial" pitchFamily="34" charset="-120"/>
+              </a:rPr>
+              <a:t>Si el texto no cabe, resumir: letra mínima 6 pt. Si hay menos de 6 focos, eliminar la fila sobrante (clic derecho › Eliminar fila).</a:t>
+            </a:r>
+            <a:endParaRPr lang="en-US" sz="930" dirty="0"/>
+          </a:p>
+          <a:p>
+            <a:pPr marL="152400" indent="-152400">
+              <a:spcAft>
+                <a:spcPts val="200"/>
+              </a:spcAft>
+              <a:buSzPct val="100000"/>
+              <a:buChar char="•"/>
+            </a:pPr>
+            <a:r>
+              <a:rPr lang="en-US" sz="930" dirty="0">
+                <a:solidFill>
+                  <a:srgbClr val="222222"/>
+                </a:solidFill>
+                <a:latin typeface="Arial" pitchFamily="34" charset="0"/>
+                <a:ea typeface="Arial" pitchFamily="34" charset="-122"/>
+                <a:cs typeface="Arial" pitchFamily="34" charset="-120"/>
+              </a:rPr>
+              <a:t>Nombre de archivo: ASSURANCE_TURNO_[1-3 ó 2-4]_[DD-DD]_[MES].pptx  (ej.: ASSURANCE_TURNO_1-3_07-20_SEP.pptx).</a:t>
+            </a:r>
+            <a:endParaRPr lang="en-US" sz="930" dirty="0"/>
+          </a:p>
+          <a:p>
+            <a:pPr marL="152400" indent="-152400">
+              <a:spcAft>
+                <a:spcPts val="200"/>
+              </a:spcAft>
+              <a:buSzPct val="100000"/>
+              <a:buChar char="•"/>
+            </a:pPr>
+            <a:r>
+              <a:rPr lang="en-US" sz="930" dirty="0">
+                <a:solidFill>
+                  <a:srgbClr val="222222"/>
+                </a:solidFill>
+                <a:latin typeface="Arial" pitchFamily="34" charset="0"/>
+                <a:ea typeface="Arial" pitchFamily="34" charset="-122"/>
+                <a:cs typeface="Arial" pitchFamily="34" charset="-120"/>
+              </a:rPr>
+              <a:t>Para publicar: dejar solo la lámina PLANTILLA completada y eliminar este instructivo.</a:t>
+            </a:r>
+            <a:endParaRPr lang="en-US" sz="930" dirty="0"/>
+          </a:p>
+        </p:txBody>
+      </p:sp>
+      <p:sp>
+        <p:nvSpPr>
+          <p:cNvPr id="63" name="Shape 60"/>
           <p:cNvSpPr/>
           <p:nvPr/>
         </p:nvSpPr>
         <p:spPr>
           <a:xfrm>
-            <a:off x="8211312" y="5532120"/>
-            <a:ext cx="329184" cy="329184"/>
-          </a:xfrm>
-          <a:prstGeom prst="ellipse">
+            <a:off x="0" y="8385048"/>
+            <a:ext cx="12191695" cy="347472"/>
+          </a:xfrm>
+          <a:prstGeom prst="rect">
             <a:avLst/>
           </a:prstGeom>
           <a:solidFill>
@@ -10541,14 +10036,14 @@
       </p:sp>
       <p:sp>
         <p:nvSpPr>
-          <p:cNvPr id="62" name="Text 59"/>
+          <p:cNvPr id="64" name="Text 61"/>
           <p:cNvSpPr txBox="1"/>
           <p:nvPr/>
         </p:nvSpPr>
         <p:spPr>
           <a:xfrm>
-            <a:off x="8211312" y="5532120"/>
-            <a:ext cx="329184" cy="329184"/>
+            <a:off x="365760" y="8385048"/>
+            <a:ext cx="4206240" cy="347472"/>
           </a:xfrm>
           <a:prstGeom prst="rect">
             <a:avLst/>
@@ -10560,11 +10055,11 @@
           <a:bodyPr wrap="square" lIns="0" tIns="0" rIns="0" bIns="0" rtlCol="0" anchor="ctr"/>
           <a:lstStyle/>
           <a:p>
-            <a:pPr algn="ctr" indent="0" marL="0">
-              <a:buNone/>
-            </a:pPr>
-            <a:r>
-              <a:rPr lang="en-US" sz="1100" b="1" dirty="0">
+            <a:pPr indent="0" marL="0">
+              <a:buNone/>
+            </a:pPr>
+            <a:r>
+              <a:rPr lang="en-US" sz="950" b="1" dirty="0">
                 <a:solidFill>
                   <a:srgbClr val="FFFFFF"/>
                 </a:solidFill>
@@ -10572,22 +10067,22 @@
                 <a:ea typeface="Arial" pitchFamily="34" charset="-122"/>
                 <a:cs typeface="Arial" pitchFamily="34" charset="-120"/>
               </a:rPr>
-              <a:t>12</a:t>
-            </a:r>
-            <a:endParaRPr lang="en-US" sz="1100" dirty="0"/>
+              <a:t>NUESTRO COMPROMISO: CERO DAÑO A LAS PERSONAS</a:t>
+            </a:r>
+            <a:endParaRPr lang="en-US" sz="950" dirty="0"/>
           </a:p>
         </p:txBody>
       </p:sp>
       <p:sp>
         <p:nvSpPr>
-          <p:cNvPr id="63" name="Text 60"/>
+          <p:cNvPr id="65" name="Text 62"/>
           <p:cNvSpPr txBox="1"/>
           <p:nvPr/>
         </p:nvSpPr>
         <p:spPr>
           <a:xfrm>
-            <a:off x="8641080" y="5532120"/>
-            <a:ext cx="3063240" cy="329184"/>
+            <a:off x="4206240" y="8385048"/>
+            <a:ext cx="3840480" cy="347472"/>
           </a:xfrm>
           <a:prstGeom prst="rect">
             <a:avLst/>
@@ -10599,376 +10094,41 @@
           <a:bodyPr wrap="square" lIns="0" tIns="0" rIns="0" bIns="0" rtlCol="0" anchor="ctr"/>
           <a:lstStyle/>
           <a:p>
-            <a:pPr indent="0" marL="0">
-              <a:buNone/>
-            </a:pPr>
-            <a:r>
-              <a:rPr lang="en-US" sz="1050" b="1" dirty="0">
-                <a:solidFill>
-                  <a:srgbClr val="1F3D6B"/>
-                </a:solidFill>
-                <a:latin typeface="Arial" pitchFamily="34" charset="0"/>
-                <a:ea typeface="Arial" pitchFamily="34" charset="-122"/>
-                <a:cs typeface="Arial" pitchFamily="34" charset="-120"/>
-              </a:rPr>
-              <a:t>CIERRE Y FIRMAS</a:t>
-            </a:r>
-            <a:endParaRPr lang="en-US" sz="1050" dirty="0"/>
+            <a:pPr algn="ctr" indent="0" marL="0">
+              <a:buNone/>
+            </a:pPr>
+            <a:r>
+              <a:rPr lang="en-US" sz="800" b="1" dirty="0">
+                <a:solidFill>
+                  <a:srgbClr val="E53935"/>
+                </a:solidFill>
+                <a:latin typeface="Arial" pitchFamily="34" charset="0"/>
+                <a:ea typeface="Arial" pitchFamily="34" charset="-122"/>
+                <a:cs typeface="Arial" pitchFamily="34" charset="-120"/>
+              </a:rPr>
+              <a:t>▲▲  </a:t>
+            </a:r>
+            <a:pPr algn="ctr" indent="0" marL="0">
+              <a:buNone/>
+            </a:pPr>
+            <a:r>
+              <a:rPr lang="en-US" sz="800" b="1" dirty="0">
+                <a:solidFill>
+                  <a:srgbClr val="FFFFFF"/>
+                </a:solidFill>
+                <a:latin typeface="Arial" pitchFamily="34" charset="0"/>
+                <a:ea typeface="Arial" pitchFamily="34" charset="-122"/>
+                <a:cs typeface="Arial" pitchFamily="34" charset="-120"/>
+              </a:rPr>
+              <a:t>FORMATO ASSURANCE ITO · v1.0 · INSTRUCTIVO</a:t>
+            </a:r>
+            <a:endParaRPr lang="en-US" sz="800" dirty="0"/>
           </a:p>
         </p:txBody>
       </p:sp>
       <p:sp>
         <p:nvSpPr>
-          <p:cNvPr id="64" name="Text 61"/>
-          <p:cNvSpPr txBox="1"/>
-          <p:nvPr/>
-        </p:nvSpPr>
-        <p:spPr>
-          <a:xfrm>
-            <a:off x="8238744" y="5943600"/>
-            <a:ext cx="3447288" cy="713232"/>
-          </a:xfrm>
-          <a:prstGeom prst="rect">
-            <a:avLst/>
-          </a:prstGeom>
-          <a:noFill/>
-          <a:ln/>
-        </p:spPr>
-        <p:txBody>
-          <a:bodyPr wrap="square" lIns="0" tIns="0" rIns="0" bIns="0" rtlCol="0" anchor="t"/>
-          <a:lstStyle/>
-          <a:p>
-            <a:pPr indent="0" marL="0">
-              <a:buNone/>
-            </a:pPr>
-            <a:r>
-              <a:rPr lang="en-US" sz="930" dirty="0">
-                <a:solidFill>
-                  <a:srgbClr val="222222"/>
-                </a:solidFill>
-                <a:latin typeface="Arial" pitchFamily="34" charset="0"/>
-                <a:ea typeface="Arial" pitchFamily="34" charset="-122"/>
-                <a:cs typeface="Arial" pitchFamily="34" charset="-120"/>
-              </a:rPr>
-              <a:t>Lo completa el Inspector ITO al terminar el turno: focos verificados, % cumplimiento (focos C ÷ focos aplicables), tareas detenidas y hallazgos subidos a SAP. Firman ITO y Supervisor EECC.</a:t>
-            </a:r>
-            <a:endParaRPr lang="en-US" sz="930" dirty="0"/>
-          </a:p>
-        </p:txBody>
-      </p:sp>
-      <p:sp>
-        <p:nvSpPr>
-          <p:cNvPr id="65" name="Shape 62"/>
-          <p:cNvSpPr/>
-          <p:nvPr/>
-        </p:nvSpPr>
-        <p:spPr>
-          <a:xfrm>
-            <a:off x="365760" y="6839712"/>
-            <a:ext cx="11457432" cy="1435608"/>
-          </a:xfrm>
-          <a:prstGeom prst="roundRect">
-            <a:avLst>
-              <a:gd name="adj" fmla="val 3822"/>
-            </a:avLst>
-          </a:prstGeom>
-          <a:solidFill>
-            <a:srgbClr val="FDF1F1"/>
-          </a:solidFill>
-          <a:ln w="12700">
-            <a:solidFill>
-              <a:srgbClr val="C62828"/>
-            </a:solidFill>
-            <a:prstDash val="solid"/>
-          </a:ln>
-        </p:spPr>
-      </p:sp>
-      <p:sp>
-        <p:nvSpPr>
           <p:cNvPr id="66" name="Text 63"/>
-          <p:cNvSpPr txBox="1"/>
-          <p:nvPr/>
-        </p:nvSpPr>
-        <p:spPr>
-          <a:xfrm>
-            <a:off x="548640" y="6912864"/>
-            <a:ext cx="2743200" cy="274320"/>
-          </a:xfrm>
-          <a:prstGeom prst="rect">
-            <a:avLst/>
-          </a:prstGeom>
-          <a:noFill/>
-          <a:ln/>
-        </p:spPr>
-        <p:txBody>
-          <a:bodyPr wrap="square" lIns="0" tIns="0" rIns="0" bIns="0" rtlCol="0" anchor="ctr"/>
-          <a:lstStyle/>
-          <a:p>
-            <a:pPr indent="0" marL="0">
-              <a:buNone/>
-            </a:pPr>
-            <a:r>
-              <a:rPr lang="en-US" sz="1050" b="1" dirty="0">
-                <a:solidFill>
-                  <a:srgbClr val="C62828"/>
-                </a:solidFill>
-                <a:latin typeface="Arial" pitchFamily="34" charset="0"/>
-                <a:ea typeface="Arial" pitchFamily="34" charset="-122"/>
-                <a:cs typeface="Arial" pitchFamily="34" charset="-120"/>
-              </a:rPr>
-              <a:t>REGLAS GENERALES</a:t>
-            </a:r>
-            <a:endParaRPr lang="en-US" sz="1050" dirty="0"/>
-          </a:p>
-        </p:txBody>
-      </p:sp>
-      <p:sp>
-        <p:nvSpPr>
-          <p:cNvPr id="67" name="Text 64"/>
-          <p:cNvSpPr txBox="1"/>
-          <p:nvPr/>
-        </p:nvSpPr>
-        <p:spPr>
-          <a:xfrm>
-            <a:off x="548640" y="7223760"/>
-            <a:ext cx="11064240" cy="978408"/>
-          </a:xfrm>
-          <a:prstGeom prst="rect">
-            <a:avLst/>
-          </a:prstGeom>
-          <a:noFill/>
-          <a:ln/>
-        </p:spPr>
-        <p:txBody>
-          <a:bodyPr wrap="square" lIns="0" tIns="0" rIns="0" bIns="0" rtlCol="0" anchor="t"/>
-          <a:lstStyle/>
-          <a:p>
-            <a:pPr marL="152400" indent="-152400">
-              <a:spcAft>
-                <a:spcPts val="200"/>
-              </a:spcAft>
-              <a:buSzPct val="100000"/>
-              <a:buChar char="•"/>
-            </a:pPr>
-            <a:r>
-              <a:rPr lang="en-US" sz="930" dirty="0">
-                <a:solidFill>
-                  <a:srgbClr val="222222"/>
-                </a:solidFill>
-                <a:latin typeface="Arial" pitchFamily="34" charset="0"/>
-                <a:ea typeface="Arial" pitchFamily="34" charset="-122"/>
-                <a:cs typeface="Arial" pitchFamily="34" charset="-120"/>
-              </a:rPr>
-              <a:t>No modificar columnas, colores, orden de secciones ni tamaño de la lámina.</a:t>
-            </a:r>
-            <a:endParaRPr lang="en-US" sz="930" dirty="0"/>
-          </a:p>
-          <a:p>
-            <a:pPr marL="152400" indent="-152400">
-              <a:spcAft>
-                <a:spcPts val="200"/>
-              </a:spcAft>
-              <a:buSzPct val="100000"/>
-              <a:buChar char="•"/>
-            </a:pPr>
-            <a:r>
-              <a:rPr lang="en-US" sz="930" dirty="0">
-                <a:solidFill>
-                  <a:srgbClr val="222222"/>
-                </a:solidFill>
-                <a:latin typeface="Arial" pitchFamily="34" charset="0"/>
-                <a:ea typeface="Arial" pitchFamily="34" charset="-122"/>
-                <a:cs typeface="Arial" pitchFamily="34" charset="-120"/>
-              </a:rPr>
-              <a:t>Reemplazar todo texto gris entre [corchetes]; el formato publicado no debe tener corchetes ni texto gris.</a:t>
-            </a:r>
-            <a:endParaRPr lang="en-US" sz="930" dirty="0"/>
-          </a:p>
-          <a:p>
-            <a:pPr marL="152400" indent="-152400">
-              <a:spcAft>
-                <a:spcPts val="200"/>
-              </a:spcAft>
-              <a:buSzPct val="100000"/>
-              <a:buChar char="•"/>
-            </a:pPr>
-            <a:r>
-              <a:rPr lang="en-US" sz="930" dirty="0">
-                <a:solidFill>
-                  <a:srgbClr val="222222"/>
-                </a:solidFill>
-                <a:latin typeface="Arial" pitchFamily="34" charset="0"/>
-                <a:ea typeface="Arial" pitchFamily="34" charset="-122"/>
-                <a:cs typeface="Arial" pitchFamily="34" charset="-120"/>
-              </a:rPr>
-              <a:t>Si el texto no cabe, resumir: letra mínima 6 pt. Si hay menos de 6 focos, eliminar la fila sobrante (clic derecho › Eliminar fila).</a:t>
-            </a:r>
-            <a:endParaRPr lang="en-US" sz="930" dirty="0"/>
-          </a:p>
-          <a:p>
-            <a:pPr marL="152400" indent="-152400">
-              <a:spcAft>
-                <a:spcPts val="200"/>
-              </a:spcAft>
-              <a:buSzPct val="100000"/>
-              <a:buChar char="•"/>
-            </a:pPr>
-            <a:r>
-              <a:rPr lang="en-US" sz="930" dirty="0">
-                <a:solidFill>
-                  <a:srgbClr val="222222"/>
-                </a:solidFill>
-                <a:latin typeface="Arial" pitchFamily="34" charset="0"/>
-                <a:ea typeface="Arial" pitchFamily="34" charset="-122"/>
-                <a:cs typeface="Arial" pitchFamily="34" charset="-120"/>
-              </a:rPr>
-              <a:t>Nombre de archivo: ASSURANCE_TURNO_[1-3 ó 2-4]_[DD-DD]_[MES].pptx  (ej.: ASSURANCE_TURNO_1-3_07-20_SEP.pptx).</a:t>
-            </a:r>
-            <a:endParaRPr lang="en-US" sz="930" dirty="0"/>
-          </a:p>
-          <a:p>
-            <a:pPr marL="152400" indent="-152400">
-              <a:spcAft>
-                <a:spcPts val="200"/>
-              </a:spcAft>
-              <a:buSzPct val="100000"/>
-              <a:buChar char="•"/>
-            </a:pPr>
-            <a:r>
-              <a:rPr lang="en-US" sz="930" dirty="0">
-                <a:solidFill>
-                  <a:srgbClr val="222222"/>
-                </a:solidFill>
-                <a:latin typeface="Arial" pitchFamily="34" charset="0"/>
-                <a:ea typeface="Arial" pitchFamily="34" charset="-122"/>
-                <a:cs typeface="Arial" pitchFamily="34" charset="-120"/>
-              </a:rPr>
-              <a:t>Para publicar: dejar solo la lámina PLANTILLA completada y eliminar este instructivo.</a:t>
-            </a:r>
-            <a:endParaRPr lang="en-US" sz="930" dirty="0"/>
-          </a:p>
-        </p:txBody>
-      </p:sp>
-      <p:sp>
-        <p:nvSpPr>
-          <p:cNvPr id="68" name="Shape 65"/>
-          <p:cNvSpPr/>
-          <p:nvPr/>
-        </p:nvSpPr>
-        <p:spPr>
-          <a:xfrm>
-            <a:off x="0" y="8385048"/>
-            <a:ext cx="12191695" cy="347472"/>
-          </a:xfrm>
-          <a:prstGeom prst="rect">
-            <a:avLst/>
-          </a:prstGeom>
-          <a:solidFill>
-            <a:srgbClr val="1F3D6B"/>
-          </a:solidFill>
-          <a:ln w="12700">
-            <a:solidFill>
-              <a:srgbClr val="1F3D6B"/>
-            </a:solidFill>
-            <a:prstDash val="solid"/>
-          </a:ln>
-        </p:spPr>
-      </p:sp>
-      <p:sp>
-        <p:nvSpPr>
-          <p:cNvPr id="69" name="Text 66"/>
-          <p:cNvSpPr txBox="1"/>
-          <p:nvPr/>
-        </p:nvSpPr>
-        <p:spPr>
-          <a:xfrm>
-            <a:off x="365760" y="8385048"/>
-            <a:ext cx="4206240" cy="347472"/>
-          </a:xfrm>
-          <a:prstGeom prst="rect">
-            <a:avLst/>
-          </a:prstGeom>
-          <a:noFill/>
-          <a:ln/>
-        </p:spPr>
-        <p:txBody>
-          <a:bodyPr wrap="square" lIns="0" tIns="0" rIns="0" bIns="0" rtlCol="0" anchor="ctr"/>
-          <a:lstStyle/>
-          <a:p>
-            <a:pPr indent="0" marL="0">
-              <a:buNone/>
-            </a:pPr>
-            <a:r>
-              <a:rPr lang="en-US" sz="950" b="1" dirty="0">
-                <a:solidFill>
-                  <a:srgbClr val="FFFFFF"/>
-                </a:solidFill>
-                <a:latin typeface="Arial" pitchFamily="34" charset="0"/>
-                <a:ea typeface="Arial" pitchFamily="34" charset="-122"/>
-                <a:cs typeface="Arial" pitchFamily="34" charset="-120"/>
-              </a:rPr>
-              <a:t>NUESTRO COMPROMISO: CERO DAÑO A LAS PERSONAS</a:t>
-            </a:r>
-            <a:endParaRPr lang="en-US" sz="950" dirty="0"/>
-          </a:p>
-        </p:txBody>
-      </p:sp>
-      <p:sp>
-        <p:nvSpPr>
-          <p:cNvPr id="70" name="Text 67"/>
-          <p:cNvSpPr txBox="1"/>
-          <p:nvPr/>
-        </p:nvSpPr>
-        <p:spPr>
-          <a:xfrm>
-            <a:off x="4206240" y="8385048"/>
-            <a:ext cx="3840480" cy="347472"/>
-          </a:xfrm>
-          <a:prstGeom prst="rect">
-            <a:avLst/>
-          </a:prstGeom>
-          <a:noFill/>
-          <a:ln/>
-        </p:spPr>
-        <p:txBody>
-          <a:bodyPr wrap="square" lIns="0" tIns="0" rIns="0" bIns="0" rtlCol="0" anchor="ctr"/>
-          <a:lstStyle/>
-          <a:p>
-            <a:pPr algn="ctr" indent="0" marL="0">
-              <a:buNone/>
-            </a:pPr>
-            <a:r>
-              <a:rPr lang="en-US" sz="800" b="1" dirty="0">
-                <a:solidFill>
-                  <a:srgbClr val="E53935"/>
-                </a:solidFill>
-                <a:latin typeface="Arial" pitchFamily="34" charset="0"/>
-                <a:ea typeface="Arial" pitchFamily="34" charset="-122"/>
-                <a:cs typeface="Arial" pitchFamily="34" charset="-120"/>
-              </a:rPr>
-              <a:t>▲▲  </a:t>
-            </a:r>
-            <a:pPr algn="ctr" indent="0" marL="0">
-              <a:buNone/>
-            </a:pPr>
-            <a:r>
-              <a:rPr lang="en-US" sz="800" b="1" dirty="0">
-                <a:solidFill>
-                  <a:srgbClr val="FFFFFF"/>
-                </a:solidFill>
-                <a:latin typeface="Arial" pitchFamily="34" charset="0"/>
-                <a:ea typeface="Arial" pitchFamily="34" charset="-122"/>
-                <a:cs typeface="Arial" pitchFamily="34" charset="-120"/>
-              </a:rPr>
-              <a:t>FORMATO ASSURANCE ITO · v1.0 · INSTRUCTIVO</a:t>
-            </a:r>
-            <a:endParaRPr lang="en-US" sz="800" dirty="0"/>
-          </a:p>
-        </p:txBody>
-      </p:sp>
-      <p:sp>
-        <p:nvSpPr>
-          <p:cNvPr id="71" name="Text 68"/>
           <p:cNvSpPr txBox="1"/>
           <p:nvPr/>
         </p:nvSpPr>

</xml_diff>

<commit_message>
Formato Assurance ITO: franja de indicadores de los últimos 14 días
Co-Authored-By: Claude Opus 5.5 <noreply@anthropic.com>
Claude-Session: https://claude.ai/code/session_017MaLNPnWzNhW9Tdfmjv67V
</commit_message>
<xml_diff>
--- a/FORMATO_ASSURANCE_ITO_v1.0.pptx
+++ b/FORMATO_ASSURANCE_ITO_v1.0.pptx
@@ -1458,13 +1458,356 @@
       </p:sp>
       <p:sp>
         <p:nvSpPr>
-          <p:cNvPr id="15" name="Text 12"/>
+          <p:cNvPr id="15" name="Shape 12"/>
+          <p:cNvSpPr/>
+          <p:nvPr/>
+        </p:nvSpPr>
+        <p:spPr>
+          <a:xfrm>
+            <a:off x="365760" y="1060704"/>
+            <a:ext cx="11457432" cy="274320"/>
+          </a:xfrm>
+          <a:prstGeom prst="rect">
+            <a:avLst/>
+          </a:prstGeom>
+          <a:solidFill>
+            <a:srgbClr val="F3F6FA"/>
+          </a:solidFill>
+          <a:ln w="9525">
+            <a:solidFill>
+              <a:srgbClr val="C9D3E0"/>
+            </a:solidFill>
+            <a:prstDash val="solid"/>
+          </a:ln>
+        </p:spPr>
+      </p:sp>
+      <p:sp>
+        <p:nvSpPr>
+          <p:cNvPr id="16" name="Text 13"/>
           <p:cNvSpPr txBox="1"/>
           <p:nvPr/>
         </p:nvSpPr>
         <p:spPr>
           <a:xfrm>
-            <a:off x="365760" y="1097280"/>
+            <a:off x="365760" y="1060704"/>
+            <a:ext cx="1618488" cy="274320"/>
+          </a:xfrm>
+          <a:prstGeom prst="rect">
+            <a:avLst/>
+          </a:prstGeom>
+          <a:solidFill>
+            <a:srgbClr val="1F3D6B"/>
+          </a:solidFill>
+          <a:ln/>
+        </p:spPr>
+        <p:txBody>
+          <a:bodyPr wrap="square" lIns="0" tIns="0" rIns="0" bIns="0" rtlCol="0" anchor="ctr"/>
+          <a:lstStyle/>
+          <a:p>
+            <a:pPr algn="ctr" indent="0" marL="0">
+              <a:buNone/>
+            </a:pPr>
+            <a:r>
+              <a:rPr lang="en-US" sz="750" b="1" dirty="0">
+                <a:solidFill>
+                  <a:srgbClr val="FFFFFF"/>
+                </a:solidFill>
+                <a:latin typeface="Arial" pitchFamily="34" charset="0"/>
+                <a:ea typeface="Arial" pitchFamily="34" charset="-122"/>
+                <a:cs typeface="Arial" pitchFamily="34" charset="-120"/>
+              </a:rPr>
+              <a:t>EVENTOS ÚLTIMOS 14 DÍAS</a:t>
+            </a:r>
+            <a:endParaRPr lang="en-US" sz="750" dirty="0"/>
+          </a:p>
+        </p:txBody>
+      </p:sp>
+      <p:sp>
+        <p:nvSpPr>
+          <p:cNvPr id="17" name="Text 14"/>
+          <p:cNvSpPr txBox="1"/>
+          <p:nvPr/>
+        </p:nvSpPr>
+        <p:spPr>
+          <a:xfrm>
+            <a:off x="2103120" y="1060704"/>
+            <a:ext cx="9646920" cy="274320"/>
+          </a:xfrm>
+          <a:prstGeom prst="rect">
+            <a:avLst/>
+          </a:prstGeom>
+          <a:noFill/>
+          <a:ln/>
+        </p:spPr>
+        <p:txBody>
+          <a:bodyPr wrap="square" lIns="0" tIns="0" rIns="0" bIns="0" rtlCol="0" anchor="ctr"/>
+          <a:lstStyle/>
+          <a:p>
+            <a:pPr indent="0" marL="0">
+              <a:buNone/>
+            </a:pPr>
+            <a:r>
+              <a:rPr lang="en-US" sz="850" i="1" dirty="0">
+                <a:solidFill>
+                  <a:srgbClr val="7A8594"/>
+                </a:solidFill>
+                <a:latin typeface="Arial" pitchFamily="34" charset="0"/>
+                <a:ea typeface="Arial" pitchFamily="34" charset="-122"/>
+                <a:cs typeface="Arial" pitchFamily="34" charset="-120"/>
+              </a:rPr>
+              <a:t>[del __ al __ MES]     </a:t>
+            </a:r>
+            <a:pPr indent="0" marL="0">
+              <a:buNone/>
+            </a:pPr>
+            <a:r>
+              <a:rPr lang="en-US" sz="850" b="1" dirty="0">
+                <a:solidFill>
+                  <a:srgbClr val="1F3D6B"/>
+                </a:solidFill>
+                <a:latin typeface="Arial" pitchFamily="34" charset="0"/>
+                <a:ea typeface="Arial" pitchFamily="34" charset="-122"/>
+                <a:cs typeface="Arial" pitchFamily="34" charset="-120"/>
+              </a:rPr>
+              <a:t>Total </a:t>
+            </a:r>
+            <a:pPr indent="0" marL="0">
+              <a:buNone/>
+            </a:pPr>
+            <a:r>
+              <a:rPr lang="en-US" sz="850" b="1" i="1" dirty="0">
+                <a:solidFill>
+                  <a:srgbClr val="7A8594"/>
+                </a:solidFill>
+                <a:latin typeface="Arial" pitchFamily="34" charset="0"/>
+                <a:ea typeface="Arial" pitchFamily="34" charset="-122"/>
+                <a:cs typeface="Arial" pitchFamily="34" charset="-120"/>
+              </a:rPr>
+              <a:t>[N]</a:t>
+            </a:r>
+            <a:pPr indent="0" marL="0">
+              <a:buNone/>
+            </a:pPr>
+            <a:r>
+              <a:rPr lang="en-US" sz="850" dirty="0">
+                <a:solidFill>
+                  <a:srgbClr val="222222"/>
+                </a:solidFill>
+                <a:latin typeface="Arial" pitchFamily="34" charset="0"/>
+                <a:ea typeface="Arial" pitchFamily="34" charset="-122"/>
+                <a:cs typeface="Arial" pitchFamily="34" charset="-120"/>
+              </a:rPr>
+              <a:t>    ·    </a:t>
+            </a:r>
+            <a:pPr indent="0" marL="0">
+              <a:buNone/>
+            </a:pPr>
+            <a:r>
+              <a:rPr lang="en-US" sz="850" b="1" dirty="0">
+                <a:solidFill>
+                  <a:srgbClr val="C62828"/>
+                </a:solidFill>
+                <a:latin typeface="Arial" pitchFamily="34" charset="0"/>
+                <a:ea typeface="Arial" pitchFamily="34" charset="-122"/>
+                <a:cs typeface="Arial" pitchFamily="34" charset="-120"/>
+              </a:rPr>
+              <a:t>CAAP </a:t>
+            </a:r>
+            <a:pPr indent="0" marL="0">
+              <a:buNone/>
+            </a:pPr>
+            <a:r>
+              <a:rPr lang="en-US" sz="850" b="1" i="1" dirty="0">
+                <a:solidFill>
+                  <a:srgbClr val="7A8594"/>
+                </a:solidFill>
+                <a:latin typeface="Arial" pitchFamily="34" charset="0"/>
+                <a:ea typeface="Arial" pitchFamily="34" charset="-122"/>
+                <a:cs typeface="Arial" pitchFamily="34" charset="-120"/>
+              </a:rPr>
+              <a:t>[n]</a:t>
+            </a:r>
+            <a:pPr indent="0" marL="0">
+              <a:buNone/>
+            </a:pPr>
+            <a:r>
+              <a:rPr lang="en-US" sz="850" dirty="0">
+                <a:solidFill>
+                  <a:srgbClr val="222222"/>
+                </a:solidFill>
+                <a:latin typeface="Arial" pitchFamily="34" charset="0"/>
+                <a:ea typeface="Arial" pitchFamily="34" charset="-122"/>
+                <a:cs typeface="Arial" pitchFamily="34" charset="-120"/>
+              </a:rPr>
+              <a:t>    ·    </a:t>
+            </a:r>
+            <a:pPr indent="0" marL="0">
+              <a:buNone/>
+            </a:pPr>
+            <a:r>
+              <a:rPr lang="en-US" sz="850" b="1" dirty="0">
+                <a:solidFill>
+                  <a:srgbClr val="C62828"/>
+                </a:solidFill>
+                <a:latin typeface="Arial" pitchFamily="34" charset="0"/>
+                <a:ea typeface="Arial" pitchFamily="34" charset="-122"/>
+                <a:cs typeface="Arial" pitchFamily="34" charset="-120"/>
+              </a:rPr>
+              <a:t>HAP </a:t>
+            </a:r>
+            <a:pPr indent="0" marL="0">
+              <a:buNone/>
+            </a:pPr>
+            <a:r>
+              <a:rPr lang="en-US" sz="850" b="1" i="1" dirty="0">
+                <a:solidFill>
+                  <a:srgbClr val="7A8594"/>
+                </a:solidFill>
+                <a:latin typeface="Arial" pitchFamily="34" charset="0"/>
+                <a:ea typeface="Arial" pitchFamily="34" charset="-122"/>
+                <a:cs typeface="Arial" pitchFamily="34" charset="-120"/>
+              </a:rPr>
+              <a:t>[n]</a:t>
+            </a:r>
+            <a:pPr indent="0" marL="0">
+              <a:buNone/>
+            </a:pPr>
+            <a:r>
+              <a:rPr lang="en-US" sz="850" dirty="0">
+                <a:solidFill>
+                  <a:srgbClr val="222222"/>
+                </a:solidFill>
+                <a:latin typeface="Arial" pitchFamily="34" charset="0"/>
+                <a:ea typeface="Arial" pitchFamily="34" charset="-122"/>
+                <a:cs typeface="Arial" pitchFamily="34" charset="-120"/>
+              </a:rPr>
+              <a:t>    ·    </a:t>
+            </a:r>
+            <a:pPr indent="0" marL="0">
+              <a:buNone/>
+            </a:pPr>
+            <a:r>
+              <a:rPr lang="en-US" sz="850" b="1" dirty="0">
+                <a:solidFill>
+                  <a:srgbClr val="B35C00"/>
+                </a:solidFill>
+                <a:latin typeface="Arial" pitchFamily="34" charset="0"/>
+                <a:ea typeface="Arial" pitchFamily="34" charset="-122"/>
+                <a:cs typeface="Arial" pitchFamily="34" charset="-120"/>
+              </a:rPr>
+              <a:t>CBP </a:t>
+            </a:r>
+            <a:pPr indent="0" marL="0">
+              <a:buNone/>
+            </a:pPr>
+            <a:r>
+              <a:rPr lang="en-US" sz="850" b="1" i="1" dirty="0">
+                <a:solidFill>
+                  <a:srgbClr val="7A8594"/>
+                </a:solidFill>
+                <a:latin typeface="Arial" pitchFamily="34" charset="0"/>
+                <a:ea typeface="Arial" pitchFamily="34" charset="-122"/>
+                <a:cs typeface="Arial" pitchFamily="34" charset="-120"/>
+              </a:rPr>
+              <a:t>[n]</a:t>
+            </a:r>
+            <a:pPr indent="0" marL="0">
+              <a:buNone/>
+            </a:pPr>
+            <a:r>
+              <a:rPr lang="en-US" sz="850" dirty="0">
+                <a:solidFill>
+                  <a:srgbClr val="222222"/>
+                </a:solidFill>
+                <a:latin typeface="Arial" pitchFamily="34" charset="0"/>
+                <a:ea typeface="Arial" pitchFamily="34" charset="-122"/>
+                <a:cs typeface="Arial" pitchFamily="34" charset="-120"/>
+              </a:rPr>
+              <a:t>    ·    </a:t>
+            </a:r>
+            <a:pPr indent="0" marL="0">
+              <a:buNone/>
+            </a:pPr>
+            <a:r>
+              <a:rPr lang="en-US" sz="850" b="1" dirty="0">
+                <a:solidFill>
+                  <a:srgbClr val="B35C00"/>
+                </a:solidFill>
+                <a:latin typeface="Arial" pitchFamily="34" charset="0"/>
+                <a:ea typeface="Arial" pitchFamily="34" charset="-122"/>
+                <a:cs typeface="Arial" pitchFamily="34" charset="-120"/>
+              </a:rPr>
+              <a:t>HBP </a:t>
+            </a:r>
+            <a:pPr indent="0" marL="0">
+              <a:buNone/>
+            </a:pPr>
+            <a:r>
+              <a:rPr lang="en-US" sz="850" b="1" i="1" dirty="0">
+                <a:solidFill>
+                  <a:srgbClr val="7A8594"/>
+                </a:solidFill>
+                <a:latin typeface="Arial" pitchFamily="34" charset="0"/>
+                <a:ea typeface="Arial" pitchFamily="34" charset="-122"/>
+                <a:cs typeface="Arial" pitchFamily="34" charset="-120"/>
+              </a:rPr>
+              <a:t>[n]</a:t>
+            </a:r>
+            <a:pPr indent="0" marL="0">
+              <a:buNone/>
+            </a:pPr>
+            <a:r>
+              <a:rPr lang="en-US" sz="850" dirty="0">
+                <a:solidFill>
+                  <a:srgbClr val="222222"/>
+                </a:solidFill>
+                <a:latin typeface="Arial" pitchFamily="34" charset="0"/>
+                <a:ea typeface="Arial" pitchFamily="34" charset="-122"/>
+                <a:cs typeface="Arial" pitchFamily="34" charset="-120"/>
+              </a:rPr>
+              <a:t>    ·    </a:t>
+            </a:r>
+            <a:pPr indent="0" marL="0">
+              <a:buNone/>
+            </a:pPr>
+            <a:r>
+              <a:rPr lang="en-US" sz="850" b="1" dirty="0">
+                <a:solidFill>
+                  <a:srgbClr val="1F3D6B"/>
+                </a:solidFill>
+                <a:latin typeface="Arial" pitchFamily="34" charset="0"/>
+                <a:ea typeface="Arial" pitchFamily="34" charset="-122"/>
+                <a:cs typeface="Arial" pitchFamily="34" charset="-120"/>
+              </a:rPr>
+              <a:t>vs. 14 días anteriores: </a:t>
+            </a:r>
+            <a:pPr indent="0" marL="0">
+              <a:buNone/>
+            </a:pPr>
+            <a:r>
+              <a:rPr lang="en-US" sz="850" b="1" i="1" dirty="0">
+                <a:solidFill>
+                  <a:srgbClr val="7A8594"/>
+                </a:solidFill>
+                <a:latin typeface="Arial" pitchFamily="34" charset="0"/>
+                <a:ea typeface="Arial" pitchFamily="34" charset="-122"/>
+                <a:cs typeface="Arial" pitchFamily="34" charset="-120"/>
+              </a:rPr>
+              <a:t>[N] [▲ / ▼ / =]</a:t>
+            </a:r>
+            <a:endParaRPr lang="en-US" sz="850" dirty="0"/>
+          </a:p>
+        </p:txBody>
+      </p:sp>
+      <p:sp>
+        <p:nvSpPr>
+          <p:cNvPr id="18" name="Text 15"/>
+          <p:cNvSpPr txBox="1"/>
+          <p:nvPr/>
+        </p:nvSpPr>
+        <p:spPr>
+          <a:xfrm>
+            <a:off x="365760" y="1389888"/>
             <a:ext cx="777240" cy="201168"/>
           </a:xfrm>
           <a:prstGeom prst="rect">
@@ -1499,13 +1842,13 @@
       </p:sp>
       <p:sp>
         <p:nvSpPr>
-          <p:cNvPr id="16" name="Text 13"/>
+          <p:cNvPr id="19" name="Text 16"/>
           <p:cNvSpPr txBox="1"/>
           <p:nvPr/>
         </p:nvSpPr>
         <p:spPr>
           <a:xfrm>
-            <a:off x="1207008" y="1097280"/>
+            <a:off x="1207008" y="1389888"/>
             <a:ext cx="777240" cy="201168"/>
           </a:xfrm>
           <a:prstGeom prst="rect">
@@ -1540,13 +1883,13 @@
       </p:sp>
       <p:sp>
         <p:nvSpPr>
-          <p:cNvPr id="17" name="Text 14"/>
+          <p:cNvPr id="20" name="Text 17"/>
           <p:cNvSpPr txBox="1"/>
           <p:nvPr/>
         </p:nvSpPr>
         <p:spPr>
           <a:xfrm>
-            <a:off x="2103120" y="1097280"/>
+            <a:off x="2103120" y="1389888"/>
             <a:ext cx="9720072" cy="201168"/>
           </a:xfrm>
           <a:prstGeom prst="rect">
@@ -1732,7 +2075,7 @@
           </p:nvPr>
         </p:nvGraphicFramePr>
         <p:xfrm>
-          <a:off x="365760" y="1371600"/>
+          <a:off x="365760" y="1645920"/>
           <a:ext cx="9143771" cy="914400"/>
         </p:xfrm>
         <a:graphic>
@@ -2088,7 +2431,7 @@
                   </a:tcPr>
                 </a:tc>
               </a:tr>
-              <a:tr h="676656">
+              <a:tr h="640080">
                 <a:tc>
                   <a:txBody>
                     <a:bodyPr/>
@@ -2570,7 +2913,7 @@
                   </a:tcPr>
                 </a:tc>
               </a:tr>
-              <a:tr h="676656">
+              <a:tr h="640080">
                 <a:tc>
                   <a:txBody>
                     <a:bodyPr/>
@@ -3052,7 +3395,7 @@
                   </a:tcPr>
                 </a:tc>
               </a:tr>
-              <a:tr h="676656">
+              <a:tr h="640080">
                 <a:tc>
                   <a:txBody>
                     <a:bodyPr/>
@@ -3534,7 +3877,7 @@
                   </a:tcPr>
                 </a:tc>
               </a:tr>
-              <a:tr h="676656">
+              <a:tr h="640080">
                 <a:tc>
                   <a:txBody>
                     <a:bodyPr/>
@@ -4016,7 +4359,7 @@
                   </a:tcPr>
                 </a:tc>
               </a:tr>
-              <a:tr h="676656">
+              <a:tr h="640080">
                 <a:tc>
                   <a:txBody>
                     <a:bodyPr/>
@@ -4498,7 +4841,7 @@
                   </a:tcPr>
                 </a:tc>
               </a:tr>
-              <a:tr h="676656">
+              <a:tr h="640080">
                 <a:tc>
                   <a:txBody>
                     <a:bodyPr/>
@@ -4986,13 +5329,13 @@
       </p:graphicFrame>
       <p:sp>
         <p:nvSpPr>
-          <p:cNvPr id="19" name="Text 15"/>
+          <p:cNvPr id="22" name="Text 18"/>
           <p:cNvSpPr txBox="1"/>
           <p:nvPr/>
         </p:nvSpPr>
         <p:spPr>
           <a:xfrm>
-            <a:off x="365760" y="5797296"/>
+            <a:off x="365760" y="5852160"/>
             <a:ext cx="960120" cy="292608"/>
           </a:xfrm>
           <a:prstGeom prst="rect">
@@ -5027,13 +5370,13 @@
       </p:sp>
       <p:sp>
         <p:nvSpPr>
-          <p:cNvPr id="20" name="Shape 16"/>
+          <p:cNvPr id="23" name="Shape 19"/>
           <p:cNvSpPr/>
           <p:nvPr/>
         </p:nvSpPr>
         <p:spPr>
           <a:xfrm>
-            <a:off x="1325880" y="5797296"/>
+            <a:off x="1325880" y="5852160"/>
             <a:ext cx="10497312" cy="292608"/>
           </a:xfrm>
           <a:prstGeom prst="rect">
@@ -5052,13 +5395,13 @@
       </p:sp>
       <p:sp>
         <p:nvSpPr>
-          <p:cNvPr id="21" name="Text 17"/>
+          <p:cNvPr id="24" name="Text 20"/>
           <p:cNvSpPr txBox="1"/>
           <p:nvPr/>
         </p:nvSpPr>
         <p:spPr>
           <a:xfrm>
-            <a:off x="1417320" y="5797296"/>
+            <a:off x="1417320" y="5852160"/>
             <a:ext cx="10314432" cy="292608"/>
           </a:xfrm>
           <a:prstGeom prst="rect">
@@ -5105,13 +5448,13 @@
       </p:sp>
       <p:sp>
         <p:nvSpPr>
-          <p:cNvPr id="22" name="Shape 18"/>
+          <p:cNvPr id="25" name="Shape 21"/>
           <p:cNvSpPr/>
           <p:nvPr/>
         </p:nvSpPr>
         <p:spPr>
           <a:xfrm>
-            <a:off x="365760" y="6181344"/>
+            <a:off x="365760" y="6236208"/>
             <a:ext cx="6172200" cy="219456"/>
           </a:xfrm>
           <a:prstGeom prst="rect">
@@ -5130,13 +5473,13 @@
       </p:sp>
       <p:sp>
         <p:nvSpPr>
-          <p:cNvPr id="23" name="Text 19"/>
+          <p:cNvPr id="26" name="Text 22"/>
           <p:cNvSpPr txBox="1"/>
           <p:nvPr/>
         </p:nvSpPr>
         <p:spPr>
           <a:xfrm>
-            <a:off x="457200" y="6181344"/>
+            <a:off x="457200" y="6236208"/>
             <a:ext cx="5989320" cy="219456"/>
           </a:xfrm>
           <a:prstGeom prst="rect">
@@ -5169,7 +5512,7 @@
       </p:sp>
       <p:pic>
         <p:nvPicPr>
-          <p:cNvPr id="24" name="Image 1" descr="preencoded.png">    </p:cNvPr>
+          <p:cNvPr id="27" name="Image 1" descr="preencoded.png">    </p:cNvPr>
           <p:cNvPicPr>
             <a:picLocks noChangeAspect="1"/>
           </p:cNvPicPr>
@@ -5183,7 +5526,7 @@
         </p:blipFill>
         <p:spPr>
           <a:xfrm>
-            <a:off x="438912" y="6473952"/>
+            <a:off x="438912" y="6528816"/>
             <a:ext cx="219456" cy="219456"/>
           </a:xfrm>
           <a:prstGeom prst="rect">
@@ -5193,13 +5536,13 @@
       </p:pic>
       <p:sp>
         <p:nvSpPr>
-          <p:cNvPr id="25" name="Text 20"/>
+          <p:cNvPr id="28" name="Text 23"/>
           <p:cNvSpPr txBox="1"/>
           <p:nvPr/>
         </p:nvSpPr>
         <p:spPr>
           <a:xfrm>
-            <a:off x="694944" y="6455664"/>
+            <a:off x="694944" y="6510528"/>
             <a:ext cx="1673352" cy="256032"/>
           </a:xfrm>
           <a:prstGeom prst="rect">
@@ -5232,13 +5575,13 @@
       </p:sp>
       <p:sp>
         <p:nvSpPr>
-          <p:cNvPr id="26" name="Text 21"/>
+          <p:cNvPr id="29" name="Text 24"/>
           <p:cNvSpPr txBox="1"/>
           <p:nvPr/>
         </p:nvSpPr>
         <p:spPr>
           <a:xfrm>
-            <a:off x="438912" y="6729984"/>
+            <a:off x="438912" y="6784848"/>
             <a:ext cx="1911096" cy="274320"/>
           </a:xfrm>
           <a:prstGeom prst="rect">
@@ -5271,14 +5614,14 @@
       </p:sp>
       <p:sp>
         <p:nvSpPr>
-          <p:cNvPr id="27" name="Text 22"/>
+          <p:cNvPr id="30" name="Text 25"/>
           <p:cNvSpPr txBox="1"/>
           <p:nvPr/>
         </p:nvSpPr>
         <p:spPr>
           <a:xfrm>
-            <a:off x="438912" y="7022592"/>
-            <a:ext cx="1911096" cy="822960"/>
+            <a:off x="438912" y="7077456"/>
+            <a:ext cx="1911096" cy="786384"/>
           </a:xfrm>
           <a:prstGeom prst="rect">
             <a:avLst/>
@@ -5353,14 +5696,14 @@
       </p:sp>
       <p:sp>
         <p:nvSpPr>
-          <p:cNvPr id="28" name="Shape 23"/>
+          <p:cNvPr id="31" name="Shape 26"/>
           <p:cNvSpPr/>
           <p:nvPr/>
         </p:nvSpPr>
         <p:spPr>
           <a:xfrm>
-            <a:off x="2423160" y="6501384"/>
-            <a:ext cx="9144" cy="1316736"/>
+            <a:off x="2423160" y="6556248"/>
+            <a:ext cx="9144" cy="1280160"/>
           </a:xfrm>
           <a:prstGeom prst="rect">
             <a:avLst/>
@@ -5378,7 +5721,7 @@
       </p:sp>
       <p:pic>
         <p:nvPicPr>
-          <p:cNvPr id="29" name="Image 2" descr="preencoded.png">    </p:cNvPr>
+          <p:cNvPr id="32" name="Image 2" descr="preencoded.png">    </p:cNvPr>
           <p:cNvPicPr>
             <a:picLocks noChangeAspect="1"/>
           </p:cNvPicPr>
@@ -5392,7 +5735,7 @@
         </p:blipFill>
         <p:spPr>
           <a:xfrm>
-            <a:off x="2496312" y="6473952"/>
+            <a:off x="2496312" y="6528816"/>
             <a:ext cx="219456" cy="219456"/>
           </a:xfrm>
           <a:prstGeom prst="rect">
@@ -5402,13 +5745,13 @@
       </p:pic>
       <p:sp>
         <p:nvSpPr>
-          <p:cNvPr id="30" name="Text 24"/>
+          <p:cNvPr id="33" name="Text 27"/>
           <p:cNvSpPr txBox="1"/>
           <p:nvPr/>
         </p:nvSpPr>
         <p:spPr>
           <a:xfrm>
-            <a:off x="2752344" y="6455664"/>
+            <a:off x="2752344" y="6510528"/>
             <a:ext cx="1673352" cy="256032"/>
           </a:xfrm>
           <a:prstGeom prst="rect">
@@ -5441,13 +5784,13 @@
       </p:sp>
       <p:sp>
         <p:nvSpPr>
-          <p:cNvPr id="31" name="Text 25"/>
+          <p:cNvPr id="34" name="Text 28"/>
           <p:cNvSpPr txBox="1"/>
           <p:nvPr/>
         </p:nvSpPr>
         <p:spPr>
           <a:xfrm>
-            <a:off x="2496312" y="6729984"/>
+            <a:off x="2496312" y="6784848"/>
             <a:ext cx="1911096" cy="274320"/>
           </a:xfrm>
           <a:prstGeom prst="rect">
@@ -5480,14 +5823,14 @@
       </p:sp>
       <p:sp>
         <p:nvSpPr>
-          <p:cNvPr id="32" name="Text 26"/>
+          <p:cNvPr id="35" name="Text 29"/>
           <p:cNvSpPr txBox="1"/>
           <p:nvPr/>
         </p:nvSpPr>
         <p:spPr>
           <a:xfrm>
-            <a:off x="2496312" y="7022592"/>
-            <a:ext cx="1911096" cy="822960"/>
+            <a:off x="2496312" y="7077456"/>
+            <a:ext cx="1911096" cy="786384"/>
           </a:xfrm>
           <a:prstGeom prst="rect">
             <a:avLst/>
@@ -5562,14 +5905,14 @@
       </p:sp>
       <p:sp>
         <p:nvSpPr>
-          <p:cNvPr id="33" name="Shape 27"/>
+          <p:cNvPr id="36" name="Shape 30"/>
           <p:cNvSpPr/>
           <p:nvPr/>
         </p:nvSpPr>
         <p:spPr>
           <a:xfrm>
-            <a:off x="4480560" y="6501384"/>
-            <a:ext cx="9144" cy="1316736"/>
+            <a:off x="4480560" y="6556248"/>
+            <a:ext cx="9144" cy="1280160"/>
           </a:xfrm>
           <a:prstGeom prst="rect">
             <a:avLst/>
@@ -5587,7 +5930,7 @@
       </p:sp>
       <p:pic>
         <p:nvPicPr>
-          <p:cNvPr id="34" name="Image 3" descr="preencoded.png">    </p:cNvPr>
+          <p:cNvPr id="37" name="Image 3" descr="preencoded.png">    </p:cNvPr>
           <p:cNvPicPr>
             <a:picLocks noChangeAspect="1"/>
           </p:cNvPicPr>
@@ -5601,7 +5944,7 @@
         </p:blipFill>
         <p:spPr>
           <a:xfrm>
-            <a:off x="4553712" y="6473952"/>
+            <a:off x="4553712" y="6528816"/>
             <a:ext cx="219456" cy="219456"/>
           </a:xfrm>
           <a:prstGeom prst="rect">
@@ -5611,13 +5954,13 @@
       </p:pic>
       <p:sp>
         <p:nvSpPr>
-          <p:cNvPr id="35" name="Text 28"/>
+          <p:cNvPr id="38" name="Text 31"/>
           <p:cNvSpPr txBox="1"/>
           <p:nvPr/>
         </p:nvSpPr>
         <p:spPr>
           <a:xfrm>
-            <a:off x="4809744" y="6455664"/>
+            <a:off x="4809744" y="6510528"/>
             <a:ext cx="1673352" cy="256032"/>
           </a:xfrm>
           <a:prstGeom prst="rect">
@@ -5650,13 +5993,13 @@
       </p:sp>
       <p:sp>
         <p:nvSpPr>
-          <p:cNvPr id="36" name="Text 29"/>
+          <p:cNvPr id="39" name="Text 32"/>
           <p:cNvSpPr txBox="1"/>
           <p:nvPr/>
         </p:nvSpPr>
         <p:spPr>
           <a:xfrm>
-            <a:off x="4553712" y="6729984"/>
+            <a:off x="4553712" y="6784848"/>
             <a:ext cx="1911096" cy="274320"/>
           </a:xfrm>
           <a:prstGeom prst="rect">
@@ -5689,14 +6032,14 @@
       </p:sp>
       <p:sp>
         <p:nvSpPr>
-          <p:cNvPr id="37" name="Text 30"/>
+          <p:cNvPr id="40" name="Text 33"/>
           <p:cNvSpPr txBox="1"/>
           <p:nvPr/>
         </p:nvSpPr>
         <p:spPr>
           <a:xfrm>
-            <a:off x="4553712" y="7022592"/>
-            <a:ext cx="1911096" cy="822960"/>
+            <a:off x="4553712" y="7077456"/>
+            <a:ext cx="1911096" cy="786384"/>
           </a:xfrm>
           <a:prstGeom prst="rect">
             <a:avLst/>
@@ -5771,18 +6114,18 @@
       </p:sp>
       <p:sp>
         <p:nvSpPr>
-          <p:cNvPr id="38" name="Shape 31"/>
+          <p:cNvPr id="41" name="Shape 34"/>
           <p:cNvSpPr/>
           <p:nvPr/>
         </p:nvSpPr>
         <p:spPr>
           <a:xfrm>
-            <a:off x="6675120" y="6181344"/>
-            <a:ext cx="1655064" cy="1682496"/>
+            <a:off x="6675120" y="6236208"/>
+            <a:ext cx="1655064" cy="1645920"/>
           </a:xfrm>
           <a:prstGeom prst="roundRect">
             <a:avLst>
-              <a:gd name="adj" fmla="val 3315"/>
+              <a:gd name="adj" fmla="val 3333"/>
             </a:avLst>
           </a:prstGeom>
           <a:solidFill>
@@ -5798,13 +6141,13 @@
       </p:sp>
       <p:sp>
         <p:nvSpPr>
-          <p:cNvPr id="39" name="Text 32"/>
+          <p:cNvPr id="42" name="Text 35"/>
           <p:cNvSpPr txBox="1"/>
           <p:nvPr/>
         </p:nvSpPr>
         <p:spPr>
           <a:xfrm>
-            <a:off x="6748272" y="6217920"/>
+            <a:off x="6748272" y="6272784"/>
             <a:ext cx="1508760" cy="310896"/>
           </a:xfrm>
           <a:prstGeom prst="rect">
@@ -5837,14 +6180,14 @@
       </p:sp>
       <p:sp>
         <p:nvSpPr>
-          <p:cNvPr id="40" name="Text 33"/>
+          <p:cNvPr id="43" name="Text 36"/>
           <p:cNvSpPr txBox="1"/>
           <p:nvPr/>
         </p:nvSpPr>
         <p:spPr>
           <a:xfrm>
-            <a:off x="6748272" y="6565392"/>
-            <a:ext cx="1527048" cy="1243584"/>
+            <a:off x="6748272" y="6620256"/>
+            <a:ext cx="1527048" cy="1207008"/>
           </a:xfrm>
           <a:prstGeom prst="rect">
             <a:avLst/>
@@ -5964,18 +6307,18 @@
       </p:sp>
       <p:sp>
         <p:nvSpPr>
-          <p:cNvPr id="41" name="Shape 34"/>
+          <p:cNvPr id="44" name="Shape 37"/>
           <p:cNvSpPr/>
           <p:nvPr/>
         </p:nvSpPr>
         <p:spPr>
           <a:xfrm>
-            <a:off x="8421624" y="6181344"/>
-            <a:ext cx="1655064" cy="1682496"/>
+            <a:off x="8421624" y="6236208"/>
+            <a:ext cx="1655064" cy="1645920"/>
           </a:xfrm>
           <a:prstGeom prst="roundRect">
             <a:avLst>
-              <a:gd name="adj" fmla="val 3315"/>
+              <a:gd name="adj" fmla="val 3333"/>
             </a:avLst>
           </a:prstGeom>
           <a:solidFill>
@@ -5991,13 +6334,13 @@
       </p:sp>
       <p:sp>
         <p:nvSpPr>
-          <p:cNvPr id="42" name="Text 35"/>
+          <p:cNvPr id="45" name="Text 38"/>
           <p:cNvSpPr txBox="1"/>
           <p:nvPr/>
         </p:nvSpPr>
         <p:spPr>
           <a:xfrm>
-            <a:off x="8494776" y="6217920"/>
+            <a:off x="8494776" y="6272784"/>
             <a:ext cx="1508760" cy="310896"/>
           </a:xfrm>
           <a:prstGeom prst="rect">
@@ -6030,14 +6373,14 @@
       </p:sp>
       <p:sp>
         <p:nvSpPr>
-          <p:cNvPr id="43" name="Text 36"/>
+          <p:cNvPr id="46" name="Text 39"/>
           <p:cNvSpPr txBox="1"/>
           <p:nvPr/>
         </p:nvSpPr>
         <p:spPr>
           <a:xfrm>
-            <a:off x="8494776" y="6565392"/>
-            <a:ext cx="1527048" cy="1243584"/>
+            <a:off x="8494776" y="6620256"/>
+            <a:ext cx="1527048" cy="1207008"/>
           </a:xfrm>
           <a:prstGeom prst="rect">
             <a:avLst/>
@@ -6157,18 +6500,18 @@
       </p:sp>
       <p:sp>
         <p:nvSpPr>
-          <p:cNvPr id="44" name="Shape 37"/>
+          <p:cNvPr id="47" name="Shape 40"/>
           <p:cNvSpPr/>
           <p:nvPr/>
         </p:nvSpPr>
         <p:spPr>
           <a:xfrm>
-            <a:off x="10168128" y="6181344"/>
-            <a:ext cx="1655064" cy="1682496"/>
+            <a:off x="10168128" y="6236208"/>
+            <a:ext cx="1655064" cy="1645920"/>
           </a:xfrm>
           <a:prstGeom prst="roundRect">
             <a:avLst>
-              <a:gd name="adj" fmla="val 3315"/>
+              <a:gd name="adj" fmla="val 3333"/>
             </a:avLst>
           </a:prstGeom>
           <a:solidFill>
@@ -6184,13 +6527,13 @@
       </p:sp>
       <p:sp>
         <p:nvSpPr>
-          <p:cNvPr id="45" name="Text 38"/>
+          <p:cNvPr id="48" name="Text 41"/>
           <p:cNvSpPr txBox="1"/>
           <p:nvPr/>
         </p:nvSpPr>
         <p:spPr>
           <a:xfrm>
-            <a:off x="10241280" y="6217920"/>
+            <a:off x="10241280" y="6272784"/>
             <a:ext cx="1508760" cy="310896"/>
           </a:xfrm>
           <a:prstGeom prst="rect">
@@ -6223,14 +6566,14 @@
       </p:sp>
       <p:sp>
         <p:nvSpPr>
-          <p:cNvPr id="46" name="Text 39"/>
+          <p:cNvPr id="49" name="Text 42"/>
           <p:cNvSpPr txBox="1"/>
           <p:nvPr/>
         </p:nvSpPr>
         <p:spPr>
           <a:xfrm>
-            <a:off x="10241280" y="6565392"/>
-            <a:ext cx="1527048" cy="1243584"/>
+            <a:off x="10241280" y="6620256"/>
+            <a:ext cx="1527048" cy="1207008"/>
           </a:xfrm>
           <a:prstGeom prst="rect">
             <a:avLst/>
@@ -6350,13 +6693,13 @@
       </p:sp>
       <p:sp>
         <p:nvSpPr>
-          <p:cNvPr id="47" name="Shape 40"/>
+          <p:cNvPr id="50" name="Shape 43"/>
           <p:cNvSpPr/>
           <p:nvPr/>
         </p:nvSpPr>
         <p:spPr>
           <a:xfrm>
-            <a:off x="365760" y="7936992"/>
+            <a:off x="365760" y="7955280"/>
             <a:ext cx="11457432" cy="329184"/>
           </a:xfrm>
           <a:prstGeom prst="rect">
@@ -6375,13 +6718,13 @@
       </p:sp>
       <p:sp>
         <p:nvSpPr>
-          <p:cNvPr id="48" name="Text 41"/>
+          <p:cNvPr id="51" name="Text 44"/>
           <p:cNvSpPr txBox="1"/>
           <p:nvPr/>
         </p:nvSpPr>
         <p:spPr>
           <a:xfrm>
-            <a:off x="457200" y="7936992"/>
+            <a:off x="457200" y="7955280"/>
             <a:ext cx="5852160" cy="329184"/>
           </a:xfrm>
           <a:prstGeom prst="rect">
@@ -6428,13 +6771,13 @@
       </p:sp>
       <p:sp>
         <p:nvSpPr>
-          <p:cNvPr id="49" name="Text 42"/>
+          <p:cNvPr id="52" name="Text 45"/>
           <p:cNvSpPr txBox="1"/>
           <p:nvPr/>
         </p:nvSpPr>
         <p:spPr>
           <a:xfrm>
-            <a:off x="6400800" y="7936992"/>
+            <a:off x="6400800" y="7955280"/>
             <a:ext cx="5349240" cy="329184"/>
           </a:xfrm>
           <a:prstGeom prst="rect">
@@ -6509,7 +6852,7 @@
       </p:sp>
       <p:sp>
         <p:nvSpPr>
-          <p:cNvPr id="50" name="Shape 43"/>
+          <p:cNvPr id="53" name="Shape 46"/>
           <p:cNvSpPr/>
           <p:nvPr/>
         </p:nvSpPr>
@@ -6534,7 +6877,7 @@
       </p:sp>
       <p:sp>
         <p:nvSpPr>
-          <p:cNvPr id="51" name="Text 44"/>
+          <p:cNvPr id="54" name="Text 47"/>
           <p:cNvSpPr txBox="1"/>
           <p:nvPr/>
         </p:nvSpPr>
@@ -6573,7 +6916,7 @@
       </p:sp>
       <p:sp>
         <p:nvSpPr>
-          <p:cNvPr id="52" name="Text 45"/>
+          <p:cNvPr id="55" name="Text 48"/>
           <p:cNvSpPr txBox="1"/>
           <p:nvPr/>
         </p:nvSpPr>
@@ -6626,7 +6969,7 @@
       </p:sp>
       <p:sp>
         <p:nvSpPr>
-          <p:cNvPr id="53" name="Text 46"/>
+          <p:cNvPr id="56" name="Text 49"/>
           <p:cNvSpPr txBox="1"/>
           <p:nvPr/>
         </p:nvSpPr>
@@ -6665,7 +7008,7 @@
       </p:sp>
       <p:sp>
         <p:nvSpPr>
-          <p:cNvPr id="54" name="Instrucciones IA" hidden="1"/>
+          <p:cNvPr id="57" name="Instrucciones IA" hidden="1"/>
           <p:cNvSpPr txBox="1"/>
           <p:nvPr/>
         </p:nvSpPr>
@@ -6867,7 +7210,7 @@
                 <a:ea typeface="Arial" pitchFamily="34" charset="-122"/>
                 <a:cs typeface="Arial" pitchFamily="34" charset="-120"/>
               </a:rPr>
-              <a:t>2. SELECCIÓN DE FOCOS (4 a 6)</a:t>
+              <a:t>2. INDICADORES 14 DÍAS (franja "EVENTOS ÚLTIMOS 14 DÍAS")</a:t>
             </a:r>
             <a:endParaRPr lang="en-US" sz="600" dirty="0"/>
           </a:p>
@@ -6884,6 +7227,97 @@
                 <a:ea typeface="Arial" pitchFamily="34" charset="-122"/>
                 <a:cs typeface="Arial" pitchFamily="34" charset="-120"/>
               </a:rPr>
+              <a:t>- Período: los 14 días que terminan en la fecha de corte indicada por el usuario (fecha de corte y los 13 días previos), según la columna de fecha del evento (en el Excel de eventos: "Fecha Evento", hoja "Export"). Escríbelo como "del DD al DD MES".</a:t>
+            </a:r>
+            <a:endParaRPr lang="en-US" sz="600" dirty="0"/>
+          </a:p>
+          <a:p>
+            <a:pPr indent="0" marL="0">
+              <a:buNone/>
+            </a:pPr>
+            <a:r>
+              <a:rPr lang="en-US" sz="600" dirty="0">
+                <a:solidFill>
+                  <a:srgbClr val="222222"/>
+                </a:solidFill>
+                <a:latin typeface="Arial" pitchFamily="34" charset="0"/>
+                <a:ea typeface="Arial" pitchFamily="34" charset="-122"/>
+                <a:cs typeface="Arial" pitchFamily="34" charset="-120"/>
+              </a:rPr>
+              <a:t>- Total: todos los eventos del período. Por tipo, combina clasificación y potencialidad (columnas "Clasificación" y "Potencialidad"): CAAP = Cuasi accidente + Alto Potencial; HAP = Hallazgo + Alto Potencial; CBP = Cuasi accidente + Bajo Potencial; HBP = Hallazgo + Bajo Potencial. Si hay accidentes u otros tipos, inclúyelos en el Total e indícalos en tu resumen al usuario.</a:t>
+            </a:r>
+            <a:endParaRPr lang="en-US" sz="600" dirty="0"/>
+          </a:p>
+          <a:p>
+            <a:pPr indent="0" marL="0">
+              <a:buNone/>
+            </a:pPr>
+            <a:r>
+              <a:rPr lang="en-US" sz="600" dirty="0">
+                <a:solidFill>
+                  <a:srgbClr val="222222"/>
+                </a:solidFill>
+                <a:latin typeface="Arial" pitchFamily="34" charset="0"/>
+                <a:ea typeface="Arial" pitchFamily="34" charset="-122"/>
+                <a:cs typeface="Arial" pitchFamily="34" charset="-120"/>
+              </a:rPr>
+              <a:t>- vs. 14 días anteriores: total de eventos de los 14 días inmediatamente previos al período, seguido de ▲ si el total actual es mayor, ▼ si es menor o = si es igual. Ej.: "19 ▲". Si el Excel no cubre ese período, escribe [DATO FALTANTE].</a:t>
+            </a:r>
+            <a:endParaRPr lang="en-US" sz="600" dirty="0"/>
+          </a:p>
+          <a:p>
+            <a:pPr indent="0" marL="0">
+              <a:buNone/>
+            </a:pPr>
+            <a:r>
+              <a:rPr lang="en-US" sz="600" dirty="0">
+                <a:solidFill>
+                  <a:srgbClr val="222222"/>
+                </a:solidFill>
+                <a:latin typeface="Arial" pitchFamily="34" charset="0"/>
+                <a:ea typeface="Arial" pitchFamily="34" charset="-122"/>
+                <a:cs typeface="Arial" pitchFamily="34" charset="-120"/>
+              </a:rPr>
+              <a:t>- Verifica que CAAP + HAP + CBP + HBP (+ otros) = Total.</a:t>
+            </a:r>
+            <a:endParaRPr lang="en-US" sz="600" dirty="0"/>
+          </a:p>
+          <a:p>
+            <a:pPr indent="0" marL="0">
+              <a:buNone/>
+            </a:pPr>
+            <a:endParaRPr lang="en-US" sz="600" dirty="0"/>
+          </a:p>
+          <a:p>
+            <a:pPr indent="0" marL="0">
+              <a:buNone/>
+            </a:pPr>
+            <a:r>
+              <a:rPr lang="en-US" sz="600" dirty="0">
+                <a:solidFill>
+                  <a:srgbClr val="222222"/>
+                </a:solidFill>
+                <a:latin typeface="Arial" pitchFamily="34" charset="0"/>
+                <a:ea typeface="Arial" pitchFamily="34" charset="-122"/>
+                <a:cs typeface="Arial" pitchFamily="34" charset="-120"/>
+              </a:rPr>
+              <a:t>3. SELECCIÓN DE FOCOS (4 a 6)</a:t>
+            </a:r>
+            <a:endParaRPr lang="en-US" sz="600" dirty="0"/>
+          </a:p>
+          <a:p>
+            <a:pPr indent="0" marL="0">
+              <a:buNone/>
+            </a:pPr>
+            <a:r>
+              <a:rPr lang="en-US" sz="600" dirty="0">
+                <a:solidFill>
+                  <a:srgbClr val="222222"/>
+                </a:solidFill>
+                <a:latin typeface="Arial" pitchFamily="34" charset="0"/>
+                <a:ea typeface="Arial" pitchFamily="34" charset="-122"/>
+                <a:cs typeface="Arial" pitchFamily="34" charset="-120"/>
+              </a:rPr>
               <a:t>- Agrupa los eventos por riesgo (p. ej.: izaje, trabajo en altura/andamios, vehículos y equipos, energía eléctrica, excavaciones/zanjas, orden y aseo). Un foco = un riesgo.</a:t>
             </a:r>
             <a:endParaRPr lang="en-US" sz="600" dirty="0"/>
@@ -6975,7 +7409,7 @@
                 <a:ea typeface="Arial" pitchFamily="34" charset="-122"/>
                 <a:cs typeface="Arial" pitchFamily="34" charset="-120"/>
               </a:rPr>
-              <a:t>3. NIVEL / PRIORIDAD (primera columna)</a:t>
+              <a:t>4. NIVEL / PRIORIDAD (primera columna)</a:t>
             </a:r>
             <a:endParaRPr lang="en-US" sz="600" dirty="0"/>
           </a:p>
@@ -7049,7 +7483,7 @@
                 <a:ea typeface="Arial" pitchFamily="34" charset="-122"/>
                 <a:cs typeface="Arial" pitchFamily="34" charset="-120"/>
               </a:rPr>
-              <a:t>4. FOCO DE ASSURANCE</a:t>
+              <a:t>5. FOCO DE ASSURANCE</a:t>
             </a:r>
             <a:endParaRPr lang="en-US" sz="600" dirty="0"/>
           </a:p>
@@ -7123,7 +7557,7 @@
                 <a:ea typeface="Arial" pitchFamily="34" charset="-122"/>
                 <a:cs typeface="Arial" pitchFamily="34" charset="-120"/>
               </a:rPr>
-              <a:t>5. EVENTO / EVIDENCIA ORIGEN</a:t>
+              <a:t>6. EVENTO / EVIDENCIA ORIGEN</a:t>
             </a:r>
             <a:endParaRPr lang="en-US" sz="600" dirty="0"/>
           </a:p>
@@ -7197,7 +7631,7 @@
                 <a:ea typeface="Arial" pitchFamily="34" charset="-122"/>
                 <a:cs typeface="Arial" pitchFamily="34" charset="-120"/>
               </a:rPr>
-              <a:t>6. HERRAMIENTA PREVENTIVA SGE</a:t>
+              <a:t>7. HERRAMIENTA PREVENTIVA SGE</a:t>
             </a:r>
             <a:endParaRPr lang="en-US" sz="600" dirty="0"/>
           </a:p>
@@ -7237,7 +7671,7 @@
                 <a:ea typeface="Arial" pitchFamily="34" charset="-122"/>
                 <a:cs typeface="Arial" pitchFamily="34" charset="-120"/>
               </a:rPr>
-              <a:t>7. EVIDENCIA / REGISTRO ESPERADO</a:t>
+              <a:t>8. EVIDENCIA / REGISTRO ESPERADO</a:t>
             </a:r>
             <a:endParaRPr lang="en-US" sz="600" dirty="0"/>
           </a:p>
@@ -7277,7 +7711,7 @@
                 <a:ea typeface="Arial" pitchFamily="34" charset="-122"/>
                 <a:cs typeface="Arial" pitchFamily="34" charset="-120"/>
               </a:rPr>
-              <a:t>8. RECURRENTE</a:t>
+              <a:t>9. RECURRENTE</a:t>
             </a:r>
             <a:endParaRPr lang="en-US" sz="600" dirty="0"/>
           </a:p>
@@ -7334,7 +7768,7 @@
                 <a:ea typeface="Arial" pitchFamily="34" charset="-122"/>
                 <a:cs typeface="Arial" pitchFamily="34" charset="-120"/>
               </a:rPr>
-              <a:t>9. SÍNTESIS Y RECORRIDOS</a:t>
+              <a:t>10. SÍNTESIS Y RECORRIDOS</a:t>
             </a:r>
             <a:endParaRPr lang="en-US" sz="600" dirty="0"/>
           </a:p>
@@ -7408,7 +7842,7 @@
                 <a:ea typeface="Arial" pitchFamily="34" charset="-122"/>
                 <a:cs typeface="Arial" pitchFamily="34" charset="-120"/>
               </a:rPr>
-              <a:t>10. ENCABEZADO, CIERRE Y FIRMAS</a:t>
+              <a:t>11. ENCABEZADO, CIERRE Y FIRMAS</a:t>
             </a:r>
             <a:endParaRPr lang="en-US" sz="600" dirty="0"/>
           </a:p>
@@ -7482,7 +7916,7 @@
                 <a:ea typeface="Arial" pitchFamily="34" charset="-122"/>
                 <a:cs typeface="Arial" pitchFamily="34" charset="-120"/>
               </a:rPr>
-              <a:t>11. FORMATO (obligatorio)</a:t>
+              <a:t>12. FORMATO (obligatorio)</a:t>
             </a:r>
             <a:endParaRPr lang="en-US" sz="600" dirty="0"/>
           </a:p>
@@ -7590,7 +8024,7 @@
                 <a:ea typeface="Arial" pitchFamily="34" charset="-122"/>
                 <a:cs typeface="Arial" pitchFamily="34" charset="-120"/>
               </a:rPr>
-              <a:t>12. ENTREGA</a:t>
+              <a:t>13. ENTREGA</a:t>
             </a:r>
             <a:endParaRPr lang="en-US" sz="600" dirty="0"/>
           </a:p>
@@ -7624,7 +8058,7 @@
                 <a:ea typeface="Arial" pitchFamily="34" charset="-122"/>
                 <a:cs typeface="Arial" pitchFamily="34" charset="-120"/>
               </a:rPr>
-              <a:t>- Si no puedes: entrega el contenido en texto, ordenado por sección y por fila de la plantilla (Encabezado; Foco 1 a 6 con sus 5 columnas; Recurrente; Bloques AM/Mediodía/PM; Brechas; Controles; Detener si), listo para copiar y pegar en cada casilla.</a:t>
+              <a:t>- Si no puedes: entrega el contenido en texto, ordenado por sección y por fila de la plantilla (Encabezado; Indicadores 14 días; Foco 1 a 6 con sus 5 columnas; Recurrente; Bloques AM/Mediodía/PM; Brechas; Controles; Detener si), listo para copiar y pegar en cada casilla.</a:t>
             </a:r>
             <a:endParaRPr lang="en-US" sz="600" dirty="0"/>
           </a:p>
@@ -7647,7 +8081,7 @@
                 <a:ea typeface="Arial" pitchFamily="34" charset="-122"/>
                 <a:cs typeface="Arial" pitchFamily="34" charset="-120"/>
               </a:rPr>
-              <a:t>13. CONTROL DE CALIDAD (en tu respuesta al usuario, no dentro del archivo)</a:t>
+              <a:t>14. CONTROL DE CALIDAD (en tu respuesta al usuario, no dentro del archivo)</a:t>
             </a:r>
             <a:endParaRPr lang="en-US" sz="600" dirty="0"/>
           </a:p>
@@ -8165,7 +8599,7 @@
                 <a:ea typeface="Arial" pitchFamily="34" charset="-122"/>
                 <a:cs typeface="Arial" pitchFamily="34" charset="-120"/>
               </a:rPr>
-              <a:t>SELECCIÓN DE FOCOS</a:t>
+              <a:t>INDICADORES 14 DÍAS</a:t>
             </a:r>
             <a:endParaRPr lang="en-US" sz="1050" dirty="0"/>
           </a:p>
@@ -8204,7 +8638,7 @@
                 <a:ea typeface="Arial" pitchFamily="34" charset="-122"/>
                 <a:cs typeface="Arial" pitchFamily="34" charset="-120"/>
               </a:rPr>
-              <a:t>Entre 4 y 6 focos, a partir de los eventos del período anterior (CAAP, HAP, CBP, HBP). Un foco = un riesgo: agrupar en un mismo foco los eventos del mismo riesgo. Priorizar los de alto potencial.</a:t>
+              <a:t>Franja bajo el encabezado: período de los datos (últimos 14 días), total de eventos y cantidad por tipo (CAAP, HAP, CBP, HBP). Comparar el total con los 14 días anteriores: ▲ subió, ▼ bajó, = igual.</a:t>
             </a:r>
             <a:endParaRPr lang="en-US" sz="930" dirty="0"/>
           </a:p>
@@ -8334,7 +8768,7 @@
                 <a:ea typeface="Arial" pitchFamily="34" charset="-122"/>
                 <a:cs typeface="Arial" pitchFamily="34" charset="-120"/>
               </a:rPr>
-              <a:t>NIVEL / PRIORIDAD</a:t>
+              <a:t>SELECCIÓN DE FOCOS</a:t>
             </a:r>
             <a:endParaRPr lang="en-US" sz="1050" dirty="0"/>
           </a:p>
@@ -8373,7 +8807,7 @@
                 <a:ea typeface="Arial" pitchFamily="34" charset="-122"/>
                 <a:cs typeface="Arial" pitchFamily="34" charset="-120"/>
               </a:rPr>
-              <a:t>N° + nivel + tipo del evento más grave del foco. N1 · CRÍTICO = celda roja; N2 · ALTO = celda naranja. Ordenar de mayor a menor. Para cambiar color: clic en la celda › Diseño de tabla › Sombreado.</a:t>
+              <a:t>Entre 4 y 6 focos, a partir de los eventos de los últimos 14 días (CAAP, HAP, CBP, HBP). Un foco = un riesgo: agrupar en un mismo foco los eventos del mismo riesgo. Priorizar los de alto potencial.</a:t>
             </a:r>
             <a:endParaRPr lang="en-US" sz="930" dirty="0"/>
           </a:p>
@@ -8503,7 +8937,7 @@
                 <a:ea typeface="Arial" pitchFamily="34" charset="-122"/>
                 <a:cs typeface="Arial" pitchFamily="34" charset="-120"/>
               </a:rPr>
-              <a:t>FOCO DE ASSURANCE</a:t>
+              <a:t>NIVEL / PRIORIDAD</a:t>
             </a:r>
             <a:endParaRPr lang="en-US" sz="1050" dirty="0"/>
           </a:p>
@@ -8542,7 +8976,7 @@
                 <a:ea typeface="Arial" pitchFamily="34" charset="-122"/>
                 <a:cs typeface="Arial" pitchFamily="34" charset="-120"/>
               </a:rPr>
-              <a:t>Tema en negrita + instrucción que parte con verbo ("Verificar…"): qué, dónde y bajo qué estándar (máx. 3 líneas). Cerrar con "Criterio de restricción": cuándo se prohíbe o se detiene la tarea (máx. 2 líneas).</a:t>
+              <a:t>N° + nivel + tipo del evento más grave del foco. N1 · CRÍTICO = celda roja; N2 · ALTO = celda naranja. Ordenar de mayor a menor. Para cambiar color: clic en la celda › Diseño de tabla › Sombreado.</a:t>
             </a:r>
             <a:endParaRPr lang="en-US" sz="930" dirty="0"/>
           </a:p>
@@ -8672,7 +9106,7 @@
                 <a:ea typeface="Arial" pitchFamily="34" charset="-122"/>
                 <a:cs typeface="Arial" pitchFamily="34" charset="-120"/>
               </a:rPr>
-              <a:t>EVENTO / EVIDENCIA ORIGEN</a:t>
+              <a:t>FOCO DE ASSURANCE</a:t>
             </a:r>
             <a:endParaRPr lang="en-US" sz="1050" dirty="0"/>
           </a:p>
@@ -8711,41 +9145,7 @@
                 <a:ea typeface="Arial" pitchFamily="34" charset="-122"/>
                 <a:cs typeface="Arial" pitchFamily="34" charset="-120"/>
               </a:rPr>
-              <a:t>Formato fijo: [Turno] TIPO ID – EECC: qué ocurrió.</a:t>
-            </a:r>
-            <a:endParaRPr lang="en-US" sz="930" dirty="0"/>
-          </a:p>
-          <a:p>
-            <a:pPr indent="0" marL="0">
-              <a:buNone/>
-            </a:pPr>
-            <a:r>
-              <a:rPr lang="en-US" sz="930" dirty="0">
-                <a:solidFill>
-                  <a:srgbClr val="222222"/>
-                </a:solidFill>
-                <a:latin typeface="Arial" pitchFamily="34" charset="0"/>
-                <a:ea typeface="Arial" pitchFamily="34" charset="-122"/>
-                <a:cs typeface="Arial" pitchFamily="34" charset="-120"/>
-              </a:rPr>
-              <a:t>Ej.: [T1-3] HAP 553767 – JEJ: camioneta con neumático dañado.</a:t>
-            </a:r>
-            <a:endParaRPr lang="en-US" sz="930" dirty="0"/>
-          </a:p>
-          <a:p>
-            <a:pPr indent="0" marL="0">
-              <a:buNone/>
-            </a:pPr>
-            <a:r>
-              <a:rPr lang="en-US" sz="930" dirty="0">
-                <a:solidFill>
-                  <a:srgbClr val="222222"/>
-                </a:solidFill>
-                <a:latin typeface="Arial" pitchFamily="34" charset="0"/>
-                <a:ea typeface="Arial" pitchFamily="34" charset="-122"/>
-                <a:cs typeface="Arial" pitchFamily="34" charset="-120"/>
-              </a:rPr>
-              <a:t>Máx. 3 eventos por foco, 1–2 líneas cada uno.</a:t>
+              <a:t>Tema en negrita + instrucción que parte con verbo ("Verificar…"): qué, dónde y bajo qué estándar (máx. 3 líneas). Cerrar con "Criterio de restricción": cuándo se prohíbe o se detiene la tarea (máx. 2 líneas).</a:t>
             </a:r>
             <a:endParaRPr lang="en-US" sz="930" dirty="0"/>
           </a:p>
@@ -8875,7 +9275,7 @@
                 <a:ea typeface="Arial" pitchFamily="34" charset="-122"/>
                 <a:cs typeface="Arial" pitchFamily="34" charset="-120"/>
               </a:rPr>
-              <a:t>HERRAMIENTA PREVENTIVA SGE</a:t>
+              <a:t>EVENTO / EVIDENCIA ORIGEN</a:t>
             </a:r>
             <a:endParaRPr lang="en-US" sz="1050" dirty="0"/>
           </a:p>
@@ -8914,7 +9314,7 @@
                 <a:ea typeface="Arial" pitchFamily="34" charset="-122"/>
                 <a:cs typeface="Arial" pitchFamily="34" charset="-120"/>
               </a:rPr>
-              <a:t>Herramienta(s) del SGE con que se verifica el foco, unidas con "+".</a:t>
+              <a:t>Formato fijo: [Turno] TIPO ID – EECC: qué ocurrió.</a:t>
             </a:r>
             <a:endParaRPr lang="en-US" sz="930" dirty="0"/>
           </a:p>
@@ -8931,7 +9331,24 @@
                 <a:ea typeface="Arial" pitchFamily="34" charset="-122"/>
                 <a:cs typeface="Arial" pitchFamily="34" charset="-120"/>
               </a:rPr>
-              <a:t>Ej.: GCC + CdP Maniobras de Izaje + ASP.</a:t>
+              <a:t>Ej.: [T1-3] HAP 553767 – JEJ: camioneta con neumático dañado.</a:t>
+            </a:r>
+            <a:endParaRPr lang="en-US" sz="930" dirty="0"/>
+          </a:p>
+          <a:p>
+            <a:pPr indent="0" marL="0">
+              <a:buNone/>
+            </a:pPr>
+            <a:r>
+              <a:rPr lang="en-US" sz="930" dirty="0">
+                <a:solidFill>
+                  <a:srgbClr val="222222"/>
+                </a:solidFill>
+                <a:latin typeface="Arial" pitchFamily="34" charset="0"/>
+                <a:ea typeface="Arial" pitchFamily="34" charset="-122"/>
+                <a:cs typeface="Arial" pitchFamily="34" charset="-120"/>
+              </a:rPr>
+              <a:t>Máx. 3 eventos por foco, 1–2 líneas cada uno.</a:t>
             </a:r>
             <a:endParaRPr lang="en-US" sz="930" dirty="0"/>
           </a:p>
@@ -9061,7 +9478,7 @@
                 <a:ea typeface="Arial" pitchFamily="34" charset="-122"/>
                 <a:cs typeface="Arial" pitchFamily="34" charset="-120"/>
               </a:rPr>
-              <a:t>EVIDENCIA / REGISTRO ESPERADO</a:t>
+              <a:t>HERRAMIENTA PREVENTIVA SGE</a:t>
             </a:r>
             <a:endParaRPr lang="en-US" sz="1050" dirty="0"/>
           </a:p>
@@ -9100,7 +9517,7 @@
                 <a:ea typeface="Arial" pitchFamily="34" charset="-122"/>
                 <a:cs typeface="Arial" pitchFamily="34" charset="-120"/>
               </a:rPr>
-              <a:t>Registro concreto y verificable que debe quedar, separado por "/". Incluir siempre registro fotográfico.</a:t>
+              <a:t>Herramienta(s) del SGE con que se verifica el foco, unidas con "+".</a:t>
             </a:r>
             <a:endParaRPr lang="en-US" sz="930" dirty="0"/>
           </a:p>
@@ -9117,7 +9534,7 @@
                 <a:ea typeface="Arial" pitchFamily="34" charset="-122"/>
                 <a:cs typeface="Arial" pitchFamily="34" charset="-120"/>
               </a:rPr>
-              <a:t>Ej.: Área segregada / radio operativa / registro fotográfico.</a:t>
+              <a:t>Ej.: GCC + CdP Maniobras de Izaje + ASP.</a:t>
             </a:r>
             <a:endParaRPr lang="en-US" sz="930" dirty="0"/>
           </a:p>
@@ -9247,7 +9664,7 @@
                 <a:ea typeface="Arial" pitchFamily="34" charset="-122"/>
                 <a:cs typeface="Arial" pitchFamily="34" charset="-120"/>
               </a:rPr>
-              <a:t>RECURRENTE</a:t>
+              <a:t>EVIDENCIA / REGISTRO ESPERADO</a:t>
             </a:r>
             <a:endParaRPr lang="en-US" sz="1050" dirty="0"/>
           </a:p>
@@ -9286,7 +9703,7 @@
                 <a:ea typeface="Arial" pitchFamily="34" charset="-122"/>
                 <a:cs typeface="Arial" pitchFamily="34" charset="-120"/>
               </a:rPr>
-              <a:t>Total de eventos HBP del período y los temas más repetidos con su cantidad.</a:t>
+              <a:t>Registro concreto y verificable que debe quedar, separado por "/". Incluir siempre registro fotográfico.</a:t>
             </a:r>
             <a:endParaRPr lang="en-US" sz="930" dirty="0"/>
           </a:p>
@@ -9303,7 +9720,7 @@
                 <a:ea typeface="Arial" pitchFamily="34" charset="-122"/>
                 <a:cs typeface="Arial" pitchFamily="34" charset="-120"/>
               </a:rPr>
-              <a:t>Ej.: 7 eventos HBP — acopio deficiente (4) · extensiones sin pasacable (3).</a:t>
+              <a:t>Ej.: Área segregada / radio operativa / registro fotográfico.</a:t>
             </a:r>
             <a:endParaRPr lang="en-US" sz="930" dirty="0"/>
           </a:p>
@@ -9433,7 +9850,7 @@
                 <a:ea typeface="Arial" pitchFamily="34" charset="-122"/>
                 <a:cs typeface="Arial" pitchFamily="34" charset="-120"/>
               </a:rPr>
-              <a:t>RECORRIDOS AM · MEDIODÍA · PM</a:t>
+              <a:t>RECURRENTE</a:t>
             </a:r>
             <a:endParaRPr lang="en-US" sz="1050" dirty="0"/>
           </a:p>
@@ -9472,7 +9889,24 @@
                 <a:ea typeface="Arial" pitchFamily="34" charset="-122"/>
                 <a:cs typeface="Arial" pitchFamily="34" charset="-120"/>
               </a:rPr>
-              <a:t>Por bloque: áreas a recorrer y 3–4 controles con el N° de foco entre paréntesis. El bloque PM se reserva para gestión SAP, CdP pendientes, actualización de PTS y entrega de turno.</a:t>
+              <a:t>Total de eventos HBP del período y los temas más repetidos con su cantidad.</a:t>
+            </a:r>
+            <a:endParaRPr lang="en-US" sz="930" dirty="0"/>
+          </a:p>
+          <a:p>
+            <a:pPr indent="0" marL="0">
+              <a:buNone/>
+            </a:pPr>
+            <a:r>
+              <a:rPr lang="en-US" sz="930" dirty="0">
+                <a:solidFill>
+                  <a:srgbClr val="222222"/>
+                </a:solidFill>
+                <a:latin typeface="Arial" pitchFamily="34" charset="0"/>
+                <a:ea typeface="Arial" pitchFamily="34" charset="-122"/>
+                <a:cs typeface="Arial" pitchFamily="34" charset="-120"/>
+              </a:rPr>
+              <a:t>Ej.: 7 eventos HBP — acopio deficiente (4) · extensiones sin pasacable (3).</a:t>
             </a:r>
             <a:endParaRPr lang="en-US" sz="930" dirty="0"/>
           </a:p>
@@ -9487,7 +9921,7 @@
         <p:spPr>
           <a:xfrm>
             <a:off x="365760" y="5413248"/>
-            <a:ext cx="5676138" cy="1298448"/>
+            <a:ext cx="3749040" cy="1298448"/>
           </a:xfrm>
           <a:prstGeom prst="roundRect">
             <a:avLst>
@@ -9578,7 +10012,7 @@
         <p:spPr>
           <a:xfrm>
             <a:off x="932688" y="5532120"/>
-            <a:ext cx="4990338" cy="329184"/>
+            <a:ext cx="3063240" cy="329184"/>
           </a:xfrm>
           <a:prstGeom prst="rect">
             <a:avLst/>
@@ -9602,7 +10036,7 @@
                 <a:ea typeface="Arial" pitchFamily="34" charset="-122"/>
                 <a:cs typeface="Arial" pitchFamily="34" charset="-120"/>
               </a:rPr>
-              <a:t>BRECHAS · CONTROLES · DETENER SI</a:t>
+              <a:t>RECORRIDOS AM · MEDIODÍA · PM</a:t>
             </a:r>
             <a:endParaRPr lang="en-US" sz="1050" dirty="0"/>
           </a:p>
@@ -9617,7 +10051,7 @@
         <p:spPr>
           <a:xfrm>
             <a:off x="530352" y="5943600"/>
-            <a:ext cx="5374386" cy="713232"/>
+            <a:ext cx="3447288" cy="713232"/>
           </a:xfrm>
           <a:prstGeom prst="rect">
             <a:avLst/>
@@ -9641,7 +10075,7 @@
                 <a:ea typeface="Arial" pitchFamily="34" charset="-122"/>
                 <a:cs typeface="Arial" pitchFamily="34" charset="-120"/>
               </a:rPr>
-              <a:t>Máx. 5 viñetas de 1 línea por recuadro. Brechas = lo que falló. Controles = lo que no se negocia. Detener si = condición concreta de detención.</a:t>
+              <a:t>Por bloque: áreas a recorrer y 3–4 controles con el N° de foco entre paréntesis. El bloque PM se reserva para gestión SAP, CdP pendientes, actualización de PTS y entrega de turno.</a:t>
             </a:r>
             <a:endParaRPr lang="en-US" sz="930" dirty="0"/>
           </a:p>
@@ -9655,8 +10089,8 @@
         </p:nvSpPr>
         <p:spPr>
           <a:xfrm>
-            <a:off x="6147054" y="5413248"/>
-            <a:ext cx="5676138" cy="1298448"/>
+            <a:off x="4219956" y="5413248"/>
+            <a:ext cx="3749040" cy="1298448"/>
           </a:xfrm>
           <a:prstGeom prst="roundRect">
             <a:avLst>
@@ -9682,7 +10116,7 @@
         </p:nvSpPr>
         <p:spPr>
           <a:xfrm>
-            <a:off x="6284214" y="5532120"/>
+            <a:off x="4357116" y="5532120"/>
             <a:ext cx="329184" cy="329184"/>
           </a:xfrm>
           <a:prstGeom prst="ellipse">
@@ -9707,7 +10141,7 @@
         </p:nvSpPr>
         <p:spPr>
           <a:xfrm>
-            <a:off x="6284214" y="5532120"/>
+            <a:off x="4357116" y="5532120"/>
             <a:ext cx="329184" cy="329184"/>
           </a:xfrm>
           <a:prstGeom prst="rect">
@@ -9746,8 +10180,8 @@
         </p:nvSpPr>
         <p:spPr>
           <a:xfrm>
-            <a:off x="6713982" y="5532120"/>
-            <a:ext cx="4990338" cy="329184"/>
+            <a:off x="4786884" y="5532120"/>
+            <a:ext cx="3063240" cy="329184"/>
           </a:xfrm>
           <a:prstGeom prst="rect">
             <a:avLst/>
@@ -9771,7 +10205,7 @@
                 <a:ea typeface="Arial" pitchFamily="34" charset="-122"/>
                 <a:cs typeface="Arial" pitchFamily="34" charset="-120"/>
               </a:rPr>
-              <a:t>CIERRE Y FIRMAS</a:t>
+              <a:t>BRECHAS · CONTROLES · DETENER SI</a:t>
             </a:r>
             <a:endParaRPr lang="en-US" sz="1050" dirty="0"/>
           </a:p>
@@ -9785,8 +10219,8 @@
         </p:nvSpPr>
         <p:spPr>
           <a:xfrm>
-            <a:off x="6311646" y="5943600"/>
-            <a:ext cx="5374386" cy="713232"/>
+            <a:off x="4384548" y="5943600"/>
+            <a:ext cx="3447288" cy="713232"/>
           </a:xfrm>
           <a:prstGeom prst="rect">
             <a:avLst/>
@@ -9810,6 +10244,175 @@
                 <a:ea typeface="Arial" pitchFamily="34" charset="-122"/>
                 <a:cs typeface="Arial" pitchFamily="34" charset="-120"/>
               </a:rPr>
+              <a:t>Máx. 5 viñetas de 1 línea por recuadro. Brechas = lo que falló. Controles = lo que no se negocia. Detener si = condición concreta de detención.</a:t>
+            </a:r>
+            <a:endParaRPr lang="en-US" sz="930" dirty="0"/>
+          </a:p>
+        </p:txBody>
+      </p:sp>
+      <p:sp>
+        <p:nvSpPr>
+          <p:cNvPr id="60" name="Shape 57"/>
+          <p:cNvSpPr/>
+          <p:nvPr/>
+        </p:nvSpPr>
+        <p:spPr>
+          <a:xfrm>
+            <a:off x="8074152" y="5413248"/>
+            <a:ext cx="3749040" cy="1298448"/>
+          </a:xfrm>
+          <a:prstGeom prst="roundRect">
+            <a:avLst>
+              <a:gd name="adj" fmla="val 4225"/>
+            </a:avLst>
+          </a:prstGeom>
+          <a:solidFill>
+            <a:srgbClr val="F3F6FA"/>
+          </a:solidFill>
+          <a:ln w="9525">
+            <a:solidFill>
+              <a:srgbClr val="C9D3E0"/>
+            </a:solidFill>
+            <a:prstDash val="solid"/>
+          </a:ln>
+        </p:spPr>
+      </p:sp>
+      <p:sp>
+        <p:nvSpPr>
+          <p:cNvPr id="61" name="Shape 58"/>
+          <p:cNvSpPr/>
+          <p:nvPr/>
+        </p:nvSpPr>
+        <p:spPr>
+          <a:xfrm>
+            <a:off x="8211312" y="5532120"/>
+            <a:ext cx="329184" cy="329184"/>
+          </a:xfrm>
+          <a:prstGeom prst="ellipse">
+            <a:avLst/>
+          </a:prstGeom>
+          <a:solidFill>
+            <a:srgbClr val="1F3D6B"/>
+          </a:solidFill>
+          <a:ln w="12700">
+            <a:solidFill>
+              <a:srgbClr val="1F3D6B"/>
+            </a:solidFill>
+            <a:prstDash val="solid"/>
+          </a:ln>
+        </p:spPr>
+      </p:sp>
+      <p:sp>
+        <p:nvSpPr>
+          <p:cNvPr id="62" name="Text 59"/>
+          <p:cNvSpPr txBox="1"/>
+          <p:nvPr/>
+        </p:nvSpPr>
+        <p:spPr>
+          <a:xfrm>
+            <a:off x="8211312" y="5532120"/>
+            <a:ext cx="329184" cy="329184"/>
+          </a:xfrm>
+          <a:prstGeom prst="rect">
+            <a:avLst/>
+          </a:prstGeom>
+          <a:noFill/>
+          <a:ln/>
+        </p:spPr>
+        <p:txBody>
+          <a:bodyPr wrap="square" lIns="0" tIns="0" rIns="0" bIns="0" rtlCol="0" anchor="ctr"/>
+          <a:lstStyle/>
+          <a:p>
+            <a:pPr algn="ctr" indent="0" marL="0">
+              <a:buNone/>
+            </a:pPr>
+            <a:r>
+              <a:rPr lang="en-US" sz="1100" b="1" dirty="0">
+                <a:solidFill>
+                  <a:srgbClr val="FFFFFF"/>
+                </a:solidFill>
+                <a:latin typeface="Arial" pitchFamily="34" charset="0"/>
+                <a:ea typeface="Arial" pitchFamily="34" charset="-122"/>
+                <a:cs typeface="Arial" pitchFamily="34" charset="-120"/>
+              </a:rPr>
+              <a:t>12</a:t>
+            </a:r>
+            <a:endParaRPr lang="en-US" sz="1100" dirty="0"/>
+          </a:p>
+        </p:txBody>
+      </p:sp>
+      <p:sp>
+        <p:nvSpPr>
+          <p:cNvPr id="63" name="Text 60"/>
+          <p:cNvSpPr txBox="1"/>
+          <p:nvPr/>
+        </p:nvSpPr>
+        <p:spPr>
+          <a:xfrm>
+            <a:off x="8641080" y="5532120"/>
+            <a:ext cx="3063240" cy="329184"/>
+          </a:xfrm>
+          <a:prstGeom prst="rect">
+            <a:avLst/>
+          </a:prstGeom>
+          <a:noFill/>
+          <a:ln/>
+        </p:spPr>
+        <p:txBody>
+          <a:bodyPr wrap="square" lIns="0" tIns="0" rIns="0" bIns="0" rtlCol="0" anchor="ctr"/>
+          <a:lstStyle/>
+          <a:p>
+            <a:pPr indent="0" marL="0">
+              <a:buNone/>
+            </a:pPr>
+            <a:r>
+              <a:rPr lang="en-US" sz="1050" b="1" dirty="0">
+                <a:solidFill>
+                  <a:srgbClr val="1F3D6B"/>
+                </a:solidFill>
+                <a:latin typeface="Arial" pitchFamily="34" charset="0"/>
+                <a:ea typeface="Arial" pitchFamily="34" charset="-122"/>
+                <a:cs typeface="Arial" pitchFamily="34" charset="-120"/>
+              </a:rPr>
+              <a:t>CIERRE Y FIRMAS</a:t>
+            </a:r>
+            <a:endParaRPr lang="en-US" sz="1050" dirty="0"/>
+          </a:p>
+        </p:txBody>
+      </p:sp>
+      <p:sp>
+        <p:nvSpPr>
+          <p:cNvPr id="64" name="Text 61"/>
+          <p:cNvSpPr txBox="1"/>
+          <p:nvPr/>
+        </p:nvSpPr>
+        <p:spPr>
+          <a:xfrm>
+            <a:off x="8238744" y="5943600"/>
+            <a:ext cx="3447288" cy="713232"/>
+          </a:xfrm>
+          <a:prstGeom prst="rect">
+            <a:avLst/>
+          </a:prstGeom>
+          <a:noFill/>
+          <a:ln/>
+        </p:spPr>
+        <p:txBody>
+          <a:bodyPr wrap="square" lIns="0" tIns="0" rIns="0" bIns="0" rtlCol="0" anchor="t"/>
+          <a:lstStyle/>
+          <a:p>
+            <a:pPr indent="0" marL="0">
+              <a:buNone/>
+            </a:pPr>
+            <a:r>
+              <a:rPr lang="en-US" sz="930" dirty="0">
+                <a:solidFill>
+                  <a:srgbClr val="222222"/>
+                </a:solidFill>
+                <a:latin typeface="Arial" pitchFamily="34" charset="0"/>
+                <a:ea typeface="Arial" pitchFamily="34" charset="-122"/>
+                <a:cs typeface="Arial" pitchFamily="34" charset="-120"/>
+              </a:rPr>
               <a:t>Lo completa el Inspector ITO al terminar el turno: focos verificados, tareas detenidas y hallazgos subidos a SAP. Firman ITO y Supervisor EECC.</a:t>
             </a:r>
             <a:endParaRPr lang="en-US" sz="930" dirty="0"/>
@@ -9818,7 +10421,7 @@
       </p:sp>
       <p:sp>
         <p:nvSpPr>
-          <p:cNvPr id="60" name="Shape 57"/>
+          <p:cNvPr id="65" name="Shape 62"/>
           <p:cNvSpPr/>
           <p:nvPr/>
         </p:nvSpPr>
@@ -9845,7 +10448,7 @@
       </p:sp>
       <p:sp>
         <p:nvSpPr>
-          <p:cNvPr id="61" name="Text 58"/>
+          <p:cNvPr id="66" name="Text 63"/>
           <p:cNvSpPr txBox="1"/>
           <p:nvPr/>
         </p:nvSpPr>
@@ -9884,7 +10487,7 @@
       </p:sp>
       <p:sp>
         <p:nvSpPr>
-          <p:cNvPr id="62" name="Text 59"/>
+          <p:cNvPr id="67" name="Text 64"/>
           <p:cNvSpPr txBox="1"/>
           <p:nvPr/>
         </p:nvSpPr>
@@ -10011,7 +10614,7 @@
       </p:sp>
       <p:sp>
         <p:nvSpPr>
-          <p:cNvPr id="63" name="Shape 60"/>
+          <p:cNvPr id="68" name="Shape 65"/>
           <p:cNvSpPr/>
           <p:nvPr/>
         </p:nvSpPr>
@@ -10036,7 +10639,7 @@
       </p:sp>
       <p:sp>
         <p:nvSpPr>
-          <p:cNvPr id="64" name="Text 61"/>
+          <p:cNvPr id="69" name="Text 66"/>
           <p:cNvSpPr txBox="1"/>
           <p:nvPr/>
         </p:nvSpPr>
@@ -10075,7 +10678,7 @@
       </p:sp>
       <p:sp>
         <p:nvSpPr>
-          <p:cNvPr id="65" name="Text 62"/>
+          <p:cNvPr id="70" name="Text 67"/>
           <p:cNvSpPr txBox="1"/>
           <p:nvPr/>
         </p:nvSpPr>
@@ -10128,7 +10731,7 @@
       </p:sp>
       <p:sp>
         <p:nvSpPr>
-          <p:cNvPr id="66" name="Text 63"/>
+          <p:cNvPr id="71" name="Text 68"/>
           <p:cNvSpPr txBox="1"/>
           <p:nvPr/>
         </p:nvSpPr>

</xml_diff>

<commit_message>
Formato Assurance ITO: ejemplo explícito de ventanas de 14 días
Co-Authored-By: Claude Opus 5.5 <noreply@anthropic.com>
Claude-Session: https://claude.ai/code/session_017MaLNPnWzNhW9Tdfmjv67V
</commit_message>
<xml_diff>
--- a/FORMATO_ASSURANCE_ITO_v1.0.pptx
+++ b/FORMATO_ASSURANCE_ITO_v1.0.pptx
@@ -7227,7 +7227,7 @@
                 <a:ea typeface="Arial" pitchFamily="34" charset="-122"/>
                 <a:cs typeface="Arial" pitchFamily="34" charset="-120"/>
               </a:rPr>
-              <a:t>- Período: los 14 días que terminan en la fecha de corte indicada por el usuario (fecha de corte y los 13 días previos), según la columna de fecha del evento (en el Excel de eventos: "Fecha Evento", hoja "Export"). Escríbelo como "del DD al DD MES".</a:t>
+              <a:t>- Período: los 14 días que terminan en la fecha de corte indicada por el usuario (fecha de corte y los 13 días previos), según la columna de fecha del evento (en el Excel de eventos: "Fecha Evento", hoja "Export"). Escríbelo como "del DD al DD MES". Ej.: fecha de corte 23 SEP → período del 10 al 23 SEP (14 días, incluido el día de corte).</a:t>
             </a:r>
             <a:endParaRPr lang="en-US" sz="600" dirty="0"/>
           </a:p>
@@ -7261,7 +7261,7 @@
                 <a:ea typeface="Arial" pitchFamily="34" charset="-122"/>
                 <a:cs typeface="Arial" pitchFamily="34" charset="-120"/>
               </a:rPr>
-              <a:t>- vs. 14 días anteriores: total de eventos de los 14 días inmediatamente previos al período, seguido de ▲ si el total actual es mayor, ▼ si es menor o = si es igual. Ej.: "19 ▲". Si el Excel no cubre ese período, escribe [DATO FALTANTE].</a:t>
+              <a:t>- vs. 14 días anteriores: total de eventos de los 14 días inmediatamente previos al período, sin superponerse con él (en el ejemplo: del 27 AGO al 09 SEP), seguido de ▲ si el total actual es mayor, ▼ si es menor o = si es igual. Ej.: "19 ▲". Si el Excel no cubre ese período, escribe [DATO FALTANTE].</a:t>
             </a:r>
             <a:endParaRPr lang="en-US" sz="600" dirty="0"/>
           </a:p>
@@ -8638,7 +8638,24 @@
                 <a:ea typeface="Arial" pitchFamily="34" charset="-122"/>
                 <a:cs typeface="Arial" pitchFamily="34" charset="-120"/>
               </a:rPr>
-              <a:t>Franja bajo el encabezado: período de los datos (últimos 14 días), total de eventos y cantidad por tipo (CAAP, HAP, CBP, HBP). Comparar el total con los 14 días anteriores: ▲ subió, ▼ bajó, = igual.</a:t>
+              <a:t>Total de eventos y cantidad por tipo en los 14 días al cierre, comparado con los 14 días previos (▲ subió, ▼ bajó, = igual).</a:t>
+            </a:r>
+            <a:endParaRPr lang="en-US" sz="930" dirty="0"/>
+          </a:p>
+          <a:p>
+            <a:pPr indent="0" marL="0">
+              <a:buNone/>
+            </a:pPr>
+            <a:r>
+              <a:rPr lang="en-US" sz="930" dirty="0">
+                <a:solidFill>
+                  <a:srgbClr val="222222"/>
+                </a:solidFill>
+                <a:latin typeface="Arial" pitchFamily="34" charset="0"/>
+                <a:ea typeface="Arial" pitchFamily="34" charset="-122"/>
+                <a:cs typeface="Arial" pitchFamily="34" charset="-120"/>
+              </a:rPr>
+              <a:t>Ej.: cierre 23 SEP → actual 10–23 SEP vs. anterior 27 AGO–09 SEP.</a:t>
             </a:r>
             <a:endParaRPr lang="en-US" sz="930" dirty="0"/>
           </a:p>

</xml_diff>